<commit_message>
Fix module presentation layout collisions
</commit_message>
<xml_diff>
--- a/blocks/A_ros2_basics/M01_ros2_concepts/M01_ROS2_기초와_분산_로봇_소프트웨어.pptx
+++ b/blocks/A_ros2_basics/M01_ros2_concepts/M01_ROS2_기초와_분산_로봇_소프트웨어.pptx
@@ -7789,7 +7789,7 @@
         </p:nvSpPr>
         <p:spPr>
           <a:xfrm>
-            <a:off x="914400" y="1810512"/>
+            <a:off x="914400" y="1773936"/>
             <a:ext cx="3840480" cy="256032"/>
           </a:xfrm>
           <a:prstGeom prst="rect">
@@ -7828,8 +7828,8 @@
         </p:nvSpPr>
         <p:spPr>
           <a:xfrm>
-            <a:off x="914400" y="2121408"/>
-            <a:ext cx="9966960" cy="256032"/>
+            <a:off x="914400" y="2048255"/>
+            <a:ext cx="9966960" cy="475488"/>
           </a:xfrm>
           <a:prstGeom prst="rect">
             <a:avLst/>
@@ -7846,7 +7846,7 @@
               <a:spcAft>
                 <a:spcPts val="0"/>
               </a:spcAft>
-              <a:defRPr sz="1200" b="0">
+              <a:defRPr sz="1000" b="0">
                 <a:solidFill>
                   <a:srgbClr val="225B9B"/>
                 </a:solidFill>
@@ -7867,7 +7867,7 @@
         </p:nvSpPr>
         <p:spPr>
           <a:xfrm>
-            <a:off x="914400" y="2816352"/>
+            <a:off x="914400" y="2852928"/>
             <a:ext cx="3840480" cy="256032"/>
           </a:xfrm>
           <a:prstGeom prst="rect">
@@ -7907,7 +7907,7 @@
         <p:spPr>
           <a:xfrm>
             <a:off x="914400" y="3127248"/>
-            <a:ext cx="9966960" cy="256032"/>
+            <a:ext cx="9966960" cy="475488"/>
           </a:xfrm>
           <a:prstGeom prst="rect">
             <a:avLst/>
@@ -7924,7 +7924,7 @@
               <a:spcAft>
                 <a:spcPts val="0"/>
               </a:spcAft>
-              <a:defRPr sz="1200" b="0">
+              <a:defRPr sz="1000" b="0">
                 <a:solidFill>
                   <a:srgbClr val="225B9B"/>
                 </a:solidFill>
@@ -7945,7 +7945,7 @@
         </p:nvSpPr>
         <p:spPr>
           <a:xfrm>
-            <a:off x="914400" y="3822191"/>
+            <a:off x="914400" y="3931920"/>
             <a:ext cx="3840480" cy="256032"/>
           </a:xfrm>
           <a:prstGeom prst="rect">
@@ -7984,8 +7984,8 @@
         </p:nvSpPr>
         <p:spPr>
           <a:xfrm>
-            <a:off x="914400" y="4133087"/>
-            <a:ext cx="9966960" cy="256032"/>
+            <a:off x="914400" y="4206240"/>
+            <a:ext cx="9966960" cy="475488"/>
           </a:xfrm>
           <a:prstGeom prst="rect">
             <a:avLst/>
@@ -8002,7 +8002,7 @@
               <a:spcAft>
                 <a:spcPts val="0"/>
               </a:spcAft>
-              <a:defRPr sz="1200" b="0">
+              <a:defRPr sz="1000" b="0">
                 <a:solidFill>
                   <a:srgbClr val="225B9B"/>
                 </a:solidFill>
@@ -8023,7 +8023,7 @@
         </p:nvSpPr>
         <p:spPr>
           <a:xfrm>
-            <a:off x="914400" y="4828032"/>
+            <a:off x="914400" y="5010912"/>
             <a:ext cx="3840480" cy="256032"/>
           </a:xfrm>
           <a:prstGeom prst="rect">
@@ -8062,8 +8062,8 @@
         </p:nvSpPr>
         <p:spPr>
           <a:xfrm>
-            <a:off x="914400" y="5138928"/>
-            <a:ext cx="9966960" cy="256032"/>
+            <a:off x="914400" y="5285232"/>
+            <a:ext cx="9966960" cy="475488"/>
           </a:xfrm>
           <a:prstGeom prst="rect">
             <a:avLst/>
@@ -8080,7 +8080,7 @@
               <a:spcAft>
                 <a:spcPts val="0"/>
               </a:spcAft>
-              <a:defRPr sz="1200" b="0">
+              <a:defRPr sz="1000" b="0">
                 <a:solidFill>
                   <a:srgbClr val="225B9B"/>
                 </a:solidFill>

</xml_diff>

<commit_message>
Strengthen curriculum stages and block teaching decks
</commit_message>
<xml_diff>
--- a/blocks/A_ros2_basics/M01_ros2_concepts/M01_ROS2_기초와_분산_로봇_소프트웨어.pptx
+++ b/blocks/A_ros2_basics/M01_ros2_concepts/M01_ROS2_기초와_분산_로봇_소프트웨어.pptx
@@ -1352,7 +1352,7 @@
           </a:p>
           <a:p>
             <a:r>
-              <a:t>[실행] pwd; source /opt/ros/jazzy/setup.bash; source ~/agv_ws/install/setup.bash</a:t>
+              <a:t>[실행] pwd; source /opt/ros/jazzy/setup.bash; source ~/ros2_curri/agv_ws/install/setup.bash</a:t>
             </a:r>
           </a:p>
           <a:p>
@@ -5496,7 +5496,7 @@
               </a:defRPr>
             </a:pPr>
             <a:r>
-              <a:t>현재 단계 실행    |    현재 폴더 ~/agv_ws    |    현재 터미널</a:t>
+              <a:t>현재 단계 실행    |    현재 폴더 ~/ros2_curri/agv_ws    |    현재 터미널</a:t>
             </a:r>
           </a:p>
         </p:txBody>
@@ -6109,7 +6109,7 @@
               </a:defRPr>
             </a:pPr>
             <a:r>
-              <a:t>현재 단계 검증    |    현재 폴더 ~/agv_ws    |    현재 터미널</a:t>
+              <a:t>현재 단계 검증    |    현재 폴더 ~/ros2_curri/agv_ws    |    현재 터미널</a:t>
             </a:r>
           </a:p>
         </p:txBody>
@@ -6516,7 +6516,7 @@
               </a:defRPr>
             </a:pPr>
             <a:r>
-              <a:t>현재 단계 오류 대응    |    현재 폴더 ~/agv_ws    |    현재 터미널</a:t>
+              <a:t>현재 단계 오류 대응    |    현재 폴더 ~/ros2_curri/agv_ws    |    현재 터미널</a:t>
             </a:r>
           </a:p>
         </p:txBody>
@@ -7041,7 +7041,7 @@
               </a:defRPr>
             </a:pPr>
             <a:r>
-              <a:t>현재 단계 미니 실습    |    현재 폴더 ~/agv_ws    |    현재 터미널</a:t>
+              <a:t>현재 단계 미니 실습    |    현재 폴더 ~/ros2_curri/agv_ws    |    현재 터미널</a:t>
             </a:r>
           </a:p>
         </p:txBody>
@@ -7370,7 +7370,7 @@
               </a:defRPr>
             </a:pPr>
             <a:r>
-              <a:t>현재 단계 체크포인트    |    현재 폴더 ~/agv_ws    |    현재 터미널</a:t>
+              <a:t>현재 단계 체크포인트    |    현재 폴더 ~/ros2_curri/agv_ws    |    현재 터미널</a:t>
             </a:r>
           </a:p>
         </p:txBody>
@@ -8781,7 +8781,7 @@
               </a:defRPr>
             </a:pPr>
             <a:r>
-              <a:t>현재 단계 시작    |    현재 폴더 ~/agv_ws    |    현재 터미널</a:t>
+              <a:t>현재 단계 시작    |    현재 폴더 ~/ros2_curri/agv_ws    |    현재 터미널</a:t>
             </a:r>
           </a:p>
         </p:txBody>
@@ -8897,7 +8897,7 @@
               </a:defRPr>
             </a:pPr>
             <a:r>
-              <a:t>• 현재 폴더: ~/agv_ws</a:t>
+              <a:t>• 현재 폴더: ~/ros2_curri/agv_ws</a:t>
             </a:r>
           </a:p>
           <a:p>
@@ -8968,7 +8968,7 @@
               </a:defRPr>
             </a:pPr>
             <a:r>
-              <a:t>확인: pwd가 ~/agv_ws이고, 이전 모듈의 완료 조건을 한 문장으로 설명할 수 있으면 시작합니다.</a:t>
+              <a:t>확인: pwd가 ~/ros2_curri/agv_ws이고, 이전 모듈의 완료 조건을 한 문장으로 설명할 수 있으면 시작합니다.</a:t>
             </a:r>
           </a:p>
         </p:txBody>
@@ -10002,7 +10002,7 @@
               </a:defRPr>
             </a:pPr>
             <a:r>
-              <a:t>~/agv_ws/src/</a:t>
+              <a:t>~/ros2_curri/agv_ws/src/</a:t>
             </a:r>
             <a:br/>
             <a:r>
@@ -10277,7 +10277,7 @@
               </a:defRPr>
             </a:pPr>
             <a:r>
-              <a:t>현재 단계 1/3    |    현재 폴더 ~/agv_ws    |    현재 터미널</a:t>
+              <a:t>현재 단계 1/3    |    현재 폴더 ~/ros2_curri/agv_ws    |    현재 터미널</a:t>
             </a:r>
           </a:p>
         </p:txBody>
@@ -10727,7 +10727,7 @@
               </a:defRPr>
             </a:pPr>
             <a:r>
-              <a:t>현재 단계 2/3    |    현재 폴더 ~/agv_ws    |    새 터미널</a:t>
+              <a:t>현재 단계 2/3    |    현재 폴더 ~/ros2_curri/agv_ws    |    새 터미널</a:t>
             </a:r>
           </a:p>
         </p:txBody>
@@ -11190,7 +11190,7 @@
               </a:defRPr>
             </a:pPr>
             <a:r>
-              <a:t>현재 단계 3/3    |    현재 폴더 ~/agv_ws    |    현재 터미널</a:t>
+              <a:t>현재 단계 3/3    |    현재 폴더 ~/ros2_curri/agv_ws    |    현재 터미널</a:t>
             </a:r>
           </a:p>
         </p:txBody>

</xml_diff>

<commit_message>
Add annotated modeling and sensor teaching evidence
</commit_message>
<xml_diff>
--- a/blocks/A_ros2_basics/M01_ros2_concepts/M01_ROS2_기초와_분산_로봇_소프트웨어.pptx
+++ b/blocks/A_ros2_basics/M01_ros2_concepts/M01_ROS2_기초와_분산_로봇_소프트웨어.pptx
@@ -717,7 +717,7 @@
           </a:p>
           <a:p>
             <a:r>
-              <a:t>[확인] 캡처의 명령과 다음 슬라이드의 검증 명령을 비교한다.</a:t>
+              <a:t>[확인] ① 명령/설정  ② 정상 출력 또는 화면  ③ 다음 검증 명령으로 재확인</a:t>
             </a:r>
           </a:p>
           <a:p>
@@ -5851,8 +5851,8 @@
         </p:nvSpPr>
         <p:spPr>
           <a:xfrm>
-            <a:off x="777240" y="6217920"/>
-            <a:ext cx="10607040" cy="182880"/>
+            <a:off x="777240" y="6144768"/>
+            <a:ext cx="10607040" cy="310896"/>
           </a:xfrm>
           <a:prstGeom prst="rect">
             <a:avLst/>
@@ -5877,7 +5877,7 @@
               </a:defRPr>
             </a:pPr>
             <a:r>
-              <a:t>① 명령/설정  ② 정상 출력 또는 화면  ③ 다음 검증 명령으로 재확인</a:t>
+              <a:t>화면에서 확인: ① 명령/설정  ② 정상 출력 또는 화면  ③ 다음 검증 명령으로 재확인</a:t>
             </a:r>
           </a:p>
         </p:txBody>

</xml_diff>

<commit_message>
Rework decks into project-building workshops
</commit_message>
<xml_diff>
--- a/blocks/A_ros2_basics/M01_ros2_concepts/M01_ROS2_기초와_분산_로봇_소프트웨어.pptx
+++ b/blocks/A_ros2_basics/M01_ros2_concepts/M01_ROS2_기초와_분산_로봇_소프트웨어.pptx
@@ -21,6 +21,7 @@
     <p:sldId id="269" r:id="rId21"/>
     <p:sldId id="270" r:id="rId22"/>
     <p:sldId id="271" r:id="rId23"/>
+    <p:sldId id="272" r:id="rId24"/>
   </p:sldIdLst>
   <p:sldSz cx="12191999" cy="6858000" type="screen4x3"/>
   <p:notesSz cx="6858000" cy="9144000"/>
@@ -607,27 +608,32 @@
           <a:lstStyle/>
           <a:p>
             <a:r>
-              <a:t>[설명] build/source/run을 생략 없이 실행한다.</a:t>
-            </a:r>
-          </a:p>
-          <a:p>
-            <a:r>
-              <a:t>[실행] source /opt/ros/jazzy/setup.bash</a:t>
-            </a:r>
-          </a:p>
-          <a:p>
-            <a:r>
-              <a:t>ros2 run demo_nodes_cpp talker</a:t>
-            </a:r>
-          </a:p>
-          <a:p>
-            <a:r>
-              <a:t># 새 터미널: ros2 run demo_nodes_py listener</a:t>
-            </a:r>
-          </a:p>
-          <a:p>
-            <a:r>
-              <a:t>[확인] talker/listener와 node·topic·echo·info 명령으로 연결을 확인한다.</a:t>
+              <a:t>[설명] 코드 밖에서도 이름·타입·연결 수를 확인할 수 있다.</a:t>
+            </a:r>
+          </a:p>
+          <a:p>
+            <a:r>
+              <a:t>[실행] ros2 node list</a:t>
+            </a:r>
+          </a:p>
+          <a:p>
+            <a:r>
+              <a:t>ros2 topic list</a:t>
+            </a:r>
+          </a:p>
+          <a:p>
+            <a:r>
+              <a:t>ros2 topic info /chatter</a:t>
+            </a:r>
+          </a:p>
+          <a:p>
+            <a:r>
+              <a:t>ros2 topic echo /chatter --once</a:t>
+            </a:r>
+          </a:p>
+          <a:p>
+            <a:r>
+              <a:t>[확인] 명령 출력에서 슬라이드의 확인 항목을 찾는다.</a:t>
             </a:r>
           </a:p>
           <a:p>
@@ -707,17 +713,27 @@
           <a:lstStyle/>
           <a:p>
             <a:r>
-              <a:t>[설명] 실제 Ubuntu/ROS 2 환경에서 생성한 검증 화면이다.</a:t>
-            </a:r>
-          </a:p>
-          <a:p>
-            <a:r>
-              <a:t>[실행] 슬라이드의 명령 또는 파일 작성 단계를 진행한다.</a:t>
-            </a:r>
-          </a:p>
-          <a:p>
-            <a:r>
-              <a:t>[확인] ① 명령/설정  ② 정상 출력 또는 화면  ③ 다음 검증 명령으로 재확인</a:t>
+              <a:t>[설명] build/source/run을 생략 없이 실행한다.</a:t>
+            </a:r>
+          </a:p>
+          <a:p>
+            <a:r>
+              <a:t>[실행] source /opt/ros/jazzy/setup.bash</a:t>
+            </a:r>
+          </a:p>
+          <a:p>
+            <a:r>
+              <a:t>ros2 run demo_nodes_cpp talker</a:t>
+            </a:r>
+          </a:p>
+          <a:p>
+            <a:r>
+              <a:t># 새 터미널: ros2 run demo_nodes_py listener</a:t>
+            </a:r>
+          </a:p>
+          <a:p>
+            <a:r>
+              <a:t>[확인] talker/listener와 node·topic·echo·info 명령으로 연결을 확인한다.</a:t>
             </a:r>
           </a:p>
           <a:p>
@@ -797,27 +813,17 @@
           <a:lstStyle/>
           <a:p>
             <a:r>
-              <a:t>[설명] 검증 명령은 GUI 결과와 별도로 실행해 재현 가능한 완료 기준을 만든다.</a:t>
-            </a:r>
-          </a:p>
-          <a:p>
-            <a:r>
-              <a:t>[실행] ros2 node list</a:t>
-            </a:r>
-          </a:p>
-          <a:p>
-            <a:r>
-              <a:t>ros2 topic info /chatter</a:t>
-            </a:r>
-          </a:p>
-          <a:p>
-            <a:r>
-              <a:t>ros2 topic echo /chatter --once</a:t>
-            </a:r>
-          </a:p>
-          <a:p>
-            <a:r>
-              <a:t>[확인] talker/listener와 node·topic·echo·info 명령으로 연결을 확인한다.</a:t>
+              <a:t>[설명] 실제 Ubuntu/ROS 2 환경에서 생성한 검증 화면이다.</a:t>
+            </a:r>
+          </a:p>
+          <a:p>
+            <a:r>
+              <a:t>[실행] 슬라이드의 명령 또는 파일 작성 단계를 진행한다.</a:t>
+            </a:r>
+          </a:p>
+          <a:p>
+            <a:r>
+              <a:t>[확인] ① 명령/설정  ② 정상 출력 또는 화면  ③ 다음 검증 명령으로 재확인</a:t>
             </a:r>
           </a:p>
           <a:p>
@@ -897,17 +903,27 @@
           <a:lstStyle/>
           <a:p>
             <a:r>
-              <a:t>[설명] 오류를 대신 해결하지 말고 증상부터 우선 확인 순서대로 교육생이 실행하게 한다.</a:t>
-            </a:r>
-          </a:p>
-          <a:p>
-            <a:r>
-              <a:t>[실행] 슬라이드의 명령 또는 파일 작성 단계를 진행한다.</a:t>
-            </a:r>
-          </a:p>
-          <a:p>
-            <a:r>
-              <a:t>[확인] 수정 뒤 첫 검증 명령을 다시 실행한다.</a:t>
+              <a:t>[설명] 검증 명령은 GUI 결과와 별도로 실행해 재현 가능한 완료 기준을 만든다.</a:t>
+            </a:r>
+          </a:p>
+          <a:p>
+            <a:r>
+              <a:t>[실행] ros2 node list</a:t>
+            </a:r>
+          </a:p>
+          <a:p>
+            <a:r>
+              <a:t>ros2 topic info /chatter</a:t>
+            </a:r>
+          </a:p>
+          <a:p>
+            <a:r>
+              <a:t>ros2 topic echo /chatter --once</a:t>
+            </a:r>
+          </a:p>
+          <a:p>
+            <a:r>
+              <a:t>[확인] talker/listener와 node·topic·echo·info 명령으로 연결을 확인한다.</a:t>
             </a:r>
           </a:p>
           <a:p>
@@ -917,7 +933,7 @@
           </a:p>
           <a:p>
             <a:r>
-              <a:t>[오류] 슬라이드의 두 대표 오류를 먼저 사용한다.</a:t>
+              <a:t>[오류] 오류가 나면 현재 폴더, source, 파일 경로를 먼저 확인한다.</a:t>
             </a:r>
           </a:p>
         </p:txBody>
@@ -987,7 +1003,7 @@
           <a:lstStyle/>
           <a:p>
             <a:r>
-              <a:t>[설명] 교육생이 직접 한 값만 바꿔 원인과 결과를 연결하게 한다.</a:t>
+              <a:t>[설명] 오류를 대신 해결하지 말고 증상부터 우선 확인 순서대로 교육생이 실행하게 한다.</a:t>
             </a:r>
           </a:p>
           <a:p>
@@ -997,7 +1013,7 @@
           </a:p>
           <a:p>
             <a:r>
-              <a:t>[확인] 원래 값과 변경 값을 모두 기록한다.</a:t>
+              <a:t>[확인] 수정 뒤 첫 검증 명령을 다시 실행한다.</a:t>
             </a:r>
           </a:p>
           <a:p>
@@ -1007,7 +1023,7 @@
           </a:p>
           <a:p>
             <a:r>
-              <a:t>[오류] 오류가 나면 현재 폴더, source, 파일 경로를 먼저 확인한다.</a:t>
+              <a:t>[오류] 슬라이드의 두 대표 오류를 먼저 사용한다.</a:t>
             </a:r>
           </a:p>
         </p:txBody>
@@ -1077,7 +1093,7 @@
           <a:lstStyle/>
           <a:p>
             <a:r>
-              <a:t>[설명] 교육생이 Complete·캡처·로그를 저장했는지 확인하고 다음 모듈의 시작 상태를 읽는다.</a:t>
+              <a:t>[설명] 교육생이 직접 한 값만 바꿔 원인과 결과를 연결하게 한다.</a:t>
             </a:r>
           </a:p>
           <a:p>
@@ -1087,7 +1103,7 @@
           </a:p>
           <a:p>
             <a:r>
-              <a:t>[확인] M02 workspace 생성 시작 조건을 말할 수 있다.</a:t>
+              <a:t>[확인] 원래 값과 변경 값을 모두 기록한다.</a:t>
             </a:r>
           </a:p>
           <a:p>
@@ -1167,6 +1183,96 @@
           <a:lstStyle/>
           <a:p>
             <a:r>
+              <a:t>[설명] 교육생이 자신의 workspace·캡처·로그를 저장했는지 확인하고 다음 모듈의 시작 상태를 읽는다.</a:t>
+            </a:r>
+          </a:p>
+          <a:p>
+            <a:r>
+              <a:t>[실행] 슬라이드의 명령 또는 파일 작성 단계를 진행한다.</a:t>
+            </a:r>
+          </a:p>
+          <a:p>
+            <a:r>
+              <a:t>[확인] M02 workspace 생성 시작 조건을 말할 수 있다.</a:t>
+            </a:r>
+          </a:p>
+          <a:p>
+            <a:r>
+              <a:t>[멈춤] 교육생이 현재 체크포인트를 통과할 때까지 기다린다.</a:t>
+            </a:r>
+          </a:p>
+          <a:p>
+            <a:r>
+              <a:t>[오류] 오류가 나면 현재 폴더, source, 파일 경로를 먼저 확인한다.</a:t>
+            </a:r>
+          </a:p>
+        </p:txBody>
+      </p:sp>
+      <p:sp>
+        <p:nvSpPr>
+          <p:cNvPr id="4" name="Slide Number Placeholder 3"/>
+          <p:cNvSpPr>
+            <a:spLocks noGrp="1"/>
+          </p:cNvSpPr>
+          <p:nvPr>
+            <p:ph type="sldNum" idx="5" sz="quarter"/>
+          </p:nvPr>
+        </p:nvSpPr>
+        <p:spPr/>
+      </p:sp>
+    </p:spTree>
+  </p:cSld>
+  <p:clrMapOvr>
+    <a:masterClrMapping/>
+  </p:clrMapOvr>
+</p:notes>
+</file>
+
+<file path=ppt/notesSlides/notesSlide17.xml><?xml version="1.0" encoding="utf-8"?>
+<p:notes xmlns:a="http://schemas.openxmlformats.org/drawingml/2006/main" xmlns:p="http://schemas.openxmlformats.org/presentationml/2006/main" xmlns:r="http://schemas.openxmlformats.org/officeDocument/2006/relationships">
+  <p:cSld>
+    <p:spTree>
+      <p:nvGrpSpPr>
+        <p:cNvPr id="1" name=""/>
+        <p:cNvGrpSpPr/>
+        <p:nvPr/>
+      </p:nvGrpSpPr>
+      <p:grpSpPr>
+        <a:xfrm>
+          <a:off x="0" y="0"/>
+          <a:ext cx="0" cy="0"/>
+          <a:chOff x="0" y="0"/>
+          <a:chExt cx="0" cy="0"/>
+        </a:xfrm>
+      </p:grpSpPr>
+      <p:sp>
+        <p:nvSpPr>
+          <p:cNvPr id="2" name="Slide Image Placeholder 1"/>
+          <p:cNvSpPr>
+            <a:spLocks noGrp="1"/>
+          </p:cNvSpPr>
+          <p:nvPr>
+            <p:ph type="sldImg" idx="2"/>
+          </p:nvPr>
+        </p:nvSpPr>
+        <p:spPr/>
+      </p:sp>
+      <p:sp>
+        <p:nvSpPr>
+          <p:cNvPr id="3" name="Notes Placeholder 2"/>
+          <p:cNvSpPr>
+            <a:spLocks noGrp="1"/>
+          </p:cNvSpPr>
+          <p:nvPr>
+            <p:ph type="body" idx="3" sz="quarter"/>
+          </p:nvPr>
+        </p:nvSpPr>
+        <p:spPr/>
+        <p:txBody>
+          <a:bodyPr/>
+          <a:lstStyle/>
+          <a:p>
+            <a:r>
               <a:t>[설명] 공식 문서는 버전 차이와 확장 학습을 확인할 때 사용한다.</a:t>
             </a:r>
           </a:p>
@@ -1352,7 +1458,7 @@
           </a:p>
           <a:p>
             <a:r>
-              <a:t>[실행] pwd; source /opt/ros/jazzy/setup.bash; source ~/ros2_curri/agv_ws/install/setup.bash</a:t>
+              <a:t>[실행] pwd; source /opt/ros/jazzy/setup.bash</a:t>
             </a:r>
           </a:p>
           <a:p>
@@ -1527,7 +1633,7 @@
           <a:lstStyle/>
           <a:p>
             <a:r>
-              <a:t>[설명] 도식의 각 상자가 무엇을 만들고 화살표가 어떤 방향으로 데이터를 보내는지 설명한다.</a:t>
+              <a:t>[설명] 이 모듈이 전체 AGV 프로젝트에 추가하는 기능을 먼저 선언한다.</a:t>
             </a:r>
           </a:p>
           <a:p>
@@ -1537,7 +1643,7 @@
           </a:p>
           <a:p>
             <a:r>
-              <a:t>[확인] 교육생이 왼쪽에서 오른쪽(또는 제어 방향)으로 흐름을 말할 수 있다.</a:t>
+              <a:t>[확인] talker/listener와 node·topic·echo·info 명령으로 연결을 확인한다.</a:t>
             </a:r>
           </a:p>
           <a:p>
@@ -1617,7 +1723,7 @@
           <a:lstStyle/>
           <a:p>
             <a:r>
-              <a:t>[설명] 실제 파일 경로를 보여 주고 어떤 package의 책임인지 설명한다.</a:t>
+              <a:t>[설명] 도식의 각 상자가 무엇을 만들고 화살표가 어떤 방향으로 데이터를 보내는지 설명한다.</a:t>
             </a:r>
           </a:p>
           <a:p>
@@ -1627,7 +1733,7 @@
           </a:p>
           <a:p>
             <a:r>
-              <a:t>[확인] 교육생이 파일의 부모 package를 찾을 수 있다.</a:t>
+              <a:t>[확인] 교육생이 왼쪽에서 오른쪽(또는 제어 방향)으로 흐름을 말할 수 있다.</a:t>
             </a:r>
           </a:p>
           <a:p>
@@ -1707,22 +1813,17 @@
           <a:lstStyle/>
           <a:p>
             <a:r>
-              <a:t>[설명] 새 터미널은 ROS 명령을 아직 모른다.</a:t>
-            </a:r>
-          </a:p>
-          <a:p>
-            <a:r>
-              <a:t>[실행] source /opt/ros/jazzy/setup.bash</a:t>
-            </a:r>
-          </a:p>
-          <a:p>
-            <a:r>
-              <a:t>ros2 --help | head</a:t>
-            </a:r>
-          </a:p>
-          <a:p>
-            <a:r>
-              <a:t>[확인] 명령 출력에서 슬라이드의 확인 항목을 찾는다.</a:t>
+              <a:t>[설명] 실제 파일 경로를 보여 주고 어떤 package의 책임인지 설명한다.</a:t>
+            </a:r>
+          </a:p>
+          <a:p>
+            <a:r>
+              <a:t>[실행] 슬라이드의 명령 또는 파일 작성 단계를 진행한다.</a:t>
+            </a:r>
+          </a:p>
+          <a:p>
+            <a:r>
+              <a:t>[확인] 교육생이 파일의 부모 package를 찾을 수 있다.</a:t>
             </a:r>
           </a:p>
           <a:p>
@@ -1802,33 +1903,17 @@
           <a:lstStyle/>
           <a:p>
             <a:r>
-              <a:t>[설명] Publisher와 Subscriber는 동시에 살아 있어야 한다.</a:t>
-            </a:r>
-          </a:p>
-          <a:p>
-            <a:r>
-              <a:t>[실행] # 터미널 1</a:t>
-            </a:r>
-          </a:p>
-          <a:p>
-            <a:r>
-              <a:t>ros2 run demo_nodes_cpp talker</a:t>
-            </a:r>
-          </a:p>
-          <a:p/>
-          <a:p>
-            <a:r>
-              <a:t># 새 터미널 2</a:t>
-            </a:r>
-          </a:p>
-          <a:p>
-            <a:r>
-              <a:t>source /opt/ros/jazzy/setup.bash</a:t>
-            </a:r>
-          </a:p>
-          <a:p>
-            <a:r>
-              <a:t>ros2 run demo_nodes_py listener</a:t>
+              <a:t>[설명] 새 터미널은 ROS 명령을 아직 모른다.</a:t>
+            </a:r>
+          </a:p>
+          <a:p>
+            <a:r>
+              <a:t>[실행] source /opt/ros/jazzy/setup.bash</a:t>
+            </a:r>
+          </a:p>
+          <a:p>
+            <a:r>
+              <a:t>ros2 --help | head</a:t>
             </a:r>
           </a:p>
           <a:p>
@@ -1913,27 +1998,33 @@
           <a:lstStyle/>
           <a:p>
             <a:r>
-              <a:t>[설명] 코드 밖에서도 이름·타입·연결 수를 확인할 수 있다.</a:t>
-            </a:r>
-          </a:p>
-          <a:p>
-            <a:r>
-              <a:t>[실행] ros2 node list</a:t>
-            </a:r>
-          </a:p>
-          <a:p>
-            <a:r>
-              <a:t>ros2 topic list</a:t>
-            </a:r>
-          </a:p>
-          <a:p>
-            <a:r>
-              <a:t>ros2 topic info /chatter</a:t>
-            </a:r>
-          </a:p>
-          <a:p>
-            <a:r>
-              <a:t>ros2 topic echo /chatter --once</a:t>
+              <a:t>[설명] Publisher와 Subscriber는 동시에 살아 있어야 한다.</a:t>
+            </a:r>
+          </a:p>
+          <a:p>
+            <a:r>
+              <a:t>[실행] # 터미널 1</a:t>
+            </a:r>
+          </a:p>
+          <a:p>
+            <a:r>
+              <a:t>ros2 run demo_nodes_cpp talker</a:t>
+            </a:r>
+          </a:p>
+          <a:p/>
+          <a:p>
+            <a:r>
+              <a:t># 새 터미널 2</a:t>
+            </a:r>
+          </a:p>
+          <a:p>
+            <a:r>
+              <a:t>source /opt/ros/jazzy/setup.bash</a:t>
+            </a:r>
+          </a:p>
+          <a:p>
+            <a:r>
+              <a:t>ros2 run demo_nodes_py listener</a:t>
             </a:r>
           </a:p>
           <a:p>
@@ -5186,7 +5277,7 @@
               </a:defRPr>
             </a:pPr>
             <a:r>
-              <a:t>이 PPT만 보고 시작 상태 → 파일 작성 → build/run → 검증 → 오류 대응 → checkpoint를 순서대로 수행합니다.</a:t>
+              <a:t>이 PPT에서 폴더 생성 → 빈 파일 열기 → 코드 입력·저장 → build/run → 검증을 직접 반복합니다.</a:t>
             </a:r>
           </a:p>
         </p:txBody>
@@ -5321,7 +5412,7 @@
               </a:defRPr>
             </a:pPr>
             <a:r>
-              <a:t>build → source → run 순서로 실행한다</a:t>
+              <a:t>구현 뒤 실행 3/3: 연결을 명령으로 관찰한다</a:t>
             </a:r>
           </a:p>
         </p:txBody>
@@ -5360,7 +5451,7 @@
               </a:defRPr>
             </a:pPr>
             <a:r>
-              <a:t>새 파일 또는 수정 파일은 build와 source 뒤에만 실행 이름·설정에 반영됩니다.</a:t>
+              <a:t>방금 직접 만든 파일을 실행·검사하며 다음 파일로 넘어갈 기준을 만듭니다.</a:t>
             </a:r>
           </a:p>
         </p:txBody>
@@ -5496,21 +5587,99 @@
               </a:defRPr>
             </a:pPr>
             <a:r>
-              <a:t>현재 단계 실행    |    현재 폴더 ~/ros2_curri/agv_ws    |    현재 터미널</a:t>
-            </a:r>
-          </a:p>
-        </p:txBody>
-      </p:sp>
-      <p:sp>
-        <p:nvSpPr>
-          <p:cNvPr id="7" name="Rounded Rectangle 6"/>
+              <a:t>현재 단계 실행 3/3    |    현재 폴더 ~/ros2_curri/my_agv_ws    |    현재 터미널</a:t>
+            </a:r>
+          </a:p>
+        </p:txBody>
+      </p:sp>
+      <p:sp>
+        <p:nvSpPr>
+          <p:cNvPr id="7" name="TextBox 6"/>
+          <p:cNvSpPr txBox="1"/>
+          <p:nvPr/>
+        </p:nvSpPr>
+        <p:spPr>
+          <a:xfrm>
+            <a:off x="676656" y="1764792"/>
+            <a:ext cx="1828800" cy="347472"/>
+          </a:xfrm>
+          <a:prstGeom prst="rect">
+            <a:avLst/>
+          </a:prstGeom>
+          <a:noFill/>
+        </p:spPr>
+        <p:txBody>
+          <a:bodyPr wrap="square" lIns="73152" rIns="73152" tIns="36576" bIns="36576">
+            <a:spAutoFit/>
+          </a:bodyPr>
+          <a:lstStyle/>
+          <a:p>
+            <a:pPr algn="l">
+              <a:spcAft>
+                <a:spcPts val="0"/>
+              </a:spcAft>
+              <a:defRPr sz="1800" b="1">
+                <a:solidFill>
+                  <a:srgbClr val="225B9B"/>
+                </a:solidFill>
+                <a:latin typeface="Noto Sans CJK KR"/>
+              </a:defRPr>
+            </a:pPr>
+            <a:r>
+              <a:t>왜 하는가</a:t>
+            </a:r>
+          </a:p>
+        </p:txBody>
+      </p:sp>
+      <p:sp>
+        <p:nvSpPr>
+          <p:cNvPr id="8" name="TextBox 7"/>
+          <p:cNvSpPr txBox="1"/>
+          <p:nvPr/>
+        </p:nvSpPr>
+        <p:spPr>
+          <a:xfrm>
+            <a:off x="676656" y="2103120"/>
+            <a:ext cx="10789920" cy="512064"/>
+          </a:xfrm>
+          <a:prstGeom prst="rect">
+            <a:avLst/>
+          </a:prstGeom>
+          <a:noFill/>
+        </p:spPr>
+        <p:txBody>
+          <a:bodyPr wrap="square" lIns="73152" rIns="73152" tIns="36576" bIns="36576">
+            <a:spAutoFit/>
+          </a:bodyPr>
+          <a:lstStyle/>
+          <a:p>
+            <a:pPr algn="l">
+              <a:spcAft>
+                <a:spcPts val="0"/>
+              </a:spcAft>
+              <a:defRPr sz="2000" b="0">
+                <a:solidFill>
+                  <a:srgbClr val="122C4E"/>
+                </a:solidFill>
+                <a:latin typeface="Noto Sans CJK KR"/>
+              </a:defRPr>
+            </a:pPr>
+            <a:r>
+              <a:t>코드 밖에서도 이름·타입·연결 수를 확인할 수 있다.</a:t>
+            </a:r>
+          </a:p>
+        </p:txBody>
+      </p:sp>
+      <p:sp>
+        <p:nvSpPr>
+          <p:cNvPr id="9" name="Rounded Rectangle 8"/>
           <p:cNvSpPr/>
           <p:nvPr/>
         </p:nvSpPr>
         <p:spPr>
           <a:xfrm>
-            <a:off x="658368" y="1700784"/>
-            <a:ext cx="10972800" cy="3182112"/>
+            <a:off x="676656" y="2871216"/>
+            <a:ext cx="10835640" cy="2331720"/>
           </a:xfrm>
           <a:prstGeom prst="roundRect">
             <a:avLst/>
@@ -5554,29 +5723,33 @@
               </a:defRPr>
             </a:pPr>
             <a:r>
-              <a:t>source /opt/ros/jazzy/setup.bash</a:t>
+              <a:t>ros2 node list</a:t>
             </a:r>
             <a:br/>
             <a:r>
-              <a:t>ros2 run demo_nodes_cpp talker</a:t>
+              <a:t>ros2 topic list</a:t>
             </a:r>
             <a:br/>
             <a:r>
-              <a:t># 새 터미널: ros2 run demo_nodes_py listener</a:t>
-            </a:r>
-          </a:p>
-        </p:txBody>
-      </p:sp>
-      <p:sp>
-        <p:nvSpPr>
-          <p:cNvPr id="8" name="TextBox 7"/>
+              <a:t>ros2 topic info /chatter</a:t>
+            </a:r>
+            <a:br/>
+            <a:r>
+              <a:t>ros2 topic echo /chatter --once</a:t>
+            </a:r>
+          </a:p>
+        </p:txBody>
+      </p:sp>
+      <p:sp>
+        <p:nvSpPr>
+          <p:cNvPr id="10" name="TextBox 9"/>
           <p:cNvSpPr txBox="1"/>
           <p:nvPr/>
         </p:nvSpPr>
         <p:spPr>
           <a:xfrm>
-            <a:off x="786384" y="5239512"/>
-            <a:ext cx="1261872" cy="237744"/>
+            <a:off x="768096" y="5468112"/>
+            <a:ext cx="1143000" cy="256032"/>
           </a:xfrm>
           <a:prstGeom prst="rect">
             <a:avLst/>
@@ -5601,21 +5774,21 @@
               </a:defRPr>
             </a:pPr>
             <a:r>
-              <a:t>확인 기준</a:t>
-            </a:r>
-          </a:p>
-        </p:txBody>
-      </p:sp>
-      <p:sp>
-        <p:nvSpPr>
-          <p:cNvPr id="9" name="TextBox 8"/>
+              <a:t>확인</a:t>
+            </a:r>
+          </a:p>
+        </p:txBody>
+      </p:sp>
+      <p:sp>
+        <p:nvSpPr>
+          <p:cNvPr id="11" name="TextBox 10"/>
           <p:cNvSpPr txBox="1"/>
           <p:nvPr/>
         </p:nvSpPr>
         <p:spPr>
           <a:xfrm>
-            <a:off x="786384" y="5532120"/>
-            <a:ext cx="10469880" cy="420624"/>
+            <a:off x="768096" y="5742432"/>
+            <a:ext cx="10561320" cy="347472"/>
           </a:xfrm>
           <a:prstGeom prst="rect">
             <a:avLst/>
@@ -5640,7 +5813,7 @@
               </a:defRPr>
             </a:pPr>
             <a:r>
-              <a:t>talker/listener와 node·topic·echo·info 명령으로 연결을 확인한다.</a:t>
+              <a:t>출력에서 topic·frame·파일 이름 또는 성공 메시지를 찾고, 맞지 않으면 다음 파일로 가지 않습니다.</a:t>
             </a:r>
           </a:p>
         </p:txBody>
@@ -5697,7 +5870,7 @@
               </a:defRPr>
             </a:pPr>
             <a:r>
-              <a:t>정상 결과: 실제 환경에서 확인한 출력</a:t>
+              <a:t>build → source → run 순서로 실행한다</a:t>
             </a:r>
           </a:p>
         </p:txBody>
@@ -5736,7 +5909,7 @@
               </a:defRPr>
             </a:pPr>
             <a:r>
-              <a:t>실제 ROS 2 환경의 파일·패키지·구성 검증 로그</a:t>
+              <a:t>새 파일 또는 수정 파일은 build와 source 뒤에만 실행 이름·설정에 반영됩니다.</a:t>
             </a:r>
           </a:p>
         </p:txBody>
@@ -5819,40 +5992,140 @@
           </a:p>
         </p:txBody>
       </p:sp>
-      <p:pic>
-        <p:nvPicPr>
-          <p:cNvPr id="6" name="Picture 5" descr="validation_terminal.png"/>
-          <p:cNvPicPr>
-            <a:picLocks noChangeAspect="1"/>
-          </p:cNvPicPr>
-          <p:nvPr/>
-        </p:nvPicPr>
-        <p:blipFill>
-          <a:blip r:embed="rId2"/>
-          <a:stretch>
-            <a:fillRect/>
-          </a:stretch>
-        </p:blipFill>
-        <p:spPr>
-          <a:xfrm>
-            <a:off x="790956" y="1884338"/>
-            <a:ext cx="10607040" cy="3738546"/>
-          </a:xfrm>
-          <a:prstGeom prst="rect">
-            <a:avLst/>
-          </a:prstGeom>
-        </p:spPr>
-      </p:pic>
-      <p:sp>
-        <p:nvSpPr>
-          <p:cNvPr id="7" name="TextBox 6"/>
+      <p:sp>
+        <p:nvSpPr>
+          <p:cNvPr id="6" name="Rectangle 5"/>
+          <p:cNvSpPr/>
+          <p:nvPr/>
+        </p:nvSpPr>
+        <p:spPr>
+          <a:xfrm>
+            <a:off x="566928" y="1188720"/>
+            <a:ext cx="11064240" cy="347472"/>
+          </a:xfrm>
+          <a:prstGeom prst="rect">
+            <a:avLst/>
+          </a:prstGeom>
+          <a:solidFill>
+            <a:srgbClr val="F4F7FB"/>
+          </a:solidFill>
+          <a:ln>
+            <a:solidFill>
+              <a:srgbClr val="F4F7FB"/>
+            </a:solidFill>
+          </a:ln>
+        </p:spPr>
+        <p:style>
+          <a:lnRef idx="1">
+            <a:schemeClr val="accent1"/>
+          </a:lnRef>
+          <a:fillRef idx="3">
+            <a:schemeClr val="accent1"/>
+          </a:fillRef>
+          <a:effectRef idx="2">
+            <a:schemeClr val="accent1"/>
+          </a:effectRef>
+          <a:fontRef idx="minor">
+            <a:schemeClr val="lt1"/>
+          </a:fontRef>
+        </p:style>
+        <p:txBody>
+          <a:bodyPr rtlCol="0" anchor="ctr" wrap="square" lIns="73152" rIns="73152" tIns="36576" bIns="36576"/>
+          <a:lstStyle/>
+          <a:p>
+            <a:pPr algn="l">
+              <a:spcAft>
+                <a:spcPts val="0"/>
+              </a:spcAft>
+              <a:defRPr sz="1300" b="1">
+                <a:solidFill>
+                  <a:srgbClr val="122C4E"/>
+                </a:solidFill>
+                <a:latin typeface="Noto Sans CJK KR"/>
+              </a:defRPr>
+            </a:pPr>
+            <a:r>
+              <a:t>현재 단계 실행    |    현재 폴더 ~/ros2_curri/my_agv_ws    |    현재 터미널</a:t>
+            </a:r>
+          </a:p>
+        </p:txBody>
+      </p:sp>
+      <p:sp>
+        <p:nvSpPr>
+          <p:cNvPr id="7" name="Rounded Rectangle 6"/>
+          <p:cNvSpPr/>
+          <p:nvPr/>
+        </p:nvSpPr>
+        <p:spPr>
+          <a:xfrm>
+            <a:off x="658368" y="1700784"/>
+            <a:ext cx="10972800" cy="3182112"/>
+          </a:xfrm>
+          <a:prstGeom prst="roundRect">
+            <a:avLst/>
+          </a:prstGeom>
+          <a:solidFill>
+            <a:srgbClr val="1D232D"/>
+          </a:solidFill>
+          <a:ln>
+            <a:solidFill>
+              <a:srgbClr val="1D232D"/>
+            </a:solidFill>
+          </a:ln>
+        </p:spPr>
+        <p:style>
+          <a:lnRef idx="1">
+            <a:schemeClr val="accent1"/>
+          </a:lnRef>
+          <a:fillRef idx="3">
+            <a:schemeClr val="accent1"/>
+          </a:fillRef>
+          <a:effectRef idx="2">
+            <a:schemeClr val="accent1"/>
+          </a:effectRef>
+          <a:fontRef idx="minor">
+            <a:schemeClr val="lt1"/>
+          </a:fontRef>
+        </p:style>
+        <p:txBody>
+          <a:bodyPr rtlCol="0" anchor="ctr" wrap="square" lIns="73152" rIns="73152" tIns="36576" bIns="36576"/>
+          <a:lstStyle/>
+          <a:p>
+            <a:pPr algn="l">
+              <a:spcAft>
+                <a:spcPts val="0"/>
+              </a:spcAft>
+              <a:defRPr sz="1600" b="0">
+                <a:solidFill>
+                  <a:srgbClr val="FFFFFF"/>
+                </a:solidFill>
+                <a:latin typeface="DejaVu Sans Mono"/>
+              </a:defRPr>
+            </a:pPr>
+            <a:r>
+              <a:t>source /opt/ros/jazzy/setup.bash</a:t>
+            </a:r>
+            <a:br/>
+            <a:r>
+              <a:t>ros2 run demo_nodes_cpp talker</a:t>
+            </a:r>
+            <a:br/>
+            <a:r>
+              <a:t># 새 터미널: ros2 run demo_nodes_py listener</a:t>
+            </a:r>
+          </a:p>
+        </p:txBody>
+      </p:sp>
+      <p:sp>
+        <p:nvSpPr>
+          <p:cNvPr id="8" name="TextBox 7"/>
           <p:cNvSpPr txBox="1"/>
           <p:nvPr/>
         </p:nvSpPr>
         <p:spPr>
           <a:xfrm>
-            <a:off x="777240" y="6144768"/>
-            <a:ext cx="10607040" cy="310896"/>
+            <a:off x="786384" y="5239512"/>
+            <a:ext cx="1261872" cy="237744"/>
           </a:xfrm>
           <a:prstGeom prst="rect">
             <a:avLst/>
@@ -5865,11 +6138,11 @@
           </a:bodyPr>
           <a:lstStyle/>
           <a:p>
-            <a:pPr algn="ctr">
-              <a:spcAft>
-                <a:spcPts val="0"/>
-              </a:spcAft>
-              <a:defRPr sz="1100" b="1">
+            <a:pPr algn="l">
+              <a:spcAft>
+                <a:spcPts val="0"/>
+              </a:spcAft>
+              <a:defRPr sz="1800" b="1">
                 <a:solidFill>
                   <a:srgbClr val="2A8B5A"/>
                 </a:solidFill>
@@ -5877,7 +6150,46 @@
               </a:defRPr>
             </a:pPr>
             <a:r>
-              <a:t>화면에서 확인: ① 명령/설정  ② 정상 출력 또는 화면  ③ 다음 검증 명령으로 재확인</a:t>
+              <a:t>확인 기준</a:t>
+            </a:r>
+          </a:p>
+        </p:txBody>
+      </p:sp>
+      <p:sp>
+        <p:nvSpPr>
+          <p:cNvPr id="9" name="TextBox 8"/>
+          <p:cNvSpPr txBox="1"/>
+          <p:nvPr/>
+        </p:nvSpPr>
+        <p:spPr>
+          <a:xfrm>
+            <a:off x="786384" y="5532120"/>
+            <a:ext cx="10469880" cy="420624"/>
+          </a:xfrm>
+          <a:prstGeom prst="rect">
+            <a:avLst/>
+          </a:prstGeom>
+          <a:noFill/>
+        </p:spPr>
+        <p:txBody>
+          <a:bodyPr wrap="square" lIns="73152" rIns="73152" tIns="36576" bIns="36576">
+            <a:spAutoFit/>
+          </a:bodyPr>
+          <a:lstStyle/>
+          <a:p>
+            <a:pPr algn="l">
+              <a:spcAft>
+                <a:spcPts val="0"/>
+              </a:spcAft>
+              <a:defRPr sz="1800" b="0">
+                <a:solidFill>
+                  <a:srgbClr val="122C4E"/>
+                </a:solidFill>
+                <a:latin typeface="Noto Sans CJK KR"/>
+              </a:defRPr>
+            </a:pPr>
+            <a:r>
+              <a:t>talker/listener와 node·topic·echo·info 명령으로 연결을 확인한다.</a:t>
             </a:r>
           </a:p>
         </p:txBody>
@@ -5934,7 +6246,7 @@
               </a:defRPr>
             </a:pPr>
             <a:r>
-              <a:t>객관적 검증 명령으로 완료를 확인한다</a:t>
+              <a:t>정상 결과: 실제 환경에서 확인한 출력</a:t>
             </a:r>
           </a:p>
         </p:txBody>
@@ -5973,7 +6285,7 @@
               </a:defRPr>
             </a:pPr>
             <a:r>
-              <a:t>화면만 보지 말고 topic·frame·파일·parameter를 다시 확인합니다.</a:t>
+              <a:t>실제 ROS 2 환경의 파일·패키지·구성 검증 로그</a:t>
             </a:r>
           </a:p>
         </p:txBody>
@@ -6056,210 +6368,40 @@
           </a:p>
         </p:txBody>
       </p:sp>
-      <p:sp>
-        <p:nvSpPr>
-          <p:cNvPr id="6" name="Rectangle 5"/>
-          <p:cNvSpPr/>
-          <p:nvPr/>
-        </p:nvSpPr>
-        <p:spPr>
-          <a:xfrm>
-            <a:off x="566928" y="1188720"/>
-            <a:ext cx="11064240" cy="347472"/>
-          </a:xfrm>
-          <a:prstGeom prst="rect">
-            <a:avLst/>
-          </a:prstGeom>
-          <a:solidFill>
-            <a:srgbClr val="F4F7FB"/>
-          </a:solidFill>
-          <a:ln>
-            <a:solidFill>
-              <a:srgbClr val="F4F7FB"/>
-            </a:solidFill>
-          </a:ln>
-        </p:spPr>
-        <p:style>
-          <a:lnRef idx="1">
-            <a:schemeClr val="accent1"/>
-          </a:lnRef>
-          <a:fillRef idx="3">
-            <a:schemeClr val="accent1"/>
-          </a:fillRef>
-          <a:effectRef idx="2">
-            <a:schemeClr val="accent1"/>
-          </a:effectRef>
-          <a:fontRef idx="minor">
-            <a:schemeClr val="lt1"/>
-          </a:fontRef>
-        </p:style>
-        <p:txBody>
-          <a:bodyPr rtlCol="0" anchor="ctr" wrap="square" lIns="73152" rIns="73152" tIns="36576" bIns="36576"/>
-          <a:lstStyle/>
-          <a:p>
-            <a:pPr algn="l">
-              <a:spcAft>
-                <a:spcPts val="0"/>
-              </a:spcAft>
-              <a:defRPr sz="1300" b="1">
-                <a:solidFill>
-                  <a:srgbClr val="122C4E"/>
-                </a:solidFill>
-                <a:latin typeface="Noto Sans CJK KR"/>
-              </a:defRPr>
-            </a:pPr>
-            <a:r>
-              <a:t>현재 단계 검증    |    현재 폴더 ~/ros2_curri/agv_ws    |    현재 터미널</a:t>
-            </a:r>
-          </a:p>
-        </p:txBody>
-      </p:sp>
-      <p:sp>
-        <p:nvSpPr>
-          <p:cNvPr id="7" name="Rounded Rectangle 6"/>
-          <p:cNvSpPr/>
-          <p:nvPr/>
-        </p:nvSpPr>
-        <p:spPr>
-          <a:xfrm>
-            <a:off x="658368" y="1755648"/>
-            <a:ext cx="10972800" cy="2148840"/>
-          </a:xfrm>
-          <a:prstGeom prst="roundRect">
-            <a:avLst/>
-          </a:prstGeom>
-          <a:solidFill>
-            <a:srgbClr val="1D232D"/>
-          </a:solidFill>
-          <a:ln>
-            <a:solidFill>
-              <a:srgbClr val="1D232D"/>
-            </a:solidFill>
-          </a:ln>
-        </p:spPr>
-        <p:style>
-          <a:lnRef idx="1">
-            <a:schemeClr val="accent1"/>
-          </a:lnRef>
-          <a:fillRef idx="3">
-            <a:schemeClr val="accent1"/>
-          </a:fillRef>
-          <a:effectRef idx="2">
-            <a:schemeClr val="accent1"/>
-          </a:effectRef>
-          <a:fontRef idx="minor">
-            <a:schemeClr val="lt1"/>
-          </a:fontRef>
-        </p:style>
-        <p:txBody>
-          <a:bodyPr rtlCol="0" anchor="ctr" wrap="square" lIns="73152" rIns="73152" tIns="36576" bIns="36576"/>
-          <a:lstStyle/>
-          <a:p>
-            <a:pPr algn="l">
-              <a:spcAft>
-                <a:spcPts val="0"/>
-              </a:spcAft>
-              <a:defRPr sz="1600" b="0">
-                <a:solidFill>
-                  <a:srgbClr val="FFFFFF"/>
-                </a:solidFill>
-                <a:latin typeface="DejaVu Sans Mono"/>
-              </a:defRPr>
-            </a:pPr>
-            <a:r>
-              <a:t>ros2 node list</a:t>
-            </a:r>
-            <a:br/>
-            <a:r>
-              <a:t>ros2 topic info /chatter</a:t>
-            </a:r>
-            <a:br/>
-            <a:r>
-              <a:t>ros2 topic echo /chatter --once</a:t>
-            </a:r>
-          </a:p>
-        </p:txBody>
-      </p:sp>
-      <p:sp>
-        <p:nvSpPr>
-          <p:cNvPr id="8" name="Rounded Rectangle 7"/>
-          <p:cNvSpPr/>
-          <p:nvPr/>
-        </p:nvSpPr>
-        <p:spPr>
-          <a:xfrm>
-            <a:off x="658368" y="4206240"/>
-            <a:ext cx="10972800" cy="1554480"/>
-          </a:xfrm>
-          <a:prstGeom prst="roundRect">
-            <a:avLst/>
-          </a:prstGeom>
-          <a:solidFill>
-            <a:srgbClr val="F4F7FB"/>
-          </a:solidFill>
-          <a:ln>
-            <a:solidFill>
-              <a:srgbClr val="D1DFD5"/>
-            </a:solidFill>
-          </a:ln>
-        </p:spPr>
-        <p:style>
-          <a:lnRef idx="1">
-            <a:schemeClr val="accent1"/>
-          </a:lnRef>
-          <a:fillRef idx="3">
-            <a:schemeClr val="accent1"/>
-          </a:fillRef>
-          <a:effectRef idx="2">
-            <a:schemeClr val="accent1"/>
-          </a:effectRef>
-          <a:fontRef idx="minor">
-            <a:schemeClr val="lt1"/>
-          </a:fontRef>
-        </p:style>
-        <p:txBody>
-          <a:bodyPr rtlCol="0" anchor="ctr" wrap="square" lIns="73152" rIns="73152" tIns="36576" bIns="36576"/>
-          <a:lstStyle/>
-          <a:p>
-            <a:pPr algn="l">
-              <a:spcAft>
-                <a:spcPts val="0"/>
-              </a:spcAft>
-              <a:defRPr sz="1800" b="1">
-                <a:solidFill>
-                  <a:srgbClr val="2A8B5A"/>
-                </a:solidFill>
-                <a:latin typeface="Noto Sans CJK KR"/>
-              </a:defRPr>
-            </a:pPr>
-            <a:r>
-              <a:t>완료 체크</a:t>
-            </a:r>
-            <a:br/>
-            <a:r>
-              <a:t>□ 명령이 오류 없이 실행된다.</a:t>
-            </a:r>
-            <a:br/>
-            <a:r>
-              <a:t>□ 기대한 파일·topic·frame·parameter 이름이 보인다.</a:t>
-            </a:r>
-            <a:br/>
-            <a:r>
-              <a:t>□ 값의 단위와 방향을 한 문장으로 설명할 수 있다.</a:t>
-            </a:r>
-          </a:p>
-        </p:txBody>
-      </p:sp>
-      <p:sp>
-        <p:nvSpPr>
-          <p:cNvPr id="9" name="TextBox 8"/>
+      <p:pic>
+        <p:nvPicPr>
+          <p:cNvPr id="6" name="Picture 5" descr="validation_terminal.png"/>
+          <p:cNvPicPr>
+            <a:picLocks noChangeAspect="1"/>
+          </p:cNvPicPr>
+          <p:nvPr/>
+        </p:nvPicPr>
+        <p:blipFill>
+          <a:blip r:embed="rId2"/>
+          <a:stretch>
+            <a:fillRect/>
+          </a:stretch>
+        </p:blipFill>
+        <p:spPr>
+          <a:xfrm>
+            <a:off x="790956" y="1884338"/>
+            <a:ext cx="10607040" cy="3738546"/>
+          </a:xfrm>
+          <a:prstGeom prst="rect">
+            <a:avLst/>
+          </a:prstGeom>
+        </p:spPr>
+      </p:pic>
+      <p:sp>
+        <p:nvSpPr>
+          <p:cNvPr id="7" name="TextBox 6"/>
           <p:cNvSpPr txBox="1"/>
           <p:nvPr/>
         </p:nvSpPr>
         <p:spPr>
           <a:xfrm>
-            <a:off x="731520" y="5989320"/>
-            <a:ext cx="10789920" cy="237744"/>
+            <a:off x="777240" y="6144768"/>
+            <a:ext cx="10607040" cy="310896"/>
           </a:xfrm>
           <a:prstGeom prst="rect">
             <a:avLst/>
@@ -6272,19 +6414,19 @@
           </a:bodyPr>
           <a:lstStyle/>
           <a:p>
-            <a:pPr algn="l">
-              <a:spcAft>
-                <a:spcPts val="0"/>
-              </a:spcAft>
-              <a:defRPr sz="1500" b="1">
-                <a:solidFill>
-                  <a:srgbClr val="122C4E"/>
-                </a:solidFill>
-                <a:latin typeface="Noto Sans CJK KR"/>
-              </a:defRPr>
-            </a:pPr>
-            <a:r>
-              <a:t>완료 조건: talker/listener와 node·topic·echo·info 명령으로 연결을 확인한다.</a:t>
+            <a:pPr algn="ctr">
+              <a:spcAft>
+                <a:spcPts val="0"/>
+              </a:spcAft>
+              <a:defRPr sz="1100" b="1">
+                <a:solidFill>
+                  <a:srgbClr val="2A8B5A"/>
+                </a:solidFill>
+                <a:latin typeface="Noto Sans CJK KR"/>
+              </a:defRPr>
+            </a:pPr>
+            <a:r>
+              <a:t>화면에서 확인: ① 명령/설정  ② 정상 출력 또는 화면  ③ 다음 검증 명령으로 재확인</a:t>
             </a:r>
           </a:p>
         </p:txBody>
@@ -6341,7 +6483,7 @@
               </a:defRPr>
             </a:pPr>
             <a:r>
-              <a:t>막히면: 증상 → 우선 확인 → 재검증</a:t>
+              <a:t>객관적 검증 명령으로 완료를 확인한다</a:t>
             </a:r>
           </a:p>
         </p:txBody>
@@ -6380,7 +6522,7 @@
               </a:defRPr>
             </a:pPr>
             <a:r>
-              <a:t>오류 메시지를 숨기지 않고 같은 순서로 점검합니다.</a:t>
+              <a:t>화면만 보지 말고 topic·frame·파일·parameter를 다시 확인합니다.</a:t>
             </a:r>
           </a:p>
         </p:txBody>
@@ -6516,7 +6658,7 @@
               </a:defRPr>
             </a:pPr>
             <a:r>
-              <a:t>현재 단계 오류 대응    |    현재 폴더 ~/ros2_curri/agv_ws    |    현재 터미널</a:t>
+              <a:t>현재 단계 검증    |    현재 폴더 ~/ros2_curri/my_agv_ws    |    현재 터미널</a:t>
             </a:r>
           </a:p>
         </p:txBody>
@@ -6529,18 +6671,18 @@
         </p:nvSpPr>
         <p:spPr>
           <a:xfrm>
-            <a:off x="694944" y="1755648"/>
-            <a:ext cx="10972800" cy="1115568"/>
+            <a:off x="658368" y="1755648"/>
+            <a:ext cx="10972800" cy="2148840"/>
           </a:xfrm>
           <a:prstGeom prst="roundRect">
             <a:avLst/>
           </a:prstGeom>
           <a:solidFill>
-            <a:srgbClr val="FFF7F4"/>
+            <a:srgbClr val="1D232D"/>
           </a:solidFill>
           <a:ln>
             <a:solidFill>
-              <a:srgbClr val="EDBEB4"/>
+              <a:srgbClr val="1D232D"/>
             </a:solidFill>
           </a:ln>
         </p:spPr>
@@ -6559,115 +6701,54 @@
           </a:fontRef>
         </p:style>
         <p:txBody>
-          <a:bodyPr rtlCol="0" anchor="ctr"/>
-          <a:lstStyle/>
-          <a:p>
-            <a:pPr algn="ctr"/>
-          </a:p>
-        </p:txBody>
-      </p:sp>
-      <p:sp>
-        <p:nvSpPr>
-          <p:cNvPr id="8" name="TextBox 7"/>
-          <p:cNvSpPr txBox="1"/>
-          <p:nvPr/>
-        </p:nvSpPr>
-        <p:spPr>
-          <a:xfrm>
-            <a:off x="896112" y="1901952"/>
-            <a:ext cx="2926080" cy="274320"/>
-          </a:xfrm>
-          <a:prstGeom prst="rect">
-            <a:avLst/>
-          </a:prstGeom>
-          <a:noFill/>
-        </p:spPr>
-        <p:txBody>
-          <a:bodyPr wrap="square" lIns="73152" rIns="73152" tIns="36576" bIns="36576">
-            <a:spAutoFit/>
-          </a:bodyPr>
+          <a:bodyPr rtlCol="0" anchor="ctr" wrap="square" lIns="73152" rIns="73152" tIns="36576" bIns="36576"/>
           <a:lstStyle/>
           <a:p>
             <a:pPr algn="l">
               <a:spcAft>
                 <a:spcPts val="0"/>
               </a:spcAft>
-              <a:defRPr sz="1800" b="1">
-                <a:solidFill>
-                  <a:srgbClr val="BE3B3B"/>
-                </a:solidFill>
-                <a:latin typeface="Noto Sans CJK KR"/>
-              </a:defRPr>
-            </a:pPr>
-            <a:r>
-              <a:t>증상 1: ros2: command not found</a:t>
-            </a:r>
-          </a:p>
-        </p:txBody>
-      </p:sp>
-      <p:sp>
-        <p:nvSpPr>
-          <p:cNvPr id="9" name="TextBox 8"/>
-          <p:cNvSpPr txBox="1"/>
-          <p:nvPr/>
-        </p:nvSpPr>
-        <p:spPr>
-          <a:xfrm>
-            <a:off x="3794760" y="1883664"/>
-            <a:ext cx="7543800" cy="621792"/>
-          </a:xfrm>
-          <a:prstGeom prst="rect">
-            <a:avLst/>
-          </a:prstGeom>
-          <a:noFill/>
-        </p:spPr>
-        <p:txBody>
-          <a:bodyPr wrap="square" lIns="73152" rIns="73152" tIns="36576" bIns="36576">
-            <a:spAutoFit/>
-          </a:bodyPr>
-          <a:lstStyle/>
-          <a:p>
-            <a:pPr algn="l">
-              <a:spcAft>
-                <a:spcPts val="0"/>
-              </a:spcAft>
               <a:defRPr sz="1600" b="0">
                 <a:solidFill>
-                  <a:srgbClr val="122C4E"/>
-                </a:solidFill>
-                <a:latin typeface="Noto Sans CJK KR"/>
-              </a:defRPr>
-            </a:pPr>
-            <a:r>
-              <a:t>우선 확인: source /opt/ros/jazzy/setup.bash를 실행한다.</a:t>
+                  <a:srgbClr val="FFFFFF"/>
+                </a:solidFill>
+                <a:latin typeface="DejaVu Sans Mono"/>
+              </a:defRPr>
+            </a:pPr>
+            <a:r>
+              <a:t>ros2 node list</a:t>
             </a:r>
             <a:br/>
             <a:r>
-              <a:t>수정 후: ros2 node list</a:t>
-            </a:r>
-          </a:p>
-        </p:txBody>
-      </p:sp>
-      <p:sp>
-        <p:nvSpPr>
-          <p:cNvPr id="10" name="Rounded Rectangle 9"/>
+              <a:t>ros2 topic info /chatter</a:t>
+            </a:r>
+            <a:br/>
+            <a:r>
+              <a:t>ros2 topic echo /chatter --once</a:t>
+            </a:r>
+          </a:p>
+        </p:txBody>
+      </p:sp>
+      <p:sp>
+        <p:nvSpPr>
+          <p:cNvPr id="8" name="Rounded Rectangle 7"/>
           <p:cNvSpPr/>
           <p:nvPr/>
         </p:nvSpPr>
         <p:spPr>
           <a:xfrm>
-            <a:off x="694944" y="3172968"/>
-            <a:ext cx="10972800" cy="1115568"/>
+            <a:off x="658368" y="4206240"/>
+            <a:ext cx="10972800" cy="1554480"/>
           </a:xfrm>
           <a:prstGeom prst="roundRect">
             <a:avLst/>
           </a:prstGeom>
           <a:solidFill>
-            <a:srgbClr val="FFF7F4"/>
+            <a:srgbClr val="F4F7FB"/>
           </a:solidFill>
           <a:ln>
             <a:solidFill>
-              <a:srgbClr val="EDBEB4"/>
+              <a:srgbClr val="D1DFD5"/>
             </a:solidFill>
           </a:ln>
         </p:spPr>
@@ -6686,23 +6767,48 @@
           </a:fontRef>
         </p:style>
         <p:txBody>
-          <a:bodyPr rtlCol="0" anchor="ctr"/>
-          <a:lstStyle/>
-          <a:p>
-            <a:pPr algn="ctr"/>
-          </a:p>
-        </p:txBody>
-      </p:sp>
-      <p:sp>
-        <p:nvSpPr>
-          <p:cNvPr id="11" name="TextBox 10"/>
+          <a:bodyPr rtlCol="0" anchor="ctr" wrap="square" lIns="73152" rIns="73152" tIns="36576" bIns="36576"/>
+          <a:lstStyle/>
+          <a:p>
+            <a:pPr algn="l">
+              <a:spcAft>
+                <a:spcPts val="0"/>
+              </a:spcAft>
+              <a:defRPr sz="1800" b="1">
+                <a:solidFill>
+                  <a:srgbClr val="2A8B5A"/>
+                </a:solidFill>
+                <a:latin typeface="Noto Sans CJK KR"/>
+              </a:defRPr>
+            </a:pPr>
+            <a:r>
+              <a:t>완료 체크</a:t>
+            </a:r>
+            <a:br/>
+            <a:r>
+              <a:t>□ 명령이 오류 없이 실행된다.</a:t>
+            </a:r>
+            <a:br/>
+            <a:r>
+              <a:t>□ 기대한 파일·topic·frame·parameter 이름이 보인다.</a:t>
+            </a:r>
+            <a:br/>
+            <a:r>
+              <a:t>□ 값의 단위와 방향을 한 문장으로 설명할 수 있다.</a:t>
+            </a:r>
+          </a:p>
+        </p:txBody>
+      </p:sp>
+      <p:sp>
+        <p:nvSpPr>
+          <p:cNvPr id="9" name="TextBox 8"/>
           <p:cNvSpPr txBox="1"/>
           <p:nvPr/>
         </p:nvSpPr>
         <p:spPr>
           <a:xfrm>
-            <a:off x="896112" y="3319272"/>
-            <a:ext cx="2926080" cy="274320"/>
+            <a:off x="731520" y="5989320"/>
+            <a:ext cx="10789920" cy="237744"/>
           </a:xfrm>
           <a:prstGeom prst="rect">
             <a:avLst/>
@@ -6719,46 +6825,7 @@
               <a:spcAft>
                 <a:spcPts val="0"/>
               </a:spcAft>
-              <a:defRPr sz="1800" b="1">
-                <a:solidFill>
-                  <a:srgbClr val="BE3B3B"/>
-                </a:solidFill>
-                <a:latin typeface="Noto Sans CJK KR"/>
-              </a:defRPr>
-            </a:pPr>
-            <a:r>
-              <a:t>증상 2: echo가 출력되지 않음</a:t>
-            </a:r>
-          </a:p>
-        </p:txBody>
-      </p:sp>
-      <p:sp>
-        <p:nvSpPr>
-          <p:cNvPr id="12" name="TextBox 11"/>
-          <p:cNvSpPr txBox="1"/>
-          <p:nvPr/>
-        </p:nvSpPr>
-        <p:spPr>
-          <a:xfrm>
-            <a:off x="3794760" y="3300984"/>
-            <a:ext cx="7543800" cy="621792"/>
-          </a:xfrm>
-          <a:prstGeom prst="rect">
-            <a:avLst/>
-          </a:prstGeom>
-          <a:noFill/>
-        </p:spPr>
-        <p:txBody>
-          <a:bodyPr wrap="square" lIns="73152" rIns="73152" tIns="36576" bIns="36576">
-            <a:spAutoFit/>
-          </a:bodyPr>
-          <a:lstStyle/>
-          <a:p>
-            <a:pPr algn="l">
-              <a:spcAft>
-                <a:spcPts val="0"/>
-              </a:spcAft>
-              <a:defRPr sz="1600" b="0">
+              <a:defRPr sz="1500" b="1">
                 <a:solidFill>
                   <a:srgbClr val="122C4E"/>
                 </a:solidFill>
@@ -6766,50 +6833,7 @@
               </a:defRPr>
             </a:pPr>
             <a:r>
-              <a:t>우선 확인: talker 실행·/chatter 이름·publisher 수를 순서대로 확인한다.</a:t>
-            </a:r>
-            <a:br/>
-            <a:r>
-              <a:t>수정 후: ros2 node list</a:t>
-            </a:r>
-          </a:p>
-        </p:txBody>
-      </p:sp>
-      <p:sp>
-        <p:nvSpPr>
-          <p:cNvPr id="13" name="TextBox 12"/>
-          <p:cNvSpPr txBox="1"/>
-          <p:nvPr/>
-        </p:nvSpPr>
-        <p:spPr>
-          <a:xfrm>
-            <a:off x="822960" y="5102352"/>
-            <a:ext cx="10607040" cy="402336"/>
-          </a:xfrm>
-          <a:prstGeom prst="rect">
-            <a:avLst/>
-          </a:prstGeom>
-          <a:noFill/>
-        </p:spPr>
-        <p:txBody>
-          <a:bodyPr wrap="square" lIns="73152" rIns="73152" tIns="36576" bIns="36576">
-            <a:spAutoFit/>
-          </a:bodyPr>
-          <a:lstStyle/>
-          <a:p>
-            <a:pPr algn="ctr">
-              <a:spcAft>
-                <a:spcPts val="0"/>
-              </a:spcAft>
-              <a:defRPr sz="1800" b="1">
-                <a:solidFill>
-                  <a:srgbClr val="DB7E22"/>
-                </a:solidFill>
-                <a:latin typeface="Noto Sans CJK KR"/>
-              </a:defRPr>
-            </a:pPr>
-            <a:r>
-              <a:t>공통 순서: ① 현재 폴더 ② source ③ 파일 경로 ④ 이름/타입/단위 ⑤ build·source 후 재실행</a:t>
+              <a:t>완료 조건: talker/listener와 node·topic·echo·info 명령으로 연결을 확인한다.</a:t>
             </a:r>
           </a:p>
         </p:txBody>
@@ -6866,7 +6890,7 @@
               </a:defRPr>
             </a:pPr>
             <a:r>
-              <a:t>미니 실습: 값 하나를 바꾸고 결과를 비교한다</a:t>
+              <a:t>막히면: 증상 → 우선 확인 → 재검증</a:t>
             </a:r>
           </a:p>
         </p:txBody>
@@ -6905,7 +6929,7 @@
               </a:defRPr>
             </a:pPr>
             <a:r>
-              <a:t>정상 결과를 만든 뒤에는 한 번에 하나의 값만 바꿉니다.</a:t>
+              <a:t>오류 메시지를 숨기지 않고 같은 순서로 점검합니다.</a:t>
             </a:r>
           </a:p>
         </p:txBody>
@@ -7041,7 +7065,7 @@
               </a:defRPr>
             </a:pPr>
             <a:r>
-              <a:t>현재 단계 미니 실습    |    현재 폴더 ~/ros2_curri/agv_ws    |    현재 터미널</a:t>
+              <a:t>현재 단계 오류 대응    |    현재 폴더 ~/ros2_curri/my_agv_ws    |    현재 터미널</a:t>
             </a:r>
           </a:p>
         </p:txBody>
@@ -7054,18 +7078,18 @@
         </p:nvSpPr>
         <p:spPr>
           <a:xfrm>
-            <a:off x="749808" y="1874519"/>
-            <a:ext cx="10652760" cy="1993392"/>
+            <a:off x="694944" y="1755648"/>
+            <a:ext cx="10972800" cy="1115568"/>
           </a:xfrm>
           <a:prstGeom prst="roundRect">
             <a:avLst/>
           </a:prstGeom>
           <a:solidFill>
-            <a:srgbClr val="FFF8EB"/>
+            <a:srgbClr val="FFF7F4"/>
           </a:solidFill>
           <a:ln>
             <a:solidFill>
-              <a:srgbClr val="ECC680"/>
+              <a:srgbClr val="EDBEB4"/>
             </a:solidFill>
           </a:ln>
         </p:spPr>
@@ -7084,23 +7108,10 @@
           </a:fontRef>
         </p:style>
         <p:txBody>
-          <a:bodyPr rtlCol="0" anchor="ctr" wrap="square" lIns="73152" rIns="73152" tIns="36576" bIns="36576"/>
-          <a:lstStyle/>
-          <a:p>
-            <a:pPr algn="ctr">
-              <a:spcAft>
-                <a:spcPts val="0"/>
-              </a:spcAft>
-              <a:defRPr sz="2300" b="1">
-                <a:solidFill>
-                  <a:srgbClr val="122C4E"/>
-                </a:solidFill>
-                <a:latin typeface="Noto Sans CJK KR"/>
-              </a:defRPr>
-            </a:pPr>
-            <a:r>
-              <a:t>listener를 Ctrl-C로 멈춘 뒤 topic info의 subscriber 수가 어떻게 바뀌는지 확인한다.</a:t>
-            </a:r>
+          <a:bodyPr rtlCol="0" anchor="ctr"/>
+          <a:lstStyle/>
+          <a:p>
+            <a:pPr algn="ctr"/>
           </a:p>
         </p:txBody>
       </p:sp>
@@ -7112,8 +7123,8 @@
         </p:nvSpPr>
         <p:spPr>
           <a:xfrm>
-            <a:off x="877824" y="4590288"/>
-            <a:ext cx="10241280" cy="594360"/>
+            <a:off x="896112" y="1901952"/>
+            <a:ext cx="2926080" cy="274320"/>
           </a:xfrm>
           <a:prstGeom prst="rect">
             <a:avLst/>
@@ -7126,11 +7137,220 @@
           </a:bodyPr>
           <a:lstStyle/>
           <a:p>
+            <a:pPr algn="l">
+              <a:spcAft>
+                <a:spcPts val="0"/>
+              </a:spcAft>
+              <a:defRPr sz="1800" b="1">
+                <a:solidFill>
+                  <a:srgbClr val="BE3B3B"/>
+                </a:solidFill>
+                <a:latin typeface="Noto Sans CJK KR"/>
+              </a:defRPr>
+            </a:pPr>
+            <a:r>
+              <a:t>증상 1: ros2: command not found</a:t>
+            </a:r>
+          </a:p>
+        </p:txBody>
+      </p:sp>
+      <p:sp>
+        <p:nvSpPr>
+          <p:cNvPr id="9" name="TextBox 8"/>
+          <p:cNvSpPr txBox="1"/>
+          <p:nvPr/>
+        </p:nvSpPr>
+        <p:spPr>
+          <a:xfrm>
+            <a:off x="3794760" y="1883664"/>
+            <a:ext cx="7543800" cy="621792"/>
+          </a:xfrm>
+          <a:prstGeom prst="rect">
+            <a:avLst/>
+          </a:prstGeom>
+          <a:noFill/>
+        </p:spPr>
+        <p:txBody>
+          <a:bodyPr wrap="square" lIns="73152" rIns="73152" tIns="36576" bIns="36576">
+            <a:spAutoFit/>
+          </a:bodyPr>
+          <a:lstStyle/>
+          <a:p>
+            <a:pPr algn="l">
+              <a:spcAft>
+                <a:spcPts val="0"/>
+              </a:spcAft>
+              <a:defRPr sz="1600" b="0">
+                <a:solidFill>
+                  <a:srgbClr val="122C4E"/>
+                </a:solidFill>
+                <a:latin typeface="Noto Sans CJK KR"/>
+              </a:defRPr>
+            </a:pPr>
+            <a:r>
+              <a:t>우선 확인: source /opt/ros/jazzy/setup.bash를 실행한다.</a:t>
+            </a:r>
+            <a:br/>
+            <a:r>
+              <a:t>수정 후: ros2 node list</a:t>
+            </a:r>
+          </a:p>
+        </p:txBody>
+      </p:sp>
+      <p:sp>
+        <p:nvSpPr>
+          <p:cNvPr id="10" name="Rounded Rectangle 9"/>
+          <p:cNvSpPr/>
+          <p:nvPr/>
+        </p:nvSpPr>
+        <p:spPr>
+          <a:xfrm>
+            <a:off x="694944" y="3172968"/>
+            <a:ext cx="10972800" cy="1115568"/>
+          </a:xfrm>
+          <a:prstGeom prst="roundRect">
+            <a:avLst/>
+          </a:prstGeom>
+          <a:solidFill>
+            <a:srgbClr val="FFF7F4"/>
+          </a:solidFill>
+          <a:ln>
+            <a:solidFill>
+              <a:srgbClr val="EDBEB4"/>
+            </a:solidFill>
+          </a:ln>
+        </p:spPr>
+        <p:style>
+          <a:lnRef idx="1">
+            <a:schemeClr val="accent1"/>
+          </a:lnRef>
+          <a:fillRef idx="3">
+            <a:schemeClr val="accent1"/>
+          </a:fillRef>
+          <a:effectRef idx="2">
+            <a:schemeClr val="accent1"/>
+          </a:effectRef>
+          <a:fontRef idx="minor">
+            <a:schemeClr val="lt1"/>
+          </a:fontRef>
+        </p:style>
+        <p:txBody>
+          <a:bodyPr rtlCol="0" anchor="ctr"/>
+          <a:lstStyle/>
+          <a:p>
+            <a:pPr algn="ctr"/>
+          </a:p>
+        </p:txBody>
+      </p:sp>
+      <p:sp>
+        <p:nvSpPr>
+          <p:cNvPr id="11" name="TextBox 10"/>
+          <p:cNvSpPr txBox="1"/>
+          <p:nvPr/>
+        </p:nvSpPr>
+        <p:spPr>
+          <a:xfrm>
+            <a:off x="896112" y="3319272"/>
+            <a:ext cx="2926080" cy="274320"/>
+          </a:xfrm>
+          <a:prstGeom prst="rect">
+            <a:avLst/>
+          </a:prstGeom>
+          <a:noFill/>
+        </p:spPr>
+        <p:txBody>
+          <a:bodyPr wrap="square" lIns="73152" rIns="73152" tIns="36576" bIns="36576">
+            <a:spAutoFit/>
+          </a:bodyPr>
+          <a:lstStyle/>
+          <a:p>
+            <a:pPr algn="l">
+              <a:spcAft>
+                <a:spcPts val="0"/>
+              </a:spcAft>
+              <a:defRPr sz="1800" b="1">
+                <a:solidFill>
+                  <a:srgbClr val="BE3B3B"/>
+                </a:solidFill>
+                <a:latin typeface="Noto Sans CJK KR"/>
+              </a:defRPr>
+            </a:pPr>
+            <a:r>
+              <a:t>증상 2: echo가 출력되지 않음</a:t>
+            </a:r>
+          </a:p>
+        </p:txBody>
+      </p:sp>
+      <p:sp>
+        <p:nvSpPr>
+          <p:cNvPr id="12" name="TextBox 11"/>
+          <p:cNvSpPr txBox="1"/>
+          <p:nvPr/>
+        </p:nvSpPr>
+        <p:spPr>
+          <a:xfrm>
+            <a:off x="3794760" y="3300984"/>
+            <a:ext cx="7543800" cy="621792"/>
+          </a:xfrm>
+          <a:prstGeom prst="rect">
+            <a:avLst/>
+          </a:prstGeom>
+          <a:noFill/>
+        </p:spPr>
+        <p:txBody>
+          <a:bodyPr wrap="square" lIns="73152" rIns="73152" tIns="36576" bIns="36576">
+            <a:spAutoFit/>
+          </a:bodyPr>
+          <a:lstStyle/>
+          <a:p>
+            <a:pPr algn="l">
+              <a:spcAft>
+                <a:spcPts val="0"/>
+              </a:spcAft>
+              <a:defRPr sz="1600" b="0">
+                <a:solidFill>
+                  <a:srgbClr val="122C4E"/>
+                </a:solidFill>
+                <a:latin typeface="Noto Sans CJK KR"/>
+              </a:defRPr>
+            </a:pPr>
+            <a:r>
+              <a:t>우선 확인: talker 실행·/chatter 이름·publisher 수를 순서대로 확인한다.</a:t>
+            </a:r>
+            <a:br/>
+            <a:r>
+              <a:t>수정 후: ros2 node list</a:t>
+            </a:r>
+          </a:p>
+        </p:txBody>
+      </p:sp>
+      <p:sp>
+        <p:nvSpPr>
+          <p:cNvPr id="13" name="TextBox 12"/>
+          <p:cNvSpPr txBox="1"/>
+          <p:nvPr/>
+        </p:nvSpPr>
+        <p:spPr>
+          <a:xfrm>
+            <a:off x="822960" y="5102352"/>
+            <a:ext cx="10607040" cy="402336"/>
+          </a:xfrm>
+          <a:prstGeom prst="rect">
+            <a:avLst/>
+          </a:prstGeom>
+          <a:noFill/>
+        </p:spPr>
+        <p:txBody>
+          <a:bodyPr wrap="square" lIns="73152" rIns="73152" tIns="36576" bIns="36576">
+            <a:spAutoFit/>
+          </a:bodyPr>
+          <a:lstStyle/>
+          <a:p>
             <a:pPr algn="ctr">
               <a:spcAft>
                 <a:spcPts val="0"/>
               </a:spcAft>
-              <a:defRPr sz="1900" b="1">
+              <a:defRPr sz="1800" b="1">
                 <a:solidFill>
                   <a:srgbClr val="DB7E22"/>
                 </a:solidFill>
@@ -7138,7 +7358,7 @@
               </a:defRPr>
             </a:pPr>
             <a:r>
-              <a:t>기록할 것: 바꾼 값(단위) · 기대한 변화 · 실제 출력/화면 · 원래 값으로 되돌린 결과</a:t>
+              <a:t>공통 순서: ① 현재 폴더 ② source ③ 파일 경로 ④ 이름/타입/단위 ⑤ build·source 후 재실행</a:t>
             </a:r>
           </a:p>
         </p:txBody>
@@ -7195,7 +7415,7 @@
               </a:defRPr>
             </a:pPr>
             <a:r>
-              <a:t>체크포인트를 저장하고 다음 모듈로 넘긴다</a:t>
+              <a:t>미니 실습: 값 하나를 바꾸고 결과를 비교한다</a:t>
             </a:r>
           </a:p>
         </p:txBody>
@@ -7234,7 +7454,7 @@
               </a:defRPr>
             </a:pPr>
             <a:r>
-              <a:t>현재 Complete는 다음 Starter의 기준선입니다.</a:t>
+              <a:t>정상 결과를 만든 뒤에는 한 번에 하나의 값만 바꿉니다.</a:t>
             </a:r>
           </a:p>
         </p:txBody>
@@ -7370,7 +7590,7 @@
               </a:defRPr>
             </a:pPr>
             <a:r>
-              <a:t>현재 단계 체크포인트    |    현재 폴더 ~/ros2_curri/agv_ws    |    현재 터미널</a:t>
+              <a:t>현재 단계 미니 실습    |    현재 폴더 ~/ros2_curri/my_agv_ws    |    현재 터미널</a:t>
             </a:r>
           </a:p>
         </p:txBody>
@@ -7383,18 +7603,18 @@
         </p:nvSpPr>
         <p:spPr>
           <a:xfrm>
-            <a:off x="685800" y="1737360"/>
-            <a:ext cx="10972800" cy="3611880"/>
+            <a:off x="749808" y="1874519"/>
+            <a:ext cx="10652760" cy="1993392"/>
           </a:xfrm>
           <a:prstGeom prst="roundRect">
             <a:avLst/>
           </a:prstGeom>
           <a:solidFill>
-            <a:srgbClr val="F4F7FB"/>
+            <a:srgbClr val="FFF8EB"/>
           </a:solidFill>
           <a:ln>
             <a:solidFill>
-              <a:srgbClr val="D2DCE8"/>
+              <a:srgbClr val="ECC680"/>
             </a:solidFill>
           </a:ln>
         </p:spPr>
@@ -7413,10 +7633,23 @@
           </a:fontRef>
         </p:style>
         <p:txBody>
-          <a:bodyPr rtlCol="0" anchor="ctr"/>
-          <a:lstStyle/>
-          <a:p>
-            <a:pPr algn="ctr"/>
+          <a:bodyPr rtlCol="0" anchor="ctr" wrap="square" lIns="73152" rIns="73152" tIns="36576" bIns="36576"/>
+          <a:lstStyle/>
+          <a:p>
+            <a:pPr algn="ctr">
+              <a:spcAft>
+                <a:spcPts val="0"/>
+              </a:spcAft>
+              <a:defRPr sz="2300" b="1">
+                <a:solidFill>
+                  <a:srgbClr val="122C4E"/>
+                </a:solidFill>
+                <a:latin typeface="Noto Sans CJK KR"/>
+              </a:defRPr>
+            </a:pPr>
+            <a:r>
+              <a:t>listener를 Ctrl-C로 멈춘 뒤 topic info의 subscriber 수가 어떻게 바뀌는지 확인한다.</a:t>
+            </a:r>
           </a:p>
         </p:txBody>
       </p:sp>
@@ -7428,111 +7661,8 @@
         </p:nvSpPr>
         <p:spPr>
           <a:xfrm>
-            <a:off x="896112" y="1993392"/>
-            <a:ext cx="10332720" cy="2971800"/>
-          </a:xfrm>
-          <a:prstGeom prst="rect">
-            <a:avLst/>
-          </a:prstGeom>
-          <a:noFill/>
-        </p:spPr>
-        <p:txBody>
-          <a:bodyPr wrap="square" lIns="109728" rIns="109728">
-            <a:spAutoFit/>
-          </a:bodyPr>
-          <a:lstStyle/>
-          <a:p>
-            <a:pPr>
-              <a:spcAft>
-                <a:spcPts val="800"/>
-              </a:spcAft>
-              <a:defRPr sz="1800">
-                <a:solidFill>
-                  <a:srgbClr val="122C4E"/>
-                </a:solidFill>
-                <a:latin typeface="Noto Sans CJK KR"/>
-              </a:defRPr>
-            </a:pPr>
-            <a:r>
-              <a:t>• □ 완료 화면: talker/listener와 node·topic·echo·info 명령으로 연결을 확인한다.</a:t>
-            </a:r>
-          </a:p>
-          <a:p>
-            <a:pPr>
-              <a:spcAft>
-                <a:spcPts val="800"/>
-              </a:spcAft>
-              <a:defRPr sz="1800">
-                <a:solidFill>
-                  <a:srgbClr val="122C4E"/>
-                </a:solidFill>
-                <a:latin typeface="Noto Sans CJK KR"/>
-              </a:defRPr>
-            </a:pPr>
-            <a:r>
-              <a:t>• □ Complete 파일: blocks/A_ros2_basics/M01_ros2_concepts/complete/</a:t>
-            </a:r>
-          </a:p>
-          <a:p>
-            <a:pPr>
-              <a:spcAft>
-                <a:spcPts val="800"/>
-              </a:spcAft>
-              <a:defRPr sz="1800">
-                <a:solidFill>
-                  <a:srgbClr val="122C4E"/>
-                </a:solidFill>
-                <a:latin typeface="Noto Sans CJK KR"/>
-              </a:defRPr>
-            </a:pPr>
-            <a:r>
-              <a:t>• □ 정상 로그·캡처: logs/validation.log, screenshots/validation_terminal.png</a:t>
-            </a:r>
-          </a:p>
-          <a:p>
-            <a:pPr>
-              <a:spcAft>
-                <a:spcPts val="800"/>
-              </a:spcAft>
-              <a:defRPr sz="1800">
-                <a:solidFill>
-                  <a:srgbClr val="122C4E"/>
-                </a:solidFill>
-                <a:latin typeface="Noto Sans CJK KR"/>
-              </a:defRPr>
-            </a:pPr>
-            <a:r>
-              <a:t>• □ 버전 식별: CHECKSUM_or_TAG.txt의 SHA-256 manifest</a:t>
-            </a:r>
-          </a:p>
-          <a:p>
-            <a:pPr>
-              <a:spcAft>
-                <a:spcPts val="800"/>
-              </a:spcAft>
-              <a:defRPr sz="1800">
-                <a:solidFill>
-                  <a:srgbClr val="122C4E"/>
-                </a:solidFill>
-                <a:latin typeface="Noto Sans CJK KR"/>
-              </a:defRPr>
-            </a:pPr>
-            <a:r>
-              <a:t>• □ 다음 시작 조건: M02 workspace 생성</a:t>
-            </a:r>
-          </a:p>
-        </p:txBody>
-      </p:sp>
-      <p:sp>
-        <p:nvSpPr>
-          <p:cNvPr id="9" name="TextBox 8"/>
-          <p:cNvSpPr txBox="1"/>
-          <p:nvPr/>
-        </p:nvSpPr>
-        <p:spPr>
-          <a:xfrm>
-            <a:off x="868680" y="5596128"/>
-            <a:ext cx="10515600" cy="338328"/>
+            <a:off x="877824" y="4590288"/>
+            <a:ext cx="10241280" cy="594360"/>
           </a:xfrm>
           <a:prstGeom prst="rect">
             <a:avLst/>
@@ -7549,15 +7679,15 @@
               <a:spcAft>
                 <a:spcPts val="0"/>
               </a:spcAft>
-              <a:defRPr sz="1700" b="1">
-                <a:solidFill>
-                  <a:srgbClr val="2A8B5A"/>
-                </a:solidFill>
-                <a:latin typeface="Noto Sans CJK KR"/>
-              </a:defRPr>
-            </a:pPr>
-            <a:r>
-              <a:t>다음 모듈을 시작하기 전, 이 슬라이드의 Complete와 다음 모듈의 Starter를 비교합니다.</a:t>
+              <a:defRPr sz="1900" b="1">
+                <a:solidFill>
+                  <a:srgbClr val="DB7E22"/>
+                </a:solidFill>
+                <a:latin typeface="Noto Sans CJK KR"/>
+              </a:defRPr>
+            </a:pPr>
+            <a:r>
+              <a:t>기록할 것: 바꾼 값(단위) · 기대한 변화 · 실제 출력/화면 · 원래 값으로 되돌린 결과</a:t>
             </a:r>
           </a:p>
         </p:txBody>
@@ -7614,6 +7744,425 @@
               </a:defRPr>
             </a:pPr>
             <a:r>
+              <a:t>내 프로젝트 체크포인트를 저장하고 다음 모듈로 넘긴다</a:t>
+            </a:r>
+          </a:p>
+        </p:txBody>
+      </p:sp>
+      <p:sp>
+        <p:nvSpPr>
+          <p:cNvPr id="3" name="TextBox 2"/>
+          <p:cNvSpPr txBox="1"/>
+          <p:nvPr/>
+        </p:nvSpPr>
+        <p:spPr>
+          <a:xfrm>
+            <a:off x="603504" y="859536"/>
+            <a:ext cx="10698480" cy="292608"/>
+          </a:xfrm>
+          <a:prstGeom prst="rect">
+            <a:avLst/>
+          </a:prstGeom>
+          <a:noFill/>
+        </p:spPr>
+        <p:txBody>
+          <a:bodyPr wrap="square" lIns="73152" rIns="73152" tIns="36576" bIns="36576">
+            <a:spAutoFit/>
+          </a:bodyPr>
+          <a:lstStyle/>
+          <a:p>
+            <a:pPr algn="l">
+              <a:spcAft>
+                <a:spcPts val="0"/>
+              </a:spcAft>
+              <a:defRPr sz="1700" b="0">
+                <a:solidFill>
+                  <a:srgbClr val="5C6672"/>
+                </a:solidFill>
+                <a:latin typeface="Noto Sans CJK KR"/>
+              </a:defRPr>
+            </a:pPr>
+            <a:r>
+              <a:t>Complete는 복구용 비교 기준이고, 다음 단계는 내가 직접 만든 workspace에서 계속합니다.</a:t>
+            </a:r>
+          </a:p>
+        </p:txBody>
+      </p:sp>
+      <p:sp>
+        <p:nvSpPr>
+          <p:cNvPr id="4" name="TextBox 3"/>
+          <p:cNvSpPr txBox="1"/>
+          <p:nvPr/>
+        </p:nvSpPr>
+        <p:spPr>
+          <a:xfrm>
+            <a:off x="530352" y="6510528"/>
+            <a:ext cx="7772400" cy="201168"/>
+          </a:xfrm>
+          <a:prstGeom prst="rect">
+            <a:avLst/>
+          </a:prstGeom>
+          <a:noFill/>
+        </p:spPr>
+        <p:txBody>
+          <a:bodyPr wrap="square" lIns="73152" rIns="73152" tIns="36576" bIns="36576">
+            <a:spAutoFit/>
+          </a:bodyPr>
+          <a:lstStyle/>
+          <a:p>
+            <a:pPr algn="l">
+              <a:spcAft>
+                <a:spcPts val="0"/>
+              </a:spcAft>
+              <a:defRPr sz="1000" b="0">
+                <a:solidFill>
+                  <a:srgbClr val="5C6672"/>
+                </a:solidFill>
+                <a:latin typeface="Noto Sans CJK KR"/>
+              </a:defRPr>
+            </a:pPr>
+            <a:r>
+              <a:t>ROS 2 Jazzy · Gazebo Harmonic · M01 · 따라 하기형 AGV 실습</a:t>
+            </a:r>
+          </a:p>
+        </p:txBody>
+      </p:sp>
+      <p:sp>
+        <p:nvSpPr>
+          <p:cNvPr id="5" name="TextBox 4"/>
+          <p:cNvSpPr txBox="1"/>
+          <p:nvPr/>
+        </p:nvSpPr>
+        <p:spPr>
+          <a:xfrm>
+            <a:off x="9144000" y="6510528"/>
+            <a:ext cx="2468880" cy="201168"/>
+          </a:xfrm>
+          <a:prstGeom prst="rect">
+            <a:avLst/>
+          </a:prstGeom>
+          <a:noFill/>
+        </p:spPr>
+        <p:txBody>
+          <a:bodyPr wrap="square" lIns="73152" rIns="73152" tIns="36576" bIns="36576">
+            <a:spAutoFit/>
+          </a:bodyPr>
+          <a:lstStyle/>
+          <a:p>
+            <a:pPr algn="r">
+              <a:spcAft>
+                <a:spcPts val="0"/>
+              </a:spcAft>
+              <a:defRPr sz="1000" b="0">
+                <a:solidFill>
+                  <a:srgbClr val="5C6672"/>
+                </a:solidFill>
+                <a:latin typeface="Noto Sans CJK KR"/>
+              </a:defRPr>
+            </a:pPr>
+            <a:r>
+              <a:t>명령·파일 경로는 슬라이드에서 복사 가능</a:t>
+            </a:r>
+          </a:p>
+        </p:txBody>
+      </p:sp>
+      <p:sp>
+        <p:nvSpPr>
+          <p:cNvPr id="6" name="Rectangle 5"/>
+          <p:cNvSpPr/>
+          <p:nvPr/>
+        </p:nvSpPr>
+        <p:spPr>
+          <a:xfrm>
+            <a:off x="566928" y="1188720"/>
+            <a:ext cx="11064240" cy="347472"/>
+          </a:xfrm>
+          <a:prstGeom prst="rect">
+            <a:avLst/>
+          </a:prstGeom>
+          <a:solidFill>
+            <a:srgbClr val="F4F7FB"/>
+          </a:solidFill>
+          <a:ln>
+            <a:solidFill>
+              <a:srgbClr val="F4F7FB"/>
+            </a:solidFill>
+          </a:ln>
+        </p:spPr>
+        <p:style>
+          <a:lnRef idx="1">
+            <a:schemeClr val="accent1"/>
+          </a:lnRef>
+          <a:fillRef idx="3">
+            <a:schemeClr val="accent1"/>
+          </a:fillRef>
+          <a:effectRef idx="2">
+            <a:schemeClr val="accent1"/>
+          </a:effectRef>
+          <a:fontRef idx="minor">
+            <a:schemeClr val="lt1"/>
+          </a:fontRef>
+        </p:style>
+        <p:txBody>
+          <a:bodyPr rtlCol="0" anchor="ctr" wrap="square" lIns="73152" rIns="73152" tIns="36576" bIns="36576"/>
+          <a:lstStyle/>
+          <a:p>
+            <a:pPr algn="l">
+              <a:spcAft>
+                <a:spcPts val="0"/>
+              </a:spcAft>
+              <a:defRPr sz="1300" b="1">
+                <a:solidFill>
+                  <a:srgbClr val="122C4E"/>
+                </a:solidFill>
+                <a:latin typeface="Noto Sans CJK KR"/>
+              </a:defRPr>
+            </a:pPr>
+            <a:r>
+              <a:t>현재 단계 체크포인트    |    현재 폴더 ~/ros2_curri/my_agv_ws    |    현재 터미널</a:t>
+            </a:r>
+          </a:p>
+        </p:txBody>
+      </p:sp>
+      <p:sp>
+        <p:nvSpPr>
+          <p:cNvPr id="7" name="Rounded Rectangle 6"/>
+          <p:cNvSpPr/>
+          <p:nvPr/>
+        </p:nvSpPr>
+        <p:spPr>
+          <a:xfrm>
+            <a:off x="685800" y="1737360"/>
+            <a:ext cx="10972800" cy="3611880"/>
+          </a:xfrm>
+          <a:prstGeom prst="roundRect">
+            <a:avLst/>
+          </a:prstGeom>
+          <a:solidFill>
+            <a:srgbClr val="F4F7FB"/>
+          </a:solidFill>
+          <a:ln>
+            <a:solidFill>
+              <a:srgbClr val="D2DCE8"/>
+            </a:solidFill>
+          </a:ln>
+        </p:spPr>
+        <p:style>
+          <a:lnRef idx="1">
+            <a:schemeClr val="accent1"/>
+          </a:lnRef>
+          <a:fillRef idx="3">
+            <a:schemeClr val="accent1"/>
+          </a:fillRef>
+          <a:effectRef idx="2">
+            <a:schemeClr val="accent1"/>
+          </a:effectRef>
+          <a:fontRef idx="minor">
+            <a:schemeClr val="lt1"/>
+          </a:fontRef>
+        </p:style>
+        <p:txBody>
+          <a:bodyPr rtlCol="0" anchor="ctr"/>
+          <a:lstStyle/>
+          <a:p>
+            <a:pPr algn="ctr"/>
+          </a:p>
+        </p:txBody>
+      </p:sp>
+      <p:sp>
+        <p:nvSpPr>
+          <p:cNvPr id="8" name="TextBox 7"/>
+          <p:cNvSpPr txBox="1"/>
+          <p:nvPr/>
+        </p:nvSpPr>
+        <p:spPr>
+          <a:xfrm>
+            <a:off x="896112" y="1993392"/>
+            <a:ext cx="10332720" cy="2971800"/>
+          </a:xfrm>
+          <a:prstGeom prst="rect">
+            <a:avLst/>
+          </a:prstGeom>
+          <a:noFill/>
+        </p:spPr>
+        <p:txBody>
+          <a:bodyPr wrap="square" lIns="109728" rIns="109728">
+            <a:spAutoFit/>
+          </a:bodyPr>
+          <a:lstStyle/>
+          <a:p>
+            <a:pPr>
+              <a:spcAft>
+                <a:spcPts val="800"/>
+              </a:spcAft>
+              <a:defRPr sz="1800">
+                <a:solidFill>
+                  <a:srgbClr val="122C4E"/>
+                </a:solidFill>
+                <a:latin typeface="Noto Sans CJK KR"/>
+              </a:defRPr>
+            </a:pPr>
+            <a:r>
+              <a:t>• □ 완료 화면: talker/listener와 node·topic·echo·info 명령으로 연결을 확인한다.</a:t>
+            </a:r>
+          </a:p>
+          <a:p>
+            <a:pPr>
+              <a:spcAft>
+                <a:spcPts val="800"/>
+              </a:spcAft>
+              <a:defRPr sz="1800">
+                <a:solidFill>
+                  <a:srgbClr val="122C4E"/>
+                </a:solidFill>
+                <a:latin typeface="Noto Sans CJK KR"/>
+              </a:defRPr>
+            </a:pPr>
+            <a:r>
+              <a:t>• □ 막혔을 때 비교할 Complete: blocks/A_ros2_basics/M01_ros2_concepts/complete/</a:t>
+            </a:r>
+          </a:p>
+          <a:p>
+            <a:pPr>
+              <a:spcAft>
+                <a:spcPts val="800"/>
+              </a:spcAft>
+              <a:defRPr sz="1800">
+                <a:solidFill>
+                  <a:srgbClr val="122C4E"/>
+                </a:solidFill>
+                <a:latin typeface="Noto Sans CJK KR"/>
+              </a:defRPr>
+            </a:pPr>
+            <a:r>
+              <a:t>• □ 정상 로그·캡처: logs/validation.log, screenshots/validation_terminal.png</a:t>
+            </a:r>
+          </a:p>
+          <a:p>
+            <a:pPr>
+              <a:spcAft>
+                <a:spcPts val="800"/>
+              </a:spcAft>
+              <a:defRPr sz="1800">
+                <a:solidFill>
+                  <a:srgbClr val="122C4E"/>
+                </a:solidFill>
+                <a:latin typeface="Noto Sans CJK KR"/>
+              </a:defRPr>
+            </a:pPr>
+            <a:r>
+              <a:t>• □ 버전 식별: CHECKSUM_or_TAG.txt의 SHA-256 manifest</a:t>
+            </a:r>
+          </a:p>
+          <a:p>
+            <a:pPr>
+              <a:spcAft>
+                <a:spcPts val="800"/>
+              </a:spcAft>
+              <a:defRPr sz="1800">
+                <a:solidFill>
+                  <a:srgbClr val="122C4E"/>
+                </a:solidFill>
+                <a:latin typeface="Noto Sans CJK KR"/>
+              </a:defRPr>
+            </a:pPr>
+            <a:r>
+              <a:t>• □ 다음 시작 조건: M02 workspace 생성</a:t>
+            </a:r>
+          </a:p>
+        </p:txBody>
+      </p:sp>
+      <p:sp>
+        <p:nvSpPr>
+          <p:cNvPr id="9" name="TextBox 8"/>
+          <p:cNvSpPr txBox="1"/>
+          <p:nvPr/>
+        </p:nvSpPr>
+        <p:spPr>
+          <a:xfrm>
+            <a:off x="868680" y="5596128"/>
+            <a:ext cx="10515600" cy="338328"/>
+          </a:xfrm>
+          <a:prstGeom prst="rect">
+            <a:avLst/>
+          </a:prstGeom>
+          <a:noFill/>
+        </p:spPr>
+        <p:txBody>
+          <a:bodyPr wrap="square" lIns="73152" rIns="73152" tIns="36576" bIns="36576">
+            <a:spAutoFit/>
+          </a:bodyPr>
+          <a:lstStyle/>
+          <a:p>
+            <a:pPr algn="ctr">
+              <a:spcAft>
+                <a:spcPts val="0"/>
+              </a:spcAft>
+              <a:defRPr sz="1700" b="1">
+                <a:solidFill>
+                  <a:srgbClr val="2A8B5A"/>
+                </a:solidFill>
+                <a:latin typeface="Noto Sans CJK KR"/>
+              </a:defRPr>
+            </a:pPr>
+            <a:r>
+              <a:t>다음 모듈을 시작하기 전, 내 src의 변경사항을 저장하고 현재 완료 조건을 다시 확인합니다.</a:t>
+            </a:r>
+          </a:p>
+        </p:txBody>
+      </p:sp>
+    </p:spTree>
+  </p:cSld>
+  <p:clrMapOvr>
+    <a:masterClrMapping/>
+  </p:clrMapOvr>
+</p:sld>
+</file>
+
+<file path=ppt/slides/slide17.xml><?xml version="1.0" encoding="utf-8"?>
+<p:sld xmlns:a="http://schemas.openxmlformats.org/drawingml/2006/main" xmlns:p="http://schemas.openxmlformats.org/presentationml/2006/main" xmlns:r="http://schemas.openxmlformats.org/officeDocument/2006/relationships">
+  <p:cSld>
+    <p:spTree>
+      <p:nvGrpSpPr>
+        <p:cNvPr id="1" name=""/>
+        <p:cNvGrpSpPr/>
+        <p:nvPr/>
+      </p:nvGrpSpPr>
+      <p:grpSpPr/>
+      <p:sp>
+        <p:nvSpPr>
+          <p:cNvPr id="2" name="TextBox 1"/>
+          <p:cNvSpPr txBox="1"/>
+          <p:nvPr/>
+        </p:nvSpPr>
+        <p:spPr>
+          <a:xfrm>
+            <a:off x="566928" y="347472"/>
+            <a:ext cx="10881360" cy="438912"/>
+          </a:xfrm>
+          <a:prstGeom prst="rect">
+            <a:avLst/>
+          </a:prstGeom>
+          <a:noFill/>
+        </p:spPr>
+        <p:txBody>
+          <a:bodyPr wrap="square" lIns="73152" rIns="73152" tIns="36576" bIns="36576">
+            <a:spAutoFit/>
+          </a:bodyPr>
+          <a:lstStyle/>
+          <a:p>
+            <a:pPr algn="l">
+              <a:spcAft>
+                <a:spcPts val="0"/>
+              </a:spcAft>
+              <a:defRPr sz="3200" b="1">
+                <a:solidFill>
+                  <a:srgbClr val="122C4E"/>
+                </a:solidFill>
+                <a:latin typeface="Noto Sans CJK KR"/>
+              </a:defRPr>
+            </a:pPr>
+            <a:r>
               <a:t>공식 참고 자료</a:t>
             </a:r>
           </a:p>
@@ -8781,7 +9330,7 @@
               </a:defRPr>
             </a:pPr>
             <a:r>
-              <a:t>현재 단계 시작    |    현재 폴더 ~/ros2_curri/agv_ws    |    현재 터미널</a:t>
+              <a:t>현재 단계 시작    |    현재 폴더 ~/ros2_curri    |    현재 터미널</a:t>
             </a:r>
           </a:p>
         </p:txBody>
@@ -8897,7 +9446,7 @@
               </a:defRPr>
             </a:pPr>
             <a:r>
-              <a:t>• 현재 폴더: ~/ros2_curri/agv_ws</a:t>
+              <a:t>• 현재 폴더: ~/ros2_curri</a:t>
             </a:r>
           </a:p>
           <a:p>
@@ -8913,7 +9462,7 @@
               </a:defRPr>
             </a:pPr>
             <a:r>
-              <a:t>• 새 터미널마다: source /opt/ros/jazzy/setup.bash → source install/setup.bash</a:t>
+              <a:t>• 이번에는 아직 내 workspace가 없으므로: source /opt/ros/jazzy/setup.bash</a:t>
             </a:r>
           </a:p>
           <a:p>
@@ -8968,7 +9517,7 @@
               </a:defRPr>
             </a:pPr>
             <a:r>
-              <a:t>확인: pwd가 ~/ros2_curri/agv_ws이고, 이전 모듈의 완료 조건을 한 문장으로 설명할 수 있으면 시작합니다.</a:t>
+              <a:t>확인: M02에서 my_agv_ws를 처음 만들기 전까지는 ~/ros2_curri에 있는 것이 정상입니다.</a:t>
             </a:r>
           </a:p>
         </p:txBody>
@@ -9358,7 +9907,7 @@
               </a:defRPr>
             </a:pPr>
             <a:r>
-              <a:t>핵심 흐름을 한 장으로 이해하기</a:t>
+              <a:t>프로젝트에 이번 기능을 직접 추가한다</a:t>
             </a:r>
           </a:p>
         </p:txBody>
@@ -9397,7 +9946,7 @@
               </a:defRPr>
             </a:pPr>
             <a:r>
-              <a:t>상자와 화살표의 방향을 따라 데이터 또는 제어의 흐름을 읽습니다.</a:t>
+              <a:t>완성본을 먼저 복사하지 않습니다. 빈 workspace에 지금 필요한 폴더와 파일을 하나씩 만듭니다.</a:t>
             </a:r>
           </a:p>
         </p:txBody>
@@ -9482,24 +10031,24 @@
       </p:sp>
       <p:sp>
         <p:nvSpPr>
-          <p:cNvPr id="6" name="Rounded Rectangle 5"/>
+          <p:cNvPr id="6" name="Rectangle 5"/>
           <p:cNvSpPr/>
           <p:nvPr/>
         </p:nvSpPr>
         <p:spPr>
           <a:xfrm>
-            <a:off x="2738628" y="2743200"/>
-            <a:ext cx="2029968" cy="1051560"/>
-          </a:xfrm>
-          <a:prstGeom prst="roundRect">
+            <a:off x="566928" y="1188720"/>
+            <a:ext cx="11064240" cy="347472"/>
+          </a:xfrm>
+          <a:prstGeom prst="rect">
             <a:avLst/>
           </a:prstGeom>
           <a:solidFill>
-            <a:srgbClr val="FFFFFF"/>
+            <a:srgbClr val="F4F7FB"/>
           </a:solidFill>
           <a:ln>
             <a:solidFill>
-              <a:srgbClr val="225B9B"/>
+              <a:srgbClr val="F4F7FB"/>
             </a:solidFill>
           </a:ln>
         </p:spPr>
@@ -9521,11 +10070,11 @@
           <a:bodyPr rtlCol="0" anchor="ctr" wrap="square" lIns="73152" rIns="73152" tIns="36576" bIns="36576"/>
           <a:lstStyle/>
           <a:p>
-            <a:pPr algn="ctr">
-              <a:spcAft>
-                <a:spcPts val="0"/>
-              </a:spcAft>
-              <a:defRPr sz="1900" b="1">
+            <a:pPr algn="l">
+              <a:spcAft>
+                <a:spcPts val="0"/>
+              </a:spcAft>
+              <a:defRPr sz="1300" b="1">
                 <a:solidFill>
                   <a:srgbClr val="122C4E"/>
                 </a:solidFill>
@@ -9533,70 +10082,31 @@
               </a:defRPr>
             </a:pPr>
             <a:r>
-              <a:t>talker</a:t>
-            </a:r>
-            <a:br/>
-            <a:r>
-              <a:t>Node</a:t>
-            </a:r>
-          </a:p>
-        </p:txBody>
-      </p:sp>
-      <p:cxnSp>
-        <p:nvCxnSpPr>
-          <p:cNvPr id="7" name="Connector 6"/>
-          <p:cNvCxnSpPr/>
-          <p:nvPr/>
-        </p:nvCxnSpPr>
-        <p:spPr>
-          <a:xfrm>
-            <a:off x="4768596" y="3264408"/>
-            <a:ext cx="283463" cy="0"/>
-          </a:xfrm>
-          <a:prstGeom prst="line">
-            <a:avLst/>
-          </a:prstGeom>
-          <a:ln w="31750">
-            <a:solidFill>
-              <a:srgbClr val="225B9B"/>
-            </a:solidFill>
-          </a:ln>
-        </p:spPr>
-        <p:style>
-          <a:lnRef idx="2">
-            <a:schemeClr val="accent1"/>
-          </a:lnRef>
-          <a:fillRef idx="0">
-            <a:schemeClr val="accent1"/>
-          </a:fillRef>
-          <a:effectRef idx="1">
-            <a:schemeClr val="accent1"/>
-          </a:effectRef>
-          <a:fontRef idx="minor">
-            <a:schemeClr val="tx1"/>
-          </a:fontRef>
-        </p:style>
-      </p:cxnSp>
-      <p:sp>
-        <p:nvSpPr>
-          <p:cNvPr id="8" name="Rounded Rectangle 7"/>
+              <a:t>현재 단계 프로젝트 조립    |    현재 폴더 ~/ros2_curri/my_agv_ws    |    현재 터미널</a:t>
+            </a:r>
+          </a:p>
+        </p:txBody>
+      </p:sp>
+      <p:sp>
+        <p:nvSpPr>
+          <p:cNvPr id="7" name="Rounded Rectangle 6"/>
           <p:cNvSpPr/>
           <p:nvPr/>
         </p:nvSpPr>
         <p:spPr>
           <a:xfrm>
-            <a:off x="5079492" y="2743200"/>
-            <a:ext cx="2029968" cy="1051560"/>
+            <a:off x="731520" y="1755648"/>
+            <a:ext cx="10835640" cy="1033271"/>
           </a:xfrm>
           <a:prstGeom prst="roundRect">
             <a:avLst/>
           </a:prstGeom>
           <a:solidFill>
-            <a:srgbClr val="FFFFFF"/>
+            <a:srgbClr val="F4F7FB"/>
           </a:solidFill>
           <a:ln>
             <a:solidFill>
-              <a:srgbClr val="225B9B"/>
+              <a:srgbClr val="5C6672"/>
             </a:solidFill>
           </a:ln>
         </p:spPr>
@@ -9615,14 +10125,79 @@
           </a:fontRef>
         </p:style>
         <p:txBody>
-          <a:bodyPr rtlCol="0" anchor="ctr" wrap="square" lIns="73152" rIns="73152" tIns="36576" bIns="36576"/>
-          <a:lstStyle/>
-          <a:p>
-            <a:pPr algn="ctr">
-              <a:spcAft>
-                <a:spcPts val="0"/>
-              </a:spcAft>
-              <a:defRPr sz="1900" b="1">
+          <a:bodyPr rtlCol="0" anchor="ctr"/>
+          <a:lstStyle/>
+          <a:p>
+            <a:pPr algn="ctr"/>
+          </a:p>
+        </p:txBody>
+      </p:sp>
+      <p:sp>
+        <p:nvSpPr>
+          <p:cNvPr id="8" name="TextBox 7"/>
+          <p:cNvSpPr txBox="1"/>
+          <p:nvPr/>
+        </p:nvSpPr>
+        <p:spPr>
+          <a:xfrm>
+            <a:off x="960120" y="1911095"/>
+            <a:ext cx="1920240" cy="228600"/>
+          </a:xfrm>
+          <a:prstGeom prst="rect">
+            <a:avLst/>
+          </a:prstGeom>
+          <a:noFill/>
+        </p:spPr>
+        <p:txBody>
+          <a:bodyPr wrap="square" lIns="73152" rIns="73152" tIns="36576" bIns="36576">
+            <a:spAutoFit/>
+          </a:bodyPr>
+          <a:lstStyle/>
+          <a:p>
+            <a:pPr algn="l">
+              <a:spcAft>
+                <a:spcPts val="0"/>
+              </a:spcAft>
+              <a:defRPr sz="1700" b="1">
+                <a:solidFill>
+                  <a:srgbClr val="5C6672"/>
+                </a:solidFill>
+                <a:latin typeface="Noto Sans CJK KR"/>
+              </a:defRPr>
+            </a:pPr>
+            <a:r>
+              <a:t>이미 있는 것</a:t>
+            </a:r>
+          </a:p>
+        </p:txBody>
+      </p:sp>
+      <p:sp>
+        <p:nvSpPr>
+          <p:cNvPr id="9" name="TextBox 8"/>
+          <p:cNvSpPr txBox="1"/>
+          <p:nvPr/>
+        </p:nvSpPr>
+        <p:spPr>
+          <a:xfrm>
+            <a:off x="2788920" y="1892807"/>
+            <a:ext cx="8229600" cy="566928"/>
+          </a:xfrm>
+          <a:prstGeom prst="rect">
+            <a:avLst/>
+          </a:prstGeom>
+          <a:noFill/>
+        </p:spPr>
+        <p:txBody>
+          <a:bodyPr wrap="square" lIns="73152" rIns="73152" tIns="36576" bIns="36576">
+            <a:spAutoFit/>
+          </a:bodyPr>
+          <a:lstStyle/>
+          <a:p>
+            <a:pPr algn="l">
+              <a:spcAft>
+                <a:spcPts val="0"/>
+              </a:spcAft>
+              <a:defRPr sz="1700" b="0">
                 <a:solidFill>
                   <a:srgbClr val="122C4E"/>
                 </a:solidFill>
@@ -9630,50 +10205,11 @@
               </a:defRPr>
             </a:pPr>
             <a:r>
-              <a:t>/chatter</a:t>
-            </a:r>
-            <a:br/>
-            <a:r>
-              <a:t>Topic</a:t>
-            </a:r>
-          </a:p>
-        </p:txBody>
-      </p:sp>
-      <p:cxnSp>
-        <p:nvCxnSpPr>
-          <p:cNvPr id="9" name="Connector 8"/>
-          <p:cNvCxnSpPr/>
-          <p:nvPr/>
-        </p:nvCxnSpPr>
-        <p:spPr>
-          <a:xfrm>
-            <a:off x="7109460" y="3264408"/>
-            <a:ext cx="283464" cy="0"/>
-          </a:xfrm>
-          <a:prstGeom prst="line">
-            <a:avLst/>
-          </a:prstGeom>
-          <a:ln w="31750">
-            <a:solidFill>
-              <a:srgbClr val="225B9B"/>
-            </a:solidFill>
-          </a:ln>
-        </p:spPr>
-        <p:style>
-          <a:lnRef idx="2">
-            <a:schemeClr val="accent1"/>
-          </a:lnRef>
-          <a:fillRef idx="0">
-            <a:schemeClr val="accent1"/>
-          </a:fillRef>
-          <a:effectRef idx="1">
-            <a:schemeClr val="accent1"/>
-          </a:effectRef>
-          <a:fontRef idx="minor">
-            <a:schemeClr val="tx1"/>
-          </a:fontRef>
-        </p:style>
-      </p:cxnSp>
+              <a:t>과정 시작</a:t>
+            </a:r>
+          </a:p>
+        </p:txBody>
+      </p:sp>
       <p:sp>
         <p:nvSpPr>
           <p:cNvPr id="10" name="Rounded Rectangle 9"/>
@@ -9682,14 +10218,14 @@
         </p:nvSpPr>
         <p:spPr>
           <a:xfrm>
-            <a:off x="7420356" y="2743200"/>
-            <a:ext cx="2029968" cy="1051560"/>
+            <a:off x="731520" y="3081528"/>
+            <a:ext cx="10835640" cy="1033271"/>
           </a:xfrm>
           <a:prstGeom prst="roundRect">
             <a:avLst/>
           </a:prstGeom>
           <a:solidFill>
-            <a:srgbClr val="FFFFFF"/>
+            <a:srgbClr val="F4F7FB"/>
           </a:solidFill>
           <a:ln>
             <a:solidFill>
@@ -9712,27 +10248,10 @@
           </a:fontRef>
         </p:style>
         <p:txBody>
-          <a:bodyPr rtlCol="0" anchor="ctr" wrap="square" lIns="73152" rIns="73152" tIns="36576" bIns="36576"/>
-          <a:lstStyle/>
-          <a:p>
-            <a:pPr algn="ctr">
-              <a:spcAft>
-                <a:spcPts val="0"/>
-              </a:spcAft>
-              <a:defRPr sz="1900" b="1">
-                <a:solidFill>
-                  <a:srgbClr val="122C4E"/>
-                </a:solidFill>
-                <a:latin typeface="Noto Sans CJK KR"/>
-              </a:defRPr>
-            </a:pPr>
-            <a:r>
-              <a:t>listener</a:t>
-            </a:r>
-            <a:br/>
-            <a:r>
-              <a:t>Node</a:t>
-            </a:r>
+          <a:bodyPr rtlCol="0" anchor="ctr"/>
+          <a:lstStyle/>
+          <a:p>
+            <a:pPr algn="ctr"/>
           </a:p>
         </p:txBody>
       </p:sp>
@@ -9744,8 +10263,8 @@
         </p:nvSpPr>
         <p:spPr>
           <a:xfrm>
-            <a:off x="914400" y="4800600"/>
-            <a:ext cx="10332720" cy="502920"/>
+            <a:off x="960120" y="3236976"/>
+            <a:ext cx="1920240" cy="228600"/>
           </a:xfrm>
           <a:prstGeom prst="rect">
             <a:avLst/>
@@ -9758,19 +10277,220 @@
           </a:bodyPr>
           <a:lstStyle/>
           <a:p>
+            <a:pPr algn="l">
+              <a:spcAft>
+                <a:spcPts val="0"/>
+              </a:spcAft>
+              <a:defRPr sz="1700" b="1">
+                <a:solidFill>
+                  <a:srgbClr val="225B9B"/>
+                </a:solidFill>
+                <a:latin typeface="Noto Sans CJK KR"/>
+              </a:defRPr>
+            </a:pPr>
+            <a:r>
+              <a:t>이번에 직접 만들 것</a:t>
+            </a:r>
+          </a:p>
+        </p:txBody>
+      </p:sp>
+      <p:sp>
+        <p:nvSpPr>
+          <p:cNvPr id="12" name="TextBox 11"/>
+          <p:cNvSpPr txBox="1"/>
+          <p:nvPr/>
+        </p:nvSpPr>
+        <p:spPr>
+          <a:xfrm>
+            <a:off x="2788920" y="3218688"/>
+            <a:ext cx="8229600" cy="566928"/>
+          </a:xfrm>
+          <a:prstGeom prst="rect">
+            <a:avLst/>
+          </a:prstGeom>
+          <a:noFill/>
+        </p:spPr>
+        <p:txBody>
+          <a:bodyPr wrap="square" lIns="73152" rIns="73152" tIns="36576" bIns="36576">
+            <a:spAutoFit/>
+          </a:bodyPr>
+          <a:lstStyle/>
+          <a:p>
+            <a:pPr algn="l">
+              <a:spcAft>
+                <a:spcPts val="0"/>
+              </a:spcAft>
+              <a:defRPr sz="1700" b="0">
+                <a:solidFill>
+                  <a:srgbClr val="122C4E"/>
+                </a:solidFill>
+                <a:latin typeface="Noto Sans CJK KR"/>
+              </a:defRPr>
+            </a:pPr>
+            <a:r>
+              <a:t>여러 ROS 2 노드가 Topic으로 메시지를 주고받는 구조를 직접 관찰한다.</a:t>
+            </a:r>
+          </a:p>
+        </p:txBody>
+      </p:sp>
+      <p:sp>
+        <p:nvSpPr>
+          <p:cNvPr id="13" name="Rounded Rectangle 12"/>
+          <p:cNvSpPr/>
+          <p:nvPr/>
+        </p:nvSpPr>
+        <p:spPr>
+          <a:xfrm>
+            <a:off x="731520" y="4407408"/>
+            <a:ext cx="10835640" cy="1033271"/>
+          </a:xfrm>
+          <a:prstGeom prst="roundRect">
+            <a:avLst/>
+          </a:prstGeom>
+          <a:solidFill>
+            <a:srgbClr val="F4F7FB"/>
+          </a:solidFill>
+          <a:ln>
+            <a:solidFill>
+              <a:srgbClr val="2A8B5A"/>
+            </a:solidFill>
+          </a:ln>
+        </p:spPr>
+        <p:style>
+          <a:lnRef idx="1">
+            <a:schemeClr val="accent1"/>
+          </a:lnRef>
+          <a:fillRef idx="3">
+            <a:schemeClr val="accent1"/>
+          </a:fillRef>
+          <a:effectRef idx="2">
+            <a:schemeClr val="accent1"/>
+          </a:effectRef>
+          <a:fontRef idx="minor">
+            <a:schemeClr val="lt1"/>
+          </a:fontRef>
+        </p:style>
+        <p:txBody>
+          <a:bodyPr rtlCol="0" anchor="ctr"/>
+          <a:lstStyle/>
+          <a:p>
+            <a:pPr algn="ctr"/>
+          </a:p>
+        </p:txBody>
+      </p:sp>
+      <p:sp>
+        <p:nvSpPr>
+          <p:cNvPr id="14" name="TextBox 13"/>
+          <p:cNvSpPr txBox="1"/>
+          <p:nvPr/>
+        </p:nvSpPr>
+        <p:spPr>
+          <a:xfrm>
+            <a:off x="960120" y="4562856"/>
+            <a:ext cx="1920240" cy="228600"/>
+          </a:xfrm>
+          <a:prstGeom prst="rect">
+            <a:avLst/>
+          </a:prstGeom>
+          <a:noFill/>
+        </p:spPr>
+        <p:txBody>
+          <a:bodyPr wrap="square" lIns="73152" rIns="73152" tIns="36576" bIns="36576">
+            <a:spAutoFit/>
+          </a:bodyPr>
+          <a:lstStyle/>
+          <a:p>
+            <a:pPr algn="l">
+              <a:spcAft>
+                <a:spcPts val="0"/>
+              </a:spcAft>
+              <a:defRPr sz="1700" b="1">
+                <a:solidFill>
+                  <a:srgbClr val="2A8B5A"/>
+                </a:solidFill>
+                <a:latin typeface="Noto Sans CJK KR"/>
+              </a:defRPr>
+            </a:pPr>
+            <a:r>
+              <a:t>만들고 나서 확인할 것</a:t>
+            </a:r>
+          </a:p>
+        </p:txBody>
+      </p:sp>
+      <p:sp>
+        <p:nvSpPr>
+          <p:cNvPr id="15" name="TextBox 14"/>
+          <p:cNvSpPr txBox="1"/>
+          <p:nvPr/>
+        </p:nvSpPr>
+        <p:spPr>
+          <a:xfrm>
+            <a:off x="2788920" y="4544568"/>
+            <a:ext cx="8229600" cy="566928"/>
+          </a:xfrm>
+          <a:prstGeom prst="rect">
+            <a:avLst/>
+          </a:prstGeom>
+          <a:noFill/>
+        </p:spPr>
+        <p:txBody>
+          <a:bodyPr wrap="square" lIns="73152" rIns="73152" tIns="36576" bIns="36576">
+            <a:spAutoFit/>
+          </a:bodyPr>
+          <a:lstStyle/>
+          <a:p>
+            <a:pPr algn="l">
+              <a:spcAft>
+                <a:spcPts val="0"/>
+              </a:spcAft>
+              <a:defRPr sz="1700" b="0">
+                <a:solidFill>
+                  <a:srgbClr val="122C4E"/>
+                </a:solidFill>
+                <a:latin typeface="Noto Sans CJK KR"/>
+              </a:defRPr>
+            </a:pPr>
+            <a:r>
+              <a:t>talker/listener와 node·topic·echo·info 명령으로 연결을 확인한다.</a:t>
+            </a:r>
+          </a:p>
+        </p:txBody>
+      </p:sp>
+      <p:sp>
+        <p:nvSpPr>
+          <p:cNvPr id="16" name="TextBox 15"/>
+          <p:cNvSpPr txBox="1"/>
+          <p:nvPr/>
+        </p:nvSpPr>
+        <p:spPr>
+          <a:xfrm>
+            <a:off x="841248" y="5833872"/>
+            <a:ext cx="10561320" cy="365760"/>
+          </a:xfrm>
+          <a:prstGeom prst="rect">
+            <a:avLst/>
+          </a:prstGeom>
+          <a:noFill/>
+        </p:spPr>
+        <p:txBody>
+          <a:bodyPr wrap="square" lIns="73152" rIns="73152" tIns="36576" bIns="36576">
+            <a:spAutoFit/>
+          </a:bodyPr>
+          <a:lstStyle/>
+          <a:p>
             <a:pPr algn="ctr">
               <a:spcAft>
                 <a:spcPts val="0"/>
               </a:spcAft>
-              <a:defRPr sz="2000" b="1">
-                <a:solidFill>
-                  <a:srgbClr val="225B9B"/>
-                </a:solidFill>
-                <a:latin typeface="Noto Sans CJK KR"/>
-              </a:defRPr>
-            </a:pPr>
-            <a:r>
-              <a:t>기억할 한 문장: 앞 단계의 출력이 다음 단계의 입력이 되도록 topic·frame·파일 이름을 끝까지 유지합니다.</a:t>
+              <a:defRPr sz="1500" b="1">
+                <a:solidFill>
+                  <a:srgbClr val="DB7E22"/>
+                </a:solidFill>
+                <a:latin typeface="Noto Sans CJK KR"/>
+              </a:defRPr>
+            </a:pPr>
+            <a:r>
+              <a:t>이번 모듈은 사용자 파일 없이 ROS 2 기본 도구를 실행해 이후 프로젝트에 필요한 동작을 관찰합니다.</a:t>
             </a:r>
           </a:p>
         </p:txBody>
@@ -9827,7 +10547,7 @@
               </a:defRPr>
             </a:pPr>
             <a:r>
-              <a:t>이번 모듈에서 생성·수정하는 파일</a:t>
+              <a:t>핵심 흐름을 한 장으로 이해하기</a:t>
             </a:r>
           </a:p>
         </p:txBody>
@@ -9866,7 +10586,7 @@
               </a:defRPr>
             </a:pPr>
             <a:r>
-              <a:t>파일명과 package 경로를 끝까지 동일하게 사용합니다.</a:t>
+              <a:t>상자와 화살표의 방향을 따라 데이터 또는 제어의 흐름을 읽습니다.</a:t>
             </a:r>
           </a:p>
         </p:txBody>
@@ -9957,18 +10677,18 @@
         </p:nvSpPr>
         <p:spPr>
           <a:xfrm>
-            <a:off x="777240" y="1600200"/>
-            <a:ext cx="10789920" cy="4407408"/>
+            <a:off x="2738628" y="2743200"/>
+            <a:ext cx="2029968" cy="1051560"/>
           </a:xfrm>
           <a:prstGeom prst="roundRect">
             <a:avLst/>
           </a:prstGeom>
           <a:solidFill>
-            <a:srgbClr val="1D232D"/>
+            <a:srgbClr val="FFFFFF"/>
           </a:solidFill>
           <a:ln>
             <a:solidFill>
-              <a:srgbClr val="1D232D"/>
+              <a:srgbClr val="225B9B"/>
             </a:solidFill>
           </a:ln>
         </p:spPr>
@@ -9990,37 +10710,231 @@
           <a:bodyPr rtlCol="0" anchor="ctr" wrap="square" lIns="73152" rIns="73152" tIns="36576" bIns="36576"/>
           <a:lstStyle/>
           <a:p>
-            <a:pPr algn="l">
-              <a:spcAft>
-                <a:spcPts val="0"/>
-              </a:spcAft>
-              <a:defRPr sz="1600" b="0">
-                <a:solidFill>
-                  <a:srgbClr val="FFFFFF"/>
-                </a:solidFill>
-                <a:latin typeface="DejaVu Sans Mono"/>
-              </a:defRPr>
-            </a:pPr>
-            <a:r>
-              <a:t>~/ros2_curri/agv_ws/src/</a:t>
+            <a:pPr algn="ctr">
+              <a:spcAft>
+                <a:spcPts val="0"/>
+              </a:spcAft>
+              <a:defRPr sz="1900" b="1">
+                <a:solidFill>
+                  <a:srgbClr val="122C4E"/>
+                </a:solidFill>
+                <a:latin typeface="Noto Sans CJK KR"/>
+              </a:defRPr>
+            </a:pPr>
+            <a:r>
+              <a:t>talker</a:t>
             </a:r>
             <a:br/>
             <a:r>
-              <a:t>└── (M01은 사용자 파일 없이 ROS 2 내장 demo node를 사용합니다.)</a:t>
-            </a:r>
-          </a:p>
-        </p:txBody>
-      </p:sp>
-      <p:sp>
-        <p:nvSpPr>
-          <p:cNvPr id="7" name="TextBox 6"/>
+              <a:t>Node</a:t>
+            </a:r>
+          </a:p>
+        </p:txBody>
+      </p:sp>
+      <p:cxnSp>
+        <p:nvCxnSpPr>
+          <p:cNvPr id="7" name="Connector 6"/>
+          <p:cNvCxnSpPr/>
+          <p:nvPr/>
+        </p:nvCxnSpPr>
+        <p:spPr>
+          <a:xfrm>
+            <a:off x="4768596" y="3264408"/>
+            <a:ext cx="283463" cy="0"/>
+          </a:xfrm>
+          <a:prstGeom prst="line">
+            <a:avLst/>
+          </a:prstGeom>
+          <a:ln w="31750">
+            <a:solidFill>
+              <a:srgbClr val="225B9B"/>
+            </a:solidFill>
+          </a:ln>
+        </p:spPr>
+        <p:style>
+          <a:lnRef idx="2">
+            <a:schemeClr val="accent1"/>
+          </a:lnRef>
+          <a:fillRef idx="0">
+            <a:schemeClr val="accent1"/>
+          </a:fillRef>
+          <a:effectRef idx="1">
+            <a:schemeClr val="accent1"/>
+          </a:effectRef>
+          <a:fontRef idx="minor">
+            <a:schemeClr val="tx1"/>
+          </a:fontRef>
+        </p:style>
+      </p:cxnSp>
+      <p:sp>
+        <p:nvSpPr>
+          <p:cNvPr id="8" name="Rounded Rectangle 7"/>
+          <p:cNvSpPr/>
+          <p:nvPr/>
+        </p:nvSpPr>
+        <p:spPr>
+          <a:xfrm>
+            <a:off x="5079492" y="2743200"/>
+            <a:ext cx="2029968" cy="1051560"/>
+          </a:xfrm>
+          <a:prstGeom prst="roundRect">
+            <a:avLst/>
+          </a:prstGeom>
+          <a:solidFill>
+            <a:srgbClr val="FFFFFF"/>
+          </a:solidFill>
+          <a:ln>
+            <a:solidFill>
+              <a:srgbClr val="225B9B"/>
+            </a:solidFill>
+          </a:ln>
+        </p:spPr>
+        <p:style>
+          <a:lnRef idx="1">
+            <a:schemeClr val="accent1"/>
+          </a:lnRef>
+          <a:fillRef idx="3">
+            <a:schemeClr val="accent1"/>
+          </a:fillRef>
+          <a:effectRef idx="2">
+            <a:schemeClr val="accent1"/>
+          </a:effectRef>
+          <a:fontRef idx="minor">
+            <a:schemeClr val="lt1"/>
+          </a:fontRef>
+        </p:style>
+        <p:txBody>
+          <a:bodyPr rtlCol="0" anchor="ctr" wrap="square" lIns="73152" rIns="73152" tIns="36576" bIns="36576"/>
+          <a:lstStyle/>
+          <a:p>
+            <a:pPr algn="ctr">
+              <a:spcAft>
+                <a:spcPts val="0"/>
+              </a:spcAft>
+              <a:defRPr sz="1900" b="1">
+                <a:solidFill>
+                  <a:srgbClr val="122C4E"/>
+                </a:solidFill>
+                <a:latin typeface="Noto Sans CJK KR"/>
+              </a:defRPr>
+            </a:pPr>
+            <a:r>
+              <a:t>/chatter</a:t>
+            </a:r>
+            <a:br/>
+            <a:r>
+              <a:t>Topic</a:t>
+            </a:r>
+          </a:p>
+        </p:txBody>
+      </p:sp>
+      <p:cxnSp>
+        <p:nvCxnSpPr>
+          <p:cNvPr id="9" name="Connector 8"/>
+          <p:cNvCxnSpPr/>
+          <p:nvPr/>
+        </p:nvCxnSpPr>
+        <p:spPr>
+          <a:xfrm>
+            <a:off x="7109460" y="3264408"/>
+            <a:ext cx="283464" cy="0"/>
+          </a:xfrm>
+          <a:prstGeom prst="line">
+            <a:avLst/>
+          </a:prstGeom>
+          <a:ln w="31750">
+            <a:solidFill>
+              <a:srgbClr val="225B9B"/>
+            </a:solidFill>
+          </a:ln>
+        </p:spPr>
+        <p:style>
+          <a:lnRef idx="2">
+            <a:schemeClr val="accent1"/>
+          </a:lnRef>
+          <a:fillRef idx="0">
+            <a:schemeClr val="accent1"/>
+          </a:fillRef>
+          <a:effectRef idx="1">
+            <a:schemeClr val="accent1"/>
+          </a:effectRef>
+          <a:fontRef idx="minor">
+            <a:schemeClr val="tx1"/>
+          </a:fontRef>
+        </p:style>
+      </p:cxnSp>
+      <p:sp>
+        <p:nvSpPr>
+          <p:cNvPr id="10" name="Rounded Rectangle 9"/>
+          <p:cNvSpPr/>
+          <p:nvPr/>
+        </p:nvSpPr>
+        <p:spPr>
+          <a:xfrm>
+            <a:off x="7420356" y="2743200"/>
+            <a:ext cx="2029968" cy="1051560"/>
+          </a:xfrm>
+          <a:prstGeom prst="roundRect">
+            <a:avLst/>
+          </a:prstGeom>
+          <a:solidFill>
+            <a:srgbClr val="FFFFFF"/>
+          </a:solidFill>
+          <a:ln>
+            <a:solidFill>
+              <a:srgbClr val="225B9B"/>
+            </a:solidFill>
+          </a:ln>
+        </p:spPr>
+        <p:style>
+          <a:lnRef idx="1">
+            <a:schemeClr val="accent1"/>
+          </a:lnRef>
+          <a:fillRef idx="3">
+            <a:schemeClr val="accent1"/>
+          </a:fillRef>
+          <a:effectRef idx="2">
+            <a:schemeClr val="accent1"/>
+          </a:effectRef>
+          <a:fontRef idx="minor">
+            <a:schemeClr val="lt1"/>
+          </a:fontRef>
+        </p:style>
+        <p:txBody>
+          <a:bodyPr rtlCol="0" anchor="ctr" wrap="square" lIns="73152" rIns="73152" tIns="36576" bIns="36576"/>
+          <a:lstStyle/>
+          <a:p>
+            <a:pPr algn="ctr">
+              <a:spcAft>
+                <a:spcPts val="0"/>
+              </a:spcAft>
+              <a:defRPr sz="1900" b="1">
+                <a:solidFill>
+                  <a:srgbClr val="122C4E"/>
+                </a:solidFill>
+                <a:latin typeface="Noto Sans CJK KR"/>
+              </a:defRPr>
+            </a:pPr>
+            <a:r>
+              <a:t>listener</a:t>
+            </a:r>
+            <a:br/>
+            <a:r>
+              <a:t>Node</a:t>
+            </a:r>
+          </a:p>
+        </p:txBody>
+      </p:sp>
+      <p:sp>
+        <p:nvSpPr>
+          <p:cNvPr id="11" name="TextBox 10"/>
           <p:cNvSpPr txBox="1"/>
           <p:nvPr/>
         </p:nvSpPr>
         <p:spPr>
           <a:xfrm>
-            <a:off x="877824" y="6144768"/>
-            <a:ext cx="10332720" cy="201168"/>
+            <a:off x="914400" y="4800600"/>
+            <a:ext cx="10332720" cy="502920"/>
           </a:xfrm>
           <a:prstGeom prst="rect">
             <a:avLst/>
@@ -10037,15 +10951,15 @@
               <a:spcAft>
                 <a:spcPts val="0"/>
               </a:spcAft>
-              <a:defRPr sz="1100" b="0">
-                <a:solidFill>
-                  <a:srgbClr val="5C6672"/>
-                </a:solidFill>
-                <a:latin typeface="Noto Sans CJK KR"/>
-              </a:defRPr>
-            </a:pPr>
-            <a:r>
-              <a:t>파일 전체 코드는 다음 슬라이드에 이어집니다. 중간 줄을 빼지 않고 끝까지 제공합니다.</a:t>
+              <a:defRPr sz="2000" b="1">
+                <a:solidFill>
+                  <a:srgbClr val="225B9B"/>
+                </a:solidFill>
+                <a:latin typeface="Noto Sans CJK KR"/>
+              </a:defRPr>
+            </a:pPr>
+            <a:r>
+              <a:t>기억할 한 문장: 앞 단계의 출력이 다음 단계의 입력이 되도록 topic·frame·파일 이름을 끝까지 유지합니다.</a:t>
             </a:r>
           </a:p>
         </p:txBody>
@@ -10102,7 +11016,7 @@
               </a:defRPr>
             </a:pPr>
             <a:r>
-              <a:t>ROS 2 환경을 등록한다</a:t>
+              <a:t>이번에 프로젝트 안에 새로 만드는 파일</a:t>
             </a:r>
           </a:p>
         </p:txBody>
@@ -10141,7 +11055,7 @@
               </a:defRPr>
             </a:pPr>
             <a:r>
-              <a:t>한 장에는 한 행동만 수행합니다.</a:t>
+              <a:t>아래 파일은 완성본을 복사하지 않고, 다음 슬라이드에서 폴더·빈 파일부터 직접 만듭니다.</a:t>
             </a:r>
           </a:p>
         </p:txBody>
@@ -10226,24 +11140,24 @@
       </p:sp>
       <p:sp>
         <p:nvSpPr>
-          <p:cNvPr id="6" name="Rectangle 5"/>
+          <p:cNvPr id="6" name="Rounded Rectangle 5"/>
           <p:cNvSpPr/>
           <p:nvPr/>
         </p:nvSpPr>
         <p:spPr>
           <a:xfrm>
-            <a:off x="566928" y="1188720"/>
-            <a:ext cx="11064240" cy="347472"/>
-          </a:xfrm>
-          <a:prstGeom prst="rect">
+            <a:off x="777240" y="1600200"/>
+            <a:ext cx="10789920" cy="4407408"/>
+          </a:xfrm>
+          <a:prstGeom prst="roundRect">
             <a:avLst/>
           </a:prstGeom>
           <a:solidFill>
-            <a:srgbClr val="F4F7FB"/>
+            <a:srgbClr val="1D232D"/>
           </a:solidFill>
           <a:ln>
             <a:solidFill>
-              <a:srgbClr val="F4F7FB"/>
+              <a:srgbClr val="1D232D"/>
             </a:solidFill>
           </a:ln>
         </p:spPr>
@@ -10269,15 +11183,19 @@
               <a:spcAft>
                 <a:spcPts val="0"/>
               </a:spcAft>
-              <a:defRPr sz="1300" b="1">
-                <a:solidFill>
-                  <a:srgbClr val="122C4E"/>
-                </a:solidFill>
-                <a:latin typeface="Noto Sans CJK KR"/>
-              </a:defRPr>
-            </a:pPr>
-            <a:r>
-              <a:t>현재 단계 1/3    |    현재 폴더 ~/ros2_curri/agv_ws    |    현재 터미널</a:t>
+              <a:defRPr sz="1600" b="0">
+                <a:solidFill>
+                  <a:srgbClr val="FFFFFF"/>
+                </a:solidFill>
+                <a:latin typeface="DejaVu Sans Mono"/>
+              </a:defRPr>
+            </a:pPr>
+            <a:r>
+              <a:t>~/ros2_curri/my_agv_ws/src/</a:t>
+            </a:r>
+            <a:br/>
+            <a:r>
+              <a:t>└── (M01은 사용자 파일 없이 ROS 2 내장 demo node를 사용합니다.)</a:t>
             </a:r>
           </a:p>
         </p:txBody>
@@ -10290,8 +11208,8 @@
         </p:nvSpPr>
         <p:spPr>
           <a:xfrm>
-            <a:off x="676656" y="1764792"/>
-            <a:ext cx="1828800" cy="347472"/>
+            <a:off x="877824" y="6144768"/>
+            <a:ext cx="10332720" cy="201168"/>
           </a:xfrm>
           <a:prstGeom prst="rect">
             <a:avLst/>
@@ -10304,198 +11222,19 @@
           </a:bodyPr>
           <a:lstStyle/>
           <a:p>
-            <a:pPr algn="l">
-              <a:spcAft>
-                <a:spcPts val="0"/>
-              </a:spcAft>
-              <a:defRPr sz="1800" b="1">
-                <a:solidFill>
-                  <a:srgbClr val="225B9B"/>
-                </a:solidFill>
-                <a:latin typeface="Noto Sans CJK KR"/>
-              </a:defRPr>
-            </a:pPr>
-            <a:r>
-              <a:t>왜 하는가</a:t>
-            </a:r>
-          </a:p>
-        </p:txBody>
-      </p:sp>
-      <p:sp>
-        <p:nvSpPr>
-          <p:cNvPr id="8" name="TextBox 7"/>
-          <p:cNvSpPr txBox="1"/>
-          <p:nvPr/>
-        </p:nvSpPr>
-        <p:spPr>
-          <a:xfrm>
-            <a:off x="676656" y="2103120"/>
-            <a:ext cx="10789920" cy="512064"/>
-          </a:xfrm>
-          <a:prstGeom prst="rect">
-            <a:avLst/>
-          </a:prstGeom>
-          <a:noFill/>
-        </p:spPr>
-        <p:txBody>
-          <a:bodyPr wrap="square" lIns="73152" rIns="73152" tIns="36576" bIns="36576">
-            <a:spAutoFit/>
-          </a:bodyPr>
-          <a:lstStyle/>
-          <a:p>
-            <a:pPr algn="l">
-              <a:spcAft>
-                <a:spcPts val="0"/>
-              </a:spcAft>
-              <a:defRPr sz="2000" b="0">
-                <a:solidFill>
-                  <a:srgbClr val="122C4E"/>
-                </a:solidFill>
-                <a:latin typeface="Noto Sans CJK KR"/>
-              </a:defRPr>
-            </a:pPr>
-            <a:r>
-              <a:t>새 터미널은 ROS 명령을 아직 모른다.</a:t>
-            </a:r>
-          </a:p>
-        </p:txBody>
-      </p:sp>
-      <p:sp>
-        <p:nvSpPr>
-          <p:cNvPr id="9" name="Rounded Rectangle 8"/>
-          <p:cNvSpPr/>
-          <p:nvPr/>
-        </p:nvSpPr>
-        <p:spPr>
-          <a:xfrm>
-            <a:off x="676656" y="2871216"/>
-            <a:ext cx="10835640" cy="2331720"/>
-          </a:xfrm>
-          <a:prstGeom prst="roundRect">
-            <a:avLst/>
-          </a:prstGeom>
-          <a:solidFill>
-            <a:srgbClr val="1D232D"/>
-          </a:solidFill>
-          <a:ln>
-            <a:solidFill>
-              <a:srgbClr val="1D232D"/>
-            </a:solidFill>
-          </a:ln>
-        </p:spPr>
-        <p:style>
-          <a:lnRef idx="1">
-            <a:schemeClr val="accent1"/>
-          </a:lnRef>
-          <a:fillRef idx="3">
-            <a:schemeClr val="accent1"/>
-          </a:fillRef>
-          <a:effectRef idx="2">
-            <a:schemeClr val="accent1"/>
-          </a:effectRef>
-          <a:fontRef idx="minor">
-            <a:schemeClr val="lt1"/>
-          </a:fontRef>
-        </p:style>
-        <p:txBody>
-          <a:bodyPr rtlCol="0" anchor="ctr" wrap="square" lIns="73152" rIns="73152" tIns="36576" bIns="36576"/>
-          <a:lstStyle/>
-          <a:p>
-            <a:pPr algn="l">
-              <a:spcAft>
-                <a:spcPts val="0"/>
-              </a:spcAft>
-              <a:defRPr sz="1600" b="0">
-                <a:solidFill>
-                  <a:srgbClr val="FFFFFF"/>
-                </a:solidFill>
-                <a:latin typeface="DejaVu Sans Mono"/>
-              </a:defRPr>
-            </a:pPr>
-            <a:r>
-              <a:t>source /opt/ros/jazzy/setup.bash</a:t>
-            </a:r>
-            <a:br/>
-            <a:r>
-              <a:t>ros2 --help | head</a:t>
-            </a:r>
-          </a:p>
-        </p:txBody>
-      </p:sp>
-      <p:sp>
-        <p:nvSpPr>
-          <p:cNvPr id="10" name="TextBox 9"/>
-          <p:cNvSpPr txBox="1"/>
-          <p:nvPr/>
-        </p:nvSpPr>
-        <p:spPr>
-          <a:xfrm>
-            <a:off x="768096" y="5468112"/>
-            <a:ext cx="1143000" cy="256032"/>
-          </a:xfrm>
-          <a:prstGeom prst="rect">
-            <a:avLst/>
-          </a:prstGeom>
-          <a:noFill/>
-        </p:spPr>
-        <p:txBody>
-          <a:bodyPr wrap="square" lIns="73152" rIns="73152" tIns="36576" bIns="36576">
-            <a:spAutoFit/>
-          </a:bodyPr>
-          <a:lstStyle/>
-          <a:p>
-            <a:pPr algn="l">
-              <a:spcAft>
-                <a:spcPts val="0"/>
-              </a:spcAft>
-              <a:defRPr sz="1800" b="1">
-                <a:solidFill>
-                  <a:srgbClr val="2A8B5A"/>
-                </a:solidFill>
-                <a:latin typeface="Noto Sans CJK KR"/>
-              </a:defRPr>
-            </a:pPr>
-            <a:r>
-              <a:t>확인</a:t>
-            </a:r>
-          </a:p>
-        </p:txBody>
-      </p:sp>
-      <p:sp>
-        <p:nvSpPr>
-          <p:cNvPr id="11" name="TextBox 10"/>
-          <p:cNvSpPr txBox="1"/>
-          <p:nvPr/>
-        </p:nvSpPr>
-        <p:spPr>
-          <a:xfrm>
-            <a:off x="768096" y="5742432"/>
-            <a:ext cx="10561320" cy="347472"/>
-          </a:xfrm>
-          <a:prstGeom prst="rect">
-            <a:avLst/>
-          </a:prstGeom>
-          <a:noFill/>
-        </p:spPr>
-        <p:txBody>
-          <a:bodyPr wrap="square" lIns="73152" rIns="73152" tIns="36576" bIns="36576">
-            <a:spAutoFit/>
-          </a:bodyPr>
-          <a:lstStyle/>
-          <a:p>
-            <a:pPr algn="l">
-              <a:spcAft>
-                <a:spcPts val="0"/>
-              </a:spcAft>
-              <a:defRPr sz="1800" b="0">
-                <a:solidFill>
-                  <a:srgbClr val="122C4E"/>
-                </a:solidFill>
-                <a:latin typeface="Noto Sans CJK KR"/>
-              </a:defRPr>
-            </a:pPr>
-            <a:r>
-              <a:t>명령의 출력에서 topic·frame·파일 이름 또는 성공 메시지를 찾으면 이 단계가 완료됩니다.</a:t>
+            <a:pPr algn="ctr">
+              <a:spcAft>
+                <a:spcPts val="0"/>
+              </a:spcAft>
+              <a:defRPr sz="1100" b="0">
+                <a:solidFill>
+                  <a:srgbClr val="5C6672"/>
+                </a:solidFill>
+                <a:latin typeface="Noto Sans CJK KR"/>
+              </a:defRPr>
+            </a:pPr>
+            <a:r>
+              <a:t>파일 하나를 만들고 저장한 뒤에만 다음 파일로 넘어갑니다. Complete는 오류가 풀리지 않을 때만 비교합니다.</a:t>
             </a:r>
           </a:p>
         </p:txBody>
@@ -10552,7 +11291,7 @@
               </a:defRPr>
             </a:pPr>
             <a:r>
-              <a:t>두 노드를 서로 다른 터미널에서 실행한다</a:t>
+              <a:t>구현 뒤 실행 1/3: ROS 2 환경을 등록한다</a:t>
             </a:r>
           </a:p>
         </p:txBody>
@@ -10591,7 +11330,7 @@
               </a:defRPr>
             </a:pPr>
             <a:r>
-              <a:t>한 장에는 한 행동만 수행합니다.</a:t>
+              <a:t>방금 직접 만든 파일을 실행·검사하며 다음 파일로 넘어갈 기준을 만듭니다.</a:t>
             </a:r>
           </a:p>
         </p:txBody>
@@ -10727,7 +11466,7 @@
               </a:defRPr>
             </a:pPr>
             <a:r>
-              <a:t>현재 단계 2/3    |    현재 폴더 ~/ros2_curri/agv_ws    |    새 터미널</a:t>
+              <a:t>현재 단계 실행 1/3    |    현재 폴더 ~/ros2_curri/my_agv_ws    |    현재 터미널</a:t>
             </a:r>
           </a:p>
         </p:txBody>
@@ -10805,7 +11544,7 @@
               </a:defRPr>
             </a:pPr>
             <a:r>
-              <a:t>Publisher와 Subscriber는 동시에 살아 있어야 한다.</a:t>
+              <a:t>새 터미널은 ROS 명령을 아직 모른다.</a:t>
             </a:r>
           </a:p>
         </p:txBody>
@@ -10863,24 +11602,11 @@
               </a:defRPr>
             </a:pPr>
             <a:r>
-              <a:t># 터미널 1</a:t>
+              <a:t>source /opt/ros/jazzy/setup.bash</a:t>
             </a:r>
             <a:br/>
             <a:r>
-              <a:t>ros2 run demo_nodes_cpp talker</a:t>
-            </a:r>
-            <a:br/>
-            <a:br/>
-            <a:r>
-              <a:t># 새 터미널 2</a:t>
-            </a:r>
-            <a:br/>
-            <a:r>
-              <a:t>source /opt/ros/jazzy/setup.bash</a:t>
-            </a:r>
-            <a:br/>
-            <a:r>
-              <a:t>ros2 run demo_nodes_py listener</a:t>
+              <a:t>ros2 --help | head</a:t>
             </a:r>
           </a:p>
         </p:txBody>
@@ -10958,7 +11684,7 @@
               </a:defRPr>
             </a:pPr>
             <a:r>
-              <a:t>명령의 출력에서 topic·frame·파일 이름 또는 성공 메시지를 찾으면 이 단계가 완료됩니다.</a:t>
+              <a:t>출력에서 topic·frame·파일 이름 또는 성공 메시지를 찾고, 맞지 않으면 다음 파일로 가지 않습니다.</a:t>
             </a:r>
           </a:p>
         </p:txBody>
@@ -11015,7 +11741,7 @@
               </a:defRPr>
             </a:pPr>
             <a:r>
-              <a:t>연결을 명령으로 관찰한다</a:t>
+              <a:t>구현 뒤 실행 2/3: 두 노드를 서로 다른 터미널에서 실행한다</a:t>
             </a:r>
           </a:p>
         </p:txBody>
@@ -11054,7 +11780,7 @@
               </a:defRPr>
             </a:pPr>
             <a:r>
-              <a:t>한 장에는 한 행동만 수행합니다.</a:t>
+              <a:t>방금 직접 만든 파일을 실행·검사하며 다음 파일로 넘어갈 기준을 만듭니다.</a:t>
             </a:r>
           </a:p>
         </p:txBody>
@@ -11190,7 +11916,7 @@
               </a:defRPr>
             </a:pPr>
             <a:r>
-              <a:t>현재 단계 3/3    |    현재 폴더 ~/ros2_curri/agv_ws    |    현재 터미널</a:t>
+              <a:t>현재 단계 실행 2/3    |    현재 폴더 ~/ros2_curri/my_agv_ws    |    새 터미널</a:t>
             </a:r>
           </a:p>
         </p:txBody>
@@ -11268,7 +11994,7 @@
               </a:defRPr>
             </a:pPr>
             <a:r>
-              <a:t>코드 밖에서도 이름·타입·연결 수를 확인할 수 있다.</a:t>
+              <a:t>Publisher와 Subscriber는 동시에 살아 있어야 한다.</a:t>
             </a:r>
           </a:p>
         </p:txBody>
@@ -11326,19 +12052,24 @@
               </a:defRPr>
             </a:pPr>
             <a:r>
-              <a:t>ros2 node list</a:t>
+              <a:t># 터미널 1</a:t>
             </a:r>
             <a:br/>
             <a:r>
-              <a:t>ros2 topic list</a:t>
+              <a:t>ros2 run demo_nodes_cpp talker</a:t>
             </a:r>
             <a:br/>
-            <a:r>
-              <a:t>ros2 topic info /chatter</a:t>
-            </a:r>
             <a:br/>
             <a:r>
-              <a:t>ros2 topic echo /chatter --once</a:t>
+              <a:t># 새 터미널 2</a:t>
+            </a:r>
+            <a:br/>
+            <a:r>
+              <a:t>source /opt/ros/jazzy/setup.bash</a:t>
+            </a:r>
+            <a:br/>
+            <a:r>
+              <a:t>ros2 run demo_nodes_py listener</a:t>
             </a:r>
           </a:p>
         </p:txBody>
@@ -11416,7 +12147,7 @@
               </a:defRPr>
             </a:pPr>
             <a:r>
-              <a:t>명령의 출력에서 topic·frame·파일 이름 또는 성공 메시지를 찾으면 이 단계가 완료됩니다.</a:t>
+              <a:t>출력에서 topic·frame·파일 이름 또는 성공 메시지를 찾고, 맞지 않으면 다음 파일로 가지 않습니다.</a:t>
             </a:r>
           </a:p>
         </p:txBody>

</xml_diff>

<commit_message>
Add full end-to-end curriculum deck
</commit_message>
<xml_diff>
--- a/blocks/A_ros2_basics/M01_ros2_concepts/M01_ROS2_기초와_분산_로봇_소프트웨어.pptx
+++ b/blocks/A_ros2_basics/M01_ros2_concepts/M01_ROS2_기초와_분산_로봇_소프트웨어.pptx
@@ -5363,7 +5363,7 @@
               <a:spcAft>
                 <a:spcPts val="0"/>
               </a:spcAft>
-              <a:defRPr sz="1800" b="1">
+              <a:defRPr sz="1400" b="1">
                 <a:solidFill>
                   <a:srgbClr val="FFFFFF"/>
                 </a:solidFill>
@@ -5371,7 +5371,7 @@
               </a:defRPr>
             </a:pPr>
             <a:r>
-              <a:t>M01 · Block A · ROS 2 + Gazebo Sim AGV</a:t>
+              <a:t>ROS 2 기반 AGV End-to-End 개발 커리큘럼 · M01 · Block A</a:t>
             </a:r>
           </a:p>
         </p:txBody>
@@ -5581,7 +5581,7 @@
               <a:spcAft>
                 <a:spcPts val="0"/>
               </a:spcAft>
-              <a:defRPr sz="1000" b="0">
+              <a:defRPr sz="900" b="0">
                 <a:solidFill>
                   <a:srgbClr val="5C6672"/>
                 </a:solidFill>
@@ -5589,7 +5589,7 @@
               </a:defRPr>
             </a:pPr>
             <a:r>
-              <a:t>ROS 2 Jazzy · Gazebo Harmonic · M01 · 따라 하기형 AGV 실습</a:t>
+              <a:t>ROS 2 기반 AGV End-to-End 개발 커리큘럼 · M01 · Block A</a:t>
             </a:r>
           </a:p>
         </p:txBody>
@@ -5755,7 +5755,7 @@
               <a:spcAft>
                 <a:spcPts val="0"/>
               </a:spcAft>
-              <a:defRPr sz="1000" b="0">
+              <a:defRPr sz="900" b="0">
                 <a:solidFill>
                   <a:srgbClr val="5C6672"/>
                 </a:solidFill>
@@ -5763,7 +5763,7 @@
               </a:defRPr>
             </a:pPr>
             <a:r>
-              <a:t>ROS 2 Jazzy · Gazebo Harmonic · M01 · 따라 하기형 AGV 실습</a:t>
+              <a:t>ROS 2 기반 AGV End-to-End 개발 커리큘럼 · M01 · Block A</a:t>
             </a:r>
           </a:p>
         </p:txBody>
@@ -6505,7 +6505,7 @@
               <a:spcAft>
                 <a:spcPts val="0"/>
               </a:spcAft>
-              <a:defRPr sz="1000" b="0">
+              <a:defRPr sz="900" b="0">
                 <a:solidFill>
                   <a:srgbClr val="5C6672"/>
                 </a:solidFill>
@@ -6513,7 +6513,7 @@
               </a:defRPr>
             </a:pPr>
             <a:r>
-              <a:t>ROS 2 Jazzy · Gazebo Harmonic · M01 · 따라 하기형 AGV 실습</a:t>
+              <a:t>ROS 2 기반 AGV End-to-End 개발 커리큘럼 · M01 · Block A</a:t>
             </a:r>
           </a:p>
         </p:txBody>
@@ -6955,7 +6955,7 @@
               <a:spcAft>
                 <a:spcPts val="0"/>
               </a:spcAft>
-              <a:defRPr sz="1000" b="0">
+              <a:defRPr sz="900" b="0">
                 <a:solidFill>
                   <a:srgbClr val="5C6672"/>
                 </a:solidFill>
@@ -6963,7 +6963,7 @@
               </a:defRPr>
             </a:pPr>
             <a:r>
-              <a:t>ROS 2 Jazzy · Gazebo Harmonic · M01 · 따라 하기형 AGV 실습</a:t>
+              <a:t>ROS 2 기반 AGV End-to-End 개발 커리큘럼 · M01 · Block A</a:t>
             </a:r>
           </a:p>
         </p:txBody>
@@ -7418,7 +7418,7 @@
               <a:spcAft>
                 <a:spcPts val="0"/>
               </a:spcAft>
-              <a:defRPr sz="1000" b="0">
+              <a:defRPr sz="900" b="0">
                 <a:solidFill>
                   <a:srgbClr val="5C6672"/>
                 </a:solidFill>
@@ -7426,7 +7426,7 @@
               </a:defRPr>
             </a:pPr>
             <a:r>
-              <a:t>ROS 2 Jazzy · Gazebo Harmonic · M01 · 따라 하기형 AGV 실습</a:t>
+              <a:t>ROS 2 기반 AGV End-to-End 개발 커리큘럼 · M01 · Block A</a:t>
             </a:r>
           </a:p>
         </p:txBody>
@@ -7876,7 +7876,7 @@
               <a:spcAft>
                 <a:spcPts val="0"/>
               </a:spcAft>
-              <a:defRPr sz="1000" b="0">
+              <a:defRPr sz="900" b="0">
                 <a:solidFill>
                   <a:srgbClr val="5C6672"/>
                 </a:solidFill>
@@ -7884,7 +7884,7 @@
               </a:defRPr>
             </a:pPr>
             <a:r>
-              <a:t>ROS 2 Jazzy · Gazebo Harmonic · M01 · 따라 하기형 AGV 실습</a:t>
+              <a:t>ROS 2 기반 AGV End-to-End 개발 커리큘럼 · M01 · Block A</a:t>
             </a:r>
           </a:p>
         </p:txBody>
@@ -8252,7 +8252,7 @@
               <a:spcAft>
                 <a:spcPts val="0"/>
               </a:spcAft>
-              <a:defRPr sz="1000" b="0">
+              <a:defRPr sz="900" b="0">
                 <a:solidFill>
                   <a:srgbClr val="5C6672"/>
                 </a:solidFill>
@@ -8260,7 +8260,7 @@
               </a:defRPr>
             </a:pPr>
             <a:r>
-              <a:t>ROS 2 Jazzy · Gazebo Harmonic · M01 · 따라 하기형 AGV 실습</a:t>
+              <a:t>ROS 2 기반 AGV End-to-End 개발 커리큘럼 · M01 · Block A</a:t>
             </a:r>
           </a:p>
         </p:txBody>
@@ -8489,7 +8489,7 @@
               <a:spcAft>
                 <a:spcPts val="0"/>
               </a:spcAft>
-              <a:defRPr sz="1000" b="0">
+              <a:defRPr sz="900" b="0">
                 <a:solidFill>
                   <a:srgbClr val="5C6672"/>
                 </a:solidFill>
@@ -8497,7 +8497,7 @@
               </a:defRPr>
             </a:pPr>
             <a:r>
-              <a:t>ROS 2 Jazzy · Gazebo Harmonic · M01 · 따라 하기형 AGV 실습</a:t>
+              <a:t>ROS 2 기반 AGV End-to-End 개발 커리큘럼 · M01 · Block A</a:t>
             </a:r>
           </a:p>
         </p:txBody>
@@ -8896,7 +8896,7 @@
               <a:spcAft>
                 <a:spcPts val="0"/>
               </a:spcAft>
-              <a:defRPr sz="1000" b="0">
+              <a:defRPr sz="900" b="0">
                 <a:solidFill>
                   <a:srgbClr val="5C6672"/>
                 </a:solidFill>
@@ -8904,7 +8904,7 @@
               </a:defRPr>
             </a:pPr>
             <a:r>
-              <a:t>ROS 2 Jazzy · Gazebo Harmonic · M01 · 따라 하기형 AGV 실습</a:t>
+              <a:t>ROS 2 기반 AGV End-to-End 개발 커리큘럼 · M01 · Block A</a:t>
             </a:r>
           </a:p>
         </p:txBody>
@@ -9421,7 +9421,7 @@
               <a:spcAft>
                 <a:spcPts val="0"/>
               </a:spcAft>
-              <a:defRPr sz="1000" b="0">
+              <a:defRPr sz="900" b="0">
                 <a:solidFill>
                   <a:srgbClr val="5C6672"/>
                 </a:solidFill>
@@ -9429,7 +9429,7 @@
               </a:defRPr>
             </a:pPr>
             <a:r>
-              <a:t>ROS 2 Jazzy · Gazebo Harmonic · M01 · 따라 하기형 AGV 실습</a:t>
+              <a:t>ROS 2 기반 AGV End-to-End 개발 커리큘럼 · M01 · Block A</a:t>
             </a:r>
           </a:p>
         </p:txBody>
@@ -9750,7 +9750,7 @@
               <a:spcAft>
                 <a:spcPts val="0"/>
               </a:spcAft>
-              <a:defRPr sz="1000" b="0">
+              <a:defRPr sz="900" b="0">
                 <a:solidFill>
                   <a:srgbClr val="5C6672"/>
                 </a:solidFill>
@@ -9758,7 +9758,7 @@
               </a:defRPr>
             </a:pPr>
             <a:r>
-              <a:t>ROS 2 Jazzy · Gazebo Harmonic · M01 · 따라 하기형 AGV 실습</a:t>
+              <a:t>ROS 2 기반 AGV End-to-End 개발 커리큘럼 · M01 · Block A</a:t>
             </a:r>
           </a:p>
         </p:txBody>
@@ -10169,7 +10169,7 @@
               <a:spcAft>
                 <a:spcPts val="0"/>
               </a:spcAft>
-              <a:defRPr sz="1000" b="0">
+              <a:defRPr sz="900" b="0">
                 <a:solidFill>
                   <a:srgbClr val="5C6672"/>
                 </a:solidFill>
@@ -10177,7 +10177,7 @@
               </a:defRPr>
             </a:pPr>
             <a:r>
-              <a:t>ROS 2 Jazzy · Gazebo Harmonic · M01 · 따라 하기형 AGV 실습</a:t>
+              <a:t>ROS 2 기반 AGV End-to-End 개발 커리큘럼 · M01 · Block A</a:t>
             </a:r>
           </a:p>
         </p:txBody>
@@ -10630,7 +10630,7 @@
               <a:spcAft>
                 <a:spcPts val="0"/>
               </a:spcAft>
-              <a:defRPr sz="1000" b="0">
+              <a:defRPr sz="900" b="0">
                 <a:solidFill>
                   <a:srgbClr val="5C6672"/>
                 </a:solidFill>
@@ -10638,7 +10638,7 @@
               </a:defRPr>
             </a:pPr>
             <a:r>
-              <a:t>ROS 2 Jazzy · Gazebo Harmonic · M01 · 따라 하기형 AGV 실습</a:t>
+              <a:t>ROS 2 기반 AGV End-to-End 개발 커리큘럼 · M01 · Block A</a:t>
             </a:r>
           </a:p>
         </p:txBody>
@@ -11161,7 +11161,7 @@
               <a:spcAft>
                 <a:spcPts val="0"/>
               </a:spcAft>
-              <a:defRPr sz="1000" b="0">
+              <a:defRPr sz="900" b="0">
                 <a:solidFill>
                   <a:srgbClr val="5C6672"/>
                 </a:solidFill>
@@ -11169,7 +11169,7 @@
               </a:defRPr>
             </a:pPr>
             <a:r>
-              <a:t>ROS 2 Jazzy · Gazebo Harmonic · M01 · 따라 하기형 AGV 실습</a:t>
+              <a:t>ROS 2 기반 AGV End-to-End 개발 커리큘럼 · M01 · Block A</a:t>
             </a:r>
           </a:p>
         </p:txBody>
@@ -11580,7 +11580,7 @@
               <a:spcAft>
                 <a:spcPts val="0"/>
               </a:spcAft>
-              <a:defRPr sz="1000" b="0">
+              <a:defRPr sz="900" b="0">
                 <a:solidFill>
                   <a:srgbClr val="5C6672"/>
                 </a:solidFill>
@@ -11588,7 +11588,7 @@
               </a:defRPr>
             </a:pPr>
             <a:r>
-              <a:t>ROS 2 Jazzy · Gazebo Harmonic · M01 · 따라 하기형 AGV 실습</a:t>
+              <a:t>ROS 2 기반 AGV End-to-End 개발 커리큘럼 · M01 · Block A</a:t>
             </a:r>
           </a:p>
         </p:txBody>
@@ -11913,7 +11913,7 @@
               <a:spcAft>
                 <a:spcPts val="0"/>
               </a:spcAft>
-              <a:defRPr sz="1000" b="0">
+              <a:defRPr sz="900" b="0">
                 <a:solidFill>
                   <a:srgbClr val="5C6672"/>
                 </a:solidFill>
@@ -11921,7 +11921,7 @@
               </a:defRPr>
             </a:pPr>
             <a:r>
-              <a:t>ROS 2 Jazzy · Gazebo Harmonic · M01 · 따라 하기형 AGV 실습</a:t>
+              <a:t>ROS 2 기반 AGV End-to-End 개발 커리큘럼 · M01 · Block A</a:t>
             </a:r>
           </a:p>
         </p:txBody>
@@ -12553,7 +12553,7 @@
               <a:spcAft>
                 <a:spcPts val="0"/>
               </a:spcAft>
-              <a:defRPr sz="1000" b="0">
+              <a:defRPr sz="900" b="0">
                 <a:solidFill>
                   <a:srgbClr val="5C6672"/>
                 </a:solidFill>
@@ -12561,7 +12561,7 @@
               </a:defRPr>
             </a:pPr>
             <a:r>
-              <a:t>ROS 2 Jazzy · Gazebo Harmonic · M01 · 따라 하기형 AGV 실습</a:t>
+              <a:t>ROS 2 기반 AGV End-to-End 개발 커리큘럼 · M01 · Block A</a:t>
             </a:r>
           </a:p>
         </p:txBody>
@@ -13022,7 +13022,7 @@
               <a:spcAft>
                 <a:spcPts val="0"/>
               </a:spcAft>
-              <a:defRPr sz="1000" b="0">
+              <a:defRPr sz="900" b="0">
                 <a:solidFill>
                   <a:srgbClr val="5C6672"/>
                 </a:solidFill>
@@ -13030,7 +13030,7 @@
               </a:defRPr>
             </a:pPr>
             <a:r>
-              <a:t>ROS 2 Jazzy · Gazebo Harmonic · M01 · 따라 하기형 AGV 실습</a:t>
+              <a:t>ROS 2 기반 AGV End-to-End 개발 커리큘럼 · M01 · Block A</a:t>
             </a:r>
           </a:p>
         </p:txBody>
@@ -13297,7 +13297,7 @@
               <a:spcAft>
                 <a:spcPts val="0"/>
               </a:spcAft>
-              <a:defRPr sz="1000" b="0">
+              <a:defRPr sz="900" b="0">
                 <a:solidFill>
                   <a:srgbClr val="5C6672"/>
                 </a:solidFill>
@@ -13305,7 +13305,7 @@
               </a:defRPr>
             </a:pPr>
             <a:r>
-              <a:t>ROS 2 Jazzy · Gazebo Harmonic · M01 · 따라 하기형 AGV 실습</a:t>
+              <a:t>ROS 2 기반 AGV End-to-End 개발 커리큘럼 · M01 · Block A</a:t>
             </a:r>
           </a:p>
         </p:txBody>
@@ -14047,7 +14047,7 @@
               <a:spcAft>
                 <a:spcPts val="0"/>
               </a:spcAft>
-              <a:defRPr sz="1000" b="0">
+              <a:defRPr sz="900" b="0">
                 <a:solidFill>
                   <a:srgbClr val="5C6672"/>
                 </a:solidFill>
@@ -14055,7 +14055,7 @@
               </a:defRPr>
             </a:pPr>
             <a:r>
-              <a:t>ROS 2 Jazzy · Gazebo Harmonic · M01 · 따라 하기형 AGV 실습</a:t>
+              <a:t>ROS 2 기반 AGV End-to-End 개발 커리큘럼 · M01 · Block A</a:t>
             </a:r>
           </a:p>
         </p:txBody>

</xml_diff>

<commit_message>
Regenerate visual terminal curriculum decks
</commit_message>
<xml_diff>
--- a/blocks/A_ros2_basics/M01_ros2_concepts/M01_ROS2_기초와_분산_로봇_소프트웨어.pptx
+++ b/blocks/A_ros2_basics/M01_ros2_concepts/M01_ROS2_기초와_분산_로봇_소프트웨어.pptx
@@ -796,7 +796,7 @@
           <a:lstStyle/>
           <a:p>
             <a:r>
-              <a:t>[설명] Publisher와 Subscriber는 동시에 살아 있어야 한다.</a:t>
+              <a:t>[설명] Publisher와 Subscriber는 동시에 살아 있어야 한다. 터미널 1은 talker를 계속 실행하고, 터미널 2는 listener가 받은 문자열을 출력하는지 관찰한다.</a:t>
             </a:r>
           </a:p>
           <a:p>
@@ -806,13 +806,18 @@
           </a:p>
           <a:p>
             <a:r>
+              <a:t>source /opt/ros/jazzy/setup.bash</a:t>
+            </a:r>
+          </a:p>
+          <a:p>
+            <a:r>
               <a:t>ros2 run demo_nodes_cpp talker</a:t>
             </a:r>
           </a:p>
           <a:p/>
           <a:p>
             <a:r>
-              <a:t># 새 터미널 2</a:t>
+              <a:t># 터미널 2</a:t>
             </a:r>
           </a:p>
           <a:p>
@@ -1017,7 +1022,12 @@
           </a:p>
           <a:p>
             <a:r>
-              <a:t>[실행] source /opt/ros/jazzy/setup.bash</a:t>
+              <a:t>[실행] # 터미널 1</a:t>
+            </a:r>
+          </a:p>
+          <a:p>
+            <a:r>
+              <a:t>source /opt/ros/jazzy/setup.bash</a:t>
             </a:r>
           </a:p>
           <a:p>
@@ -1025,9 +1035,20 @@
               <a:t>ros2 run demo_nodes_cpp talker</a:t>
             </a:r>
           </a:p>
-          <a:p>
-            <a:r>
-              <a:t># 새 터미널: ros2 run demo_nodes_py listener</a:t>
+          <a:p/>
+          <a:p>
+            <a:r>
+              <a:t># 터미널 2</a:t>
+            </a:r>
+          </a:p>
+          <a:p>
+            <a:r>
+              <a:t>source /opt/ros/jazzy/setup.bash</a:t>
+            </a:r>
+          </a:p>
+          <a:p>
+            <a:r>
+              <a:t>ros2 run demo_nodes_py listener</a:t>
             </a:r>
           </a:p>
           <a:p>
@@ -6610,7 +6631,7 @@
               </a:defRPr>
             </a:pPr>
             <a:r>
-              <a:t>현재 단계 실행 1/3    |    현재 폴더 ~/ros2_curri/my_agv_ws    |    현재 터미널</a:t>
+              <a:t>현재 단계 실행 1/3    |    현재 폴더 ~/ros2_curri/my_agv_ws    |    터미널 1</a:t>
             </a:r>
           </a:p>
         </p:txBody>
@@ -6623,8 +6644,8 @@
         </p:nvSpPr>
         <p:spPr>
           <a:xfrm>
-            <a:off x="676656" y="1764792"/>
-            <a:ext cx="1828800" cy="347472"/>
+            <a:off x="676656" y="1719072"/>
+            <a:ext cx="1691640" cy="274320"/>
           </a:xfrm>
           <a:prstGeom prst="rect">
             <a:avLst/>
@@ -6641,7 +6662,7 @@
               <a:spcAft>
                 <a:spcPts val="0"/>
               </a:spcAft>
-              <a:defRPr sz="1800" b="1">
+              <a:defRPr sz="1700" b="1">
                 <a:solidFill>
                   <a:srgbClr val="225B9B"/>
                 </a:solidFill>
@@ -6649,7 +6670,7 @@
               </a:defRPr>
             </a:pPr>
             <a:r>
-              <a:t>왜 하는가</a:t>
+              <a:t>명령의 목적</a:t>
             </a:r>
           </a:p>
         </p:txBody>
@@ -6662,7 +6683,7 @@
         </p:nvSpPr>
         <p:spPr>
           <a:xfrm>
-            <a:off x="676656" y="2103120"/>
+            <a:off x="676656" y="2002536"/>
             <a:ext cx="10789920" cy="512064"/>
           </a:xfrm>
           <a:prstGeom prst="rect">
@@ -6680,7 +6701,7 @@
               <a:spcAft>
                 <a:spcPts val="0"/>
               </a:spcAft>
-              <a:defRPr sz="2000" b="0">
+              <a:defRPr sz="1800" b="0">
                 <a:solidFill>
                   <a:srgbClr val="122C4E"/>
                 </a:solidFill>
@@ -6695,14 +6716,53 @@
       </p:sp>
       <p:sp>
         <p:nvSpPr>
-          <p:cNvPr id="9" name="Rounded Rectangle 8"/>
+          <p:cNvPr id="9" name="TextBox 8"/>
+          <p:cNvSpPr txBox="1"/>
+          <p:nvPr/>
+        </p:nvSpPr>
+        <p:spPr>
+          <a:xfrm>
+            <a:off x="676656" y="2816352"/>
+            <a:ext cx="10835640" cy="256032"/>
+          </a:xfrm>
+          <a:prstGeom prst="rect">
+            <a:avLst/>
+          </a:prstGeom>
+          <a:noFill/>
+        </p:spPr>
+        <p:txBody>
+          <a:bodyPr wrap="square" lIns="73152" rIns="73152" tIns="36576" bIns="36576">
+            <a:spAutoFit/>
+          </a:bodyPr>
+          <a:lstStyle/>
+          <a:p>
+            <a:pPr algn="ctr">
+              <a:spcAft>
+                <a:spcPts val="0"/>
+              </a:spcAft>
+              <a:defRPr sz="1600" b="1">
+                <a:solidFill>
+                  <a:srgbClr val="225B9B"/>
+                </a:solidFill>
+                <a:latin typeface="Noto Sans CJK KR"/>
+              </a:defRPr>
+            </a:pPr>
+            <a:r>
+              <a:t>터미널 1 — 아래 검은 블록은 명령만 복사합니다.</a:t>
+            </a:r>
+          </a:p>
+        </p:txBody>
+      </p:sp>
+      <p:sp>
+        <p:nvSpPr>
+          <p:cNvPr id="10" name="Rounded Rectangle 9"/>
           <p:cNvSpPr/>
           <p:nvPr/>
         </p:nvSpPr>
         <p:spPr>
           <a:xfrm>
-            <a:off x="676656" y="2871216"/>
-            <a:ext cx="10835640" cy="2331720"/>
+            <a:off x="676656" y="3154680"/>
+            <a:ext cx="10835640" cy="1938528"/>
           </a:xfrm>
           <a:prstGeom prst="roundRect">
             <a:avLst/>
@@ -6731,7 +6791,7 @@
           </a:fontRef>
         </p:style>
         <p:txBody>
-          <a:bodyPr rtlCol="0" anchor="ctr" wrap="square" lIns="73152" rIns="73152" tIns="36576" bIns="36576"/>
+          <a:bodyPr rtlCol="0" anchor="ctr" wrap="square" lIns="109728" rIns="109728" tIns="73152" bIns="73152"/>
           <a:lstStyle/>
           <a:p>
             <a:pPr algn="l">
@@ -6748,7 +6808,19 @@
             <a:r>
               <a:t>source /opt/ros/jazzy/setup.bash</a:t>
             </a:r>
-            <a:br/>
+          </a:p>
+          <a:p>
+            <a:pPr algn="l">
+              <a:spcAft>
+                <a:spcPts val="0"/>
+              </a:spcAft>
+              <a:defRPr sz="1600" b="0">
+                <a:solidFill>
+                  <a:srgbClr val="FFFFFF"/>
+                </a:solidFill>
+                <a:latin typeface="DejaVu Sans Mono"/>
+              </a:defRPr>
+            </a:pPr>
             <a:r>
               <a:t>ros2 --help | head</a:t>
             </a:r>
@@ -6757,14 +6829,14 @@
       </p:sp>
       <p:sp>
         <p:nvSpPr>
-          <p:cNvPr id="10" name="TextBox 9"/>
-          <p:cNvSpPr txBox="1"/>
-          <p:nvPr/>
-        </p:nvSpPr>
-        <p:spPr>
-          <a:xfrm>
-            <a:off x="768096" y="5468112"/>
-            <a:ext cx="1143000" cy="256032"/>
+          <p:cNvPr id="11" name="TextBox 10"/>
+          <p:cNvSpPr txBox="1"/>
+          <p:nvPr/>
+        </p:nvSpPr>
+        <p:spPr>
+          <a:xfrm>
+            <a:off x="768096" y="5276088"/>
+            <a:ext cx="10561320" cy="384048"/>
           </a:xfrm>
           <a:prstGeom prst="rect">
             <a:avLst/>
@@ -6777,11 +6849,11 @@
           </a:bodyPr>
           <a:lstStyle/>
           <a:p>
-            <a:pPr algn="l">
-              <a:spcAft>
-                <a:spcPts val="0"/>
-              </a:spcAft>
-              <a:defRPr sz="1800" b="1">
+            <a:pPr algn="ctr">
+              <a:spcAft>
+                <a:spcPts val="0"/>
+              </a:spcAft>
+              <a:defRPr sz="1500" b="1">
                 <a:solidFill>
                   <a:srgbClr val="2A8B5A"/>
                 </a:solidFill>
@@ -6789,21 +6861,21 @@
               </a:defRPr>
             </a:pPr>
             <a:r>
-              <a:t>확인</a:t>
-            </a:r>
-          </a:p>
-        </p:txBody>
-      </p:sp>
-      <p:sp>
-        <p:nvSpPr>
-          <p:cNvPr id="11" name="TextBox 10"/>
-          <p:cNvSpPr txBox="1"/>
-          <p:nvPr/>
-        </p:nvSpPr>
-        <p:spPr>
-          <a:xfrm>
-            <a:off x="768096" y="5742432"/>
-            <a:ext cx="10561320" cy="347472"/>
+              <a:t>터미널 1 역할: 터미널 1에서 이 명령만 그대로 복사해 실행합니다.</a:t>
+            </a:r>
+          </a:p>
+        </p:txBody>
+      </p:sp>
+      <p:sp>
+        <p:nvSpPr>
+          <p:cNvPr id="12" name="TextBox 11"/>
+          <p:cNvSpPr txBox="1"/>
+          <p:nvPr/>
+        </p:nvSpPr>
+        <p:spPr>
+          <a:xfrm>
+            <a:off x="768096" y="5916168"/>
+            <a:ext cx="10561320" cy="292608"/>
           </a:xfrm>
           <a:prstGeom prst="rect">
             <a:avLst/>
@@ -6816,11 +6888,11 @@
           </a:bodyPr>
           <a:lstStyle/>
           <a:p>
-            <a:pPr algn="l">
-              <a:spcAft>
-                <a:spcPts val="0"/>
-              </a:spcAft>
-              <a:defRPr sz="1800" b="0">
+            <a:pPr algn="ctr">
+              <a:spcAft>
+                <a:spcPts val="0"/>
+              </a:spcAft>
+              <a:defRPr sz="1500" b="1">
                 <a:solidFill>
                   <a:srgbClr val="122C4E"/>
                 </a:solidFill>
@@ -6828,7 +6900,7 @@
               </a:defRPr>
             </a:pPr>
             <a:r>
-              <a:t>출력에서 topic·frame·파일 이름 또는 성공 메시지를 찾고, 맞지 않으면 다음 파일로 가지 않습니다.</a:t>
+              <a:t>확인: 출력에서 topic·frame·파일 이름 또는 성공 메시지를 찾고, 맞지 않으면 다음 파일로 가지 않습니다.</a:t>
             </a:r>
           </a:p>
         </p:txBody>
@@ -7060,7 +7132,7 @@
               </a:defRPr>
             </a:pPr>
             <a:r>
-              <a:t>현재 단계 실행 2/3    |    현재 폴더 ~/ros2_curri/my_agv_ws    |    새 터미널</a:t>
+              <a:t>현재 단계 실행 2/3    |    현재 폴더 ~/ros2_curri/my_agv_ws    |    터미널 1 + 2</a:t>
             </a:r>
           </a:p>
         </p:txBody>
@@ -7073,8 +7145,8 @@
         </p:nvSpPr>
         <p:spPr>
           <a:xfrm>
-            <a:off x="676656" y="1764792"/>
-            <a:ext cx="1828800" cy="347472"/>
+            <a:off x="676656" y="1719072"/>
+            <a:ext cx="1691640" cy="274320"/>
           </a:xfrm>
           <a:prstGeom prst="rect">
             <a:avLst/>
@@ -7091,7 +7163,7 @@
               <a:spcAft>
                 <a:spcPts val="0"/>
               </a:spcAft>
-              <a:defRPr sz="1800" b="1">
+              <a:defRPr sz="1700" b="1">
                 <a:solidFill>
                   <a:srgbClr val="225B9B"/>
                 </a:solidFill>
@@ -7099,7 +7171,7 @@
               </a:defRPr>
             </a:pPr>
             <a:r>
-              <a:t>왜 하는가</a:t>
+              <a:t>명령의 목적</a:t>
             </a:r>
           </a:p>
         </p:txBody>
@@ -7112,7 +7184,7 @@
         </p:nvSpPr>
         <p:spPr>
           <a:xfrm>
-            <a:off x="676656" y="2103120"/>
+            <a:off x="676656" y="2002536"/>
             <a:ext cx="10789920" cy="512064"/>
           </a:xfrm>
           <a:prstGeom prst="rect">
@@ -7130,7 +7202,7 @@
               <a:spcAft>
                 <a:spcPts val="0"/>
               </a:spcAft>
-              <a:defRPr sz="2000" b="0">
+              <a:defRPr sz="1800" b="0">
                 <a:solidFill>
                   <a:srgbClr val="122C4E"/>
                 </a:solidFill>
@@ -7138,21 +7210,99 @@
               </a:defRPr>
             </a:pPr>
             <a:r>
-              <a:t>Publisher와 Subscriber는 동시에 살아 있어야 한다.</a:t>
-            </a:r>
-          </a:p>
-        </p:txBody>
-      </p:sp>
-      <p:sp>
-        <p:nvSpPr>
-          <p:cNvPr id="9" name="Rounded Rectangle 8"/>
+              <a:t>Publisher와 Subscriber는 동시에 살아 있어야 한다. 터미널 1은 talker를 계속 실행하고, 터미널 2는 listener가 받은 문자열을 출력하는지 관찰한다.</a:t>
+            </a:r>
+          </a:p>
+        </p:txBody>
+      </p:sp>
+      <p:sp>
+        <p:nvSpPr>
+          <p:cNvPr id="9" name="TextBox 8"/>
+          <p:cNvSpPr txBox="1"/>
+          <p:nvPr/>
+        </p:nvSpPr>
+        <p:spPr>
+          <a:xfrm>
+            <a:off x="676656" y="2679192"/>
+            <a:ext cx="10789920" cy="237744"/>
+          </a:xfrm>
+          <a:prstGeom prst="rect">
+            <a:avLst/>
+          </a:prstGeom>
+          <a:noFill/>
+        </p:spPr>
+        <p:txBody>
+          <a:bodyPr wrap="square" lIns="73152" rIns="73152" tIns="36576" bIns="36576">
+            <a:spAutoFit/>
+          </a:bodyPr>
+          <a:lstStyle/>
+          <a:p>
+            <a:pPr algn="ctr">
+              <a:spcAft>
+                <a:spcPts val="0"/>
+              </a:spcAft>
+              <a:defRPr sz="1400" b="1">
+                <a:solidFill>
+                  <a:srgbClr val="DB7E22"/>
+                </a:solidFill>
+                <a:latin typeface="Noto Sans CJK KR"/>
+              </a:defRPr>
+            </a:pPr>
+            <a:r>
+              <a:t>두 터미널은 동시에 필요합니다. 각 검은 블록에는 그대로 복사할 명령만 들어 있습니다.</a:t>
+            </a:r>
+          </a:p>
+        </p:txBody>
+      </p:sp>
+      <p:sp>
+        <p:nvSpPr>
+          <p:cNvPr id="10" name="TextBox 9"/>
+          <p:cNvSpPr txBox="1"/>
+          <p:nvPr/>
+        </p:nvSpPr>
+        <p:spPr>
+          <a:xfrm>
+            <a:off x="676656" y="3017520"/>
+            <a:ext cx="5138928" cy="256032"/>
+          </a:xfrm>
+          <a:prstGeom prst="rect">
+            <a:avLst/>
+          </a:prstGeom>
+          <a:noFill/>
+        </p:spPr>
+        <p:txBody>
+          <a:bodyPr wrap="square" lIns="73152" rIns="73152" tIns="36576" bIns="36576">
+            <a:spAutoFit/>
+          </a:bodyPr>
+          <a:lstStyle/>
+          <a:p>
+            <a:pPr algn="ctr">
+              <a:spcAft>
+                <a:spcPts val="0"/>
+              </a:spcAft>
+              <a:defRPr sz="1600" b="1">
+                <a:solidFill>
+                  <a:srgbClr val="225B9B"/>
+                </a:solidFill>
+                <a:latin typeface="Noto Sans CJK KR"/>
+              </a:defRPr>
+            </a:pPr>
+            <a:r>
+              <a:t>터미널 1 — 명령만 복사</a:t>
+            </a:r>
+          </a:p>
+        </p:txBody>
+      </p:sp>
+      <p:sp>
+        <p:nvSpPr>
+          <p:cNvPr id="11" name="Rounded Rectangle 10"/>
           <p:cNvSpPr/>
           <p:nvPr/>
         </p:nvSpPr>
         <p:spPr>
           <a:xfrm>
-            <a:off x="676656" y="2871216"/>
-            <a:ext cx="10835640" cy="2331720"/>
+            <a:off x="676656" y="3328416"/>
+            <a:ext cx="5138928" cy="1700784"/>
           </a:xfrm>
           <a:prstGeom prst="roundRect">
             <a:avLst/>
@@ -7181,14 +7331,14 @@
           </a:fontRef>
         </p:style>
         <p:txBody>
-          <a:bodyPr rtlCol="0" anchor="ctr" wrap="square" lIns="73152" rIns="73152" tIns="36576" bIns="36576"/>
+          <a:bodyPr rtlCol="0" anchor="ctr" wrap="square" lIns="109728" rIns="109728" tIns="73152" bIns="73152"/>
           <a:lstStyle/>
           <a:p>
             <a:pPr algn="l">
               <a:spcAft>
                 <a:spcPts val="0"/>
               </a:spcAft>
-              <a:defRPr sz="1600" b="0">
+              <a:defRPr sz="1400" b="0">
                 <a:solidFill>
                   <a:srgbClr val="FFFFFF"/>
                 </a:solidFill>
@@ -7196,22 +7346,173 @@
               </a:defRPr>
             </a:pPr>
             <a:r>
-              <a:t># 터미널 1</a:t>
-            </a:r>
-            <a:br/>
+              <a:t>source /opt/ros/jazzy/setup.bash</a:t>
+            </a:r>
+          </a:p>
+          <a:p>
+            <a:pPr algn="l">
+              <a:spcAft>
+                <a:spcPts val="0"/>
+              </a:spcAft>
+              <a:defRPr sz="1400" b="0">
+                <a:solidFill>
+                  <a:srgbClr val="FFFFFF"/>
+                </a:solidFill>
+                <a:latin typeface="DejaVu Sans Mono"/>
+              </a:defRPr>
+            </a:pPr>
             <a:r>
               <a:t>ros2 run demo_nodes_cpp talker</a:t>
             </a:r>
-            <a:br/>
-            <a:br/>
-            <a:r>
-              <a:t># 새 터미널 2</a:t>
-            </a:r>
-            <a:br/>
+          </a:p>
+        </p:txBody>
+      </p:sp>
+      <p:sp>
+        <p:nvSpPr>
+          <p:cNvPr id="12" name="TextBox 11"/>
+          <p:cNvSpPr txBox="1"/>
+          <p:nvPr/>
+        </p:nvSpPr>
+        <p:spPr>
+          <a:xfrm>
+            <a:off x="749808" y="5166360"/>
+            <a:ext cx="4992624" cy="438912"/>
+          </a:xfrm>
+          <a:prstGeom prst="rect">
+            <a:avLst/>
+          </a:prstGeom>
+          <a:noFill/>
+        </p:spPr>
+        <p:txBody>
+          <a:bodyPr wrap="square" lIns="73152" rIns="73152" tIns="36576" bIns="36576">
+            <a:spAutoFit/>
+          </a:bodyPr>
+          <a:lstStyle/>
+          <a:p>
+            <a:pPr algn="ctr">
+              <a:spcAft>
+                <a:spcPts val="0"/>
+              </a:spcAft>
+              <a:defRPr sz="1300" b="1">
+                <a:solidFill>
+                  <a:srgbClr val="2A8B5A"/>
+                </a:solidFill>
+                <a:latin typeface="Noto Sans CJK KR"/>
+              </a:defRPr>
+            </a:pPr>
+            <a:r>
+              <a:t>터미널 1 역할: 이 node를 실행합니다. 출력이 계속 나오는 동안 Ctrl+C로 종료하지 않습니다.</a:t>
+            </a:r>
+          </a:p>
+        </p:txBody>
+      </p:sp>
+      <p:sp>
+        <p:nvSpPr>
+          <p:cNvPr id="13" name="TextBox 12"/>
+          <p:cNvSpPr txBox="1"/>
+          <p:nvPr/>
+        </p:nvSpPr>
+        <p:spPr>
+          <a:xfrm>
+            <a:off x="6190488" y="3017520"/>
+            <a:ext cx="5138928" cy="256032"/>
+          </a:xfrm>
+          <a:prstGeom prst="rect">
+            <a:avLst/>
+          </a:prstGeom>
+          <a:noFill/>
+        </p:spPr>
+        <p:txBody>
+          <a:bodyPr wrap="square" lIns="73152" rIns="73152" tIns="36576" bIns="36576">
+            <a:spAutoFit/>
+          </a:bodyPr>
+          <a:lstStyle/>
+          <a:p>
+            <a:pPr algn="ctr">
+              <a:spcAft>
+                <a:spcPts val="0"/>
+              </a:spcAft>
+              <a:defRPr sz="1600" b="1">
+                <a:solidFill>
+                  <a:srgbClr val="225B9B"/>
+                </a:solidFill>
+                <a:latin typeface="Noto Sans CJK KR"/>
+              </a:defRPr>
+            </a:pPr>
+            <a:r>
+              <a:t>터미널 2 — 명령만 복사</a:t>
+            </a:r>
+          </a:p>
+        </p:txBody>
+      </p:sp>
+      <p:sp>
+        <p:nvSpPr>
+          <p:cNvPr id="14" name="Rounded Rectangle 13"/>
+          <p:cNvSpPr/>
+          <p:nvPr/>
+        </p:nvSpPr>
+        <p:spPr>
+          <a:xfrm>
+            <a:off x="6190488" y="3328416"/>
+            <a:ext cx="5138928" cy="1700784"/>
+          </a:xfrm>
+          <a:prstGeom prst="roundRect">
+            <a:avLst/>
+          </a:prstGeom>
+          <a:solidFill>
+            <a:srgbClr val="1D232D"/>
+          </a:solidFill>
+          <a:ln>
+            <a:solidFill>
+              <a:srgbClr val="1D232D"/>
+            </a:solidFill>
+          </a:ln>
+        </p:spPr>
+        <p:style>
+          <a:lnRef idx="1">
+            <a:schemeClr val="accent1"/>
+          </a:lnRef>
+          <a:fillRef idx="3">
+            <a:schemeClr val="accent1"/>
+          </a:fillRef>
+          <a:effectRef idx="2">
+            <a:schemeClr val="accent1"/>
+          </a:effectRef>
+          <a:fontRef idx="minor">
+            <a:schemeClr val="lt1"/>
+          </a:fontRef>
+        </p:style>
+        <p:txBody>
+          <a:bodyPr rtlCol="0" anchor="ctr" wrap="square" lIns="109728" rIns="109728" tIns="73152" bIns="73152"/>
+          <a:lstStyle/>
+          <a:p>
+            <a:pPr algn="l">
+              <a:spcAft>
+                <a:spcPts val="0"/>
+              </a:spcAft>
+              <a:defRPr sz="1400" b="0">
+                <a:solidFill>
+                  <a:srgbClr val="FFFFFF"/>
+                </a:solidFill>
+                <a:latin typeface="DejaVu Sans Mono"/>
+              </a:defRPr>
+            </a:pPr>
             <a:r>
               <a:t>source /opt/ros/jazzy/setup.bash</a:t>
             </a:r>
-            <a:br/>
+          </a:p>
+          <a:p>
+            <a:pPr algn="l">
+              <a:spcAft>
+                <a:spcPts val="0"/>
+              </a:spcAft>
+              <a:defRPr sz="1400" b="0">
+                <a:solidFill>
+                  <a:srgbClr val="FFFFFF"/>
+                </a:solidFill>
+                <a:latin typeface="DejaVu Sans Mono"/>
+              </a:defRPr>
+            </a:pPr>
             <a:r>
               <a:t>ros2 run demo_nodes_py listener</a:t>
             </a:r>
@@ -7220,14 +7521,14 @@
       </p:sp>
       <p:sp>
         <p:nvSpPr>
-          <p:cNvPr id="10" name="TextBox 9"/>
-          <p:cNvSpPr txBox="1"/>
-          <p:nvPr/>
-        </p:nvSpPr>
-        <p:spPr>
-          <a:xfrm>
-            <a:off x="768096" y="5468112"/>
-            <a:ext cx="1143000" cy="256032"/>
+          <p:cNvPr id="15" name="TextBox 14"/>
+          <p:cNvSpPr txBox="1"/>
+          <p:nvPr/>
+        </p:nvSpPr>
+        <p:spPr>
+          <a:xfrm>
+            <a:off x="6263640" y="5166360"/>
+            <a:ext cx="4992624" cy="438912"/>
           </a:xfrm>
           <a:prstGeom prst="rect">
             <a:avLst/>
@@ -7240,11 +7541,11 @@
           </a:bodyPr>
           <a:lstStyle/>
           <a:p>
-            <a:pPr algn="l">
-              <a:spcAft>
-                <a:spcPts val="0"/>
-              </a:spcAft>
-              <a:defRPr sz="1800" b="1">
+            <a:pPr algn="ctr">
+              <a:spcAft>
+                <a:spcPts val="0"/>
+              </a:spcAft>
+              <a:defRPr sz="1300" b="1">
                 <a:solidFill>
                   <a:srgbClr val="2A8B5A"/>
                 </a:solidFill>
@@ -7252,21 +7553,21 @@
               </a:defRPr>
             </a:pPr>
             <a:r>
-              <a:t>확인</a:t>
-            </a:r>
-          </a:p>
-        </p:txBody>
-      </p:sp>
-      <p:sp>
-        <p:nvSpPr>
-          <p:cNvPr id="11" name="TextBox 10"/>
-          <p:cNvSpPr txBox="1"/>
-          <p:nvPr/>
-        </p:nvSpPr>
-        <p:spPr>
-          <a:xfrm>
-            <a:off x="768096" y="5742432"/>
-            <a:ext cx="10561320" cy="347472"/>
+              <a:t>터미널 2 역할: 이 node를 실행합니다. 출력이 계속 나오는 동안 Ctrl+C로 종료하지 않습니다.</a:t>
+            </a:r>
+          </a:p>
+        </p:txBody>
+      </p:sp>
+      <p:sp>
+        <p:nvSpPr>
+          <p:cNvPr id="16" name="TextBox 15"/>
+          <p:cNvSpPr txBox="1"/>
+          <p:nvPr/>
+        </p:nvSpPr>
+        <p:spPr>
+          <a:xfrm>
+            <a:off x="768096" y="5916168"/>
+            <a:ext cx="10561320" cy="292608"/>
           </a:xfrm>
           <a:prstGeom prst="rect">
             <a:avLst/>
@@ -7279,11 +7580,11 @@
           </a:bodyPr>
           <a:lstStyle/>
           <a:p>
-            <a:pPr algn="l">
-              <a:spcAft>
-                <a:spcPts val="0"/>
-              </a:spcAft>
-              <a:defRPr sz="1800" b="0">
+            <a:pPr algn="ctr">
+              <a:spcAft>
+                <a:spcPts val="0"/>
+              </a:spcAft>
+              <a:defRPr sz="1500" b="1">
                 <a:solidFill>
                   <a:srgbClr val="122C4E"/>
                 </a:solidFill>
@@ -7291,7 +7592,7 @@
               </a:defRPr>
             </a:pPr>
             <a:r>
-              <a:t>출력에서 topic·frame·파일 이름 또는 성공 메시지를 찾고, 맞지 않으면 다음 파일로 가지 않습니다.</a:t>
+              <a:t>확인: 출력에서 topic·frame·파일 이름 또는 성공 메시지를 찾고, 맞지 않으면 다음 파일로 가지 않습니다.</a:t>
             </a:r>
           </a:p>
         </p:txBody>
@@ -7523,7 +7824,7 @@
               </a:defRPr>
             </a:pPr>
             <a:r>
-              <a:t>현재 단계 실행 3/3    |    현재 폴더 ~/ros2_curri/my_agv_ws    |    현재 터미널</a:t>
+              <a:t>현재 단계 실행 3/3    |    현재 폴더 ~/ros2_curri/my_agv_ws    |    터미널 1</a:t>
             </a:r>
           </a:p>
         </p:txBody>
@@ -7536,8 +7837,8 @@
         </p:nvSpPr>
         <p:spPr>
           <a:xfrm>
-            <a:off x="676656" y="1764792"/>
-            <a:ext cx="1828800" cy="347472"/>
+            <a:off x="676656" y="1719072"/>
+            <a:ext cx="1691640" cy="274320"/>
           </a:xfrm>
           <a:prstGeom prst="rect">
             <a:avLst/>
@@ -7554,7 +7855,7 @@
               <a:spcAft>
                 <a:spcPts val="0"/>
               </a:spcAft>
-              <a:defRPr sz="1800" b="1">
+              <a:defRPr sz="1700" b="1">
                 <a:solidFill>
                   <a:srgbClr val="225B9B"/>
                 </a:solidFill>
@@ -7562,7 +7863,7 @@
               </a:defRPr>
             </a:pPr>
             <a:r>
-              <a:t>왜 하는가</a:t>
+              <a:t>명령의 목적</a:t>
             </a:r>
           </a:p>
         </p:txBody>
@@ -7575,7 +7876,7 @@
         </p:nvSpPr>
         <p:spPr>
           <a:xfrm>
-            <a:off x="676656" y="2103120"/>
+            <a:off x="676656" y="2002536"/>
             <a:ext cx="10789920" cy="512064"/>
           </a:xfrm>
           <a:prstGeom prst="rect">
@@ -7593,7 +7894,7 @@
               <a:spcAft>
                 <a:spcPts val="0"/>
               </a:spcAft>
-              <a:defRPr sz="2000" b="0">
+              <a:defRPr sz="1800" b="0">
                 <a:solidFill>
                   <a:srgbClr val="122C4E"/>
                 </a:solidFill>
@@ -7608,14 +7909,53 @@
       </p:sp>
       <p:sp>
         <p:nvSpPr>
-          <p:cNvPr id="9" name="Rounded Rectangle 8"/>
+          <p:cNvPr id="9" name="TextBox 8"/>
+          <p:cNvSpPr txBox="1"/>
+          <p:nvPr/>
+        </p:nvSpPr>
+        <p:spPr>
+          <a:xfrm>
+            <a:off x="676656" y="2816352"/>
+            <a:ext cx="10835640" cy="256032"/>
+          </a:xfrm>
+          <a:prstGeom prst="rect">
+            <a:avLst/>
+          </a:prstGeom>
+          <a:noFill/>
+        </p:spPr>
+        <p:txBody>
+          <a:bodyPr wrap="square" lIns="73152" rIns="73152" tIns="36576" bIns="36576">
+            <a:spAutoFit/>
+          </a:bodyPr>
+          <a:lstStyle/>
+          <a:p>
+            <a:pPr algn="ctr">
+              <a:spcAft>
+                <a:spcPts val="0"/>
+              </a:spcAft>
+              <a:defRPr sz="1600" b="1">
+                <a:solidFill>
+                  <a:srgbClr val="225B9B"/>
+                </a:solidFill>
+                <a:latin typeface="Noto Sans CJK KR"/>
+              </a:defRPr>
+            </a:pPr>
+            <a:r>
+              <a:t>터미널 1 — 아래 검은 블록은 명령만 복사합니다.</a:t>
+            </a:r>
+          </a:p>
+        </p:txBody>
+      </p:sp>
+      <p:sp>
+        <p:nvSpPr>
+          <p:cNvPr id="10" name="Rounded Rectangle 9"/>
           <p:cNvSpPr/>
           <p:nvPr/>
         </p:nvSpPr>
         <p:spPr>
           <a:xfrm>
-            <a:off x="676656" y="2871216"/>
-            <a:ext cx="10835640" cy="2331720"/>
+            <a:off x="676656" y="3154680"/>
+            <a:ext cx="10835640" cy="1938528"/>
           </a:xfrm>
           <a:prstGeom prst="roundRect">
             <a:avLst/>
@@ -7644,7 +7984,7 @@
           </a:fontRef>
         </p:style>
         <p:txBody>
-          <a:bodyPr rtlCol="0" anchor="ctr" wrap="square" lIns="73152" rIns="73152" tIns="36576" bIns="36576"/>
+          <a:bodyPr rtlCol="0" anchor="ctr" wrap="square" lIns="109728" rIns="109728" tIns="73152" bIns="73152"/>
           <a:lstStyle/>
           <a:p>
             <a:pPr algn="l">
@@ -7661,15 +8001,51 @@
             <a:r>
               <a:t>ros2 node list</a:t>
             </a:r>
-            <a:br/>
+          </a:p>
+          <a:p>
+            <a:pPr algn="l">
+              <a:spcAft>
+                <a:spcPts val="0"/>
+              </a:spcAft>
+              <a:defRPr sz="1600" b="0">
+                <a:solidFill>
+                  <a:srgbClr val="FFFFFF"/>
+                </a:solidFill>
+                <a:latin typeface="DejaVu Sans Mono"/>
+              </a:defRPr>
+            </a:pPr>
             <a:r>
               <a:t>ros2 topic list</a:t>
             </a:r>
-            <a:br/>
+          </a:p>
+          <a:p>
+            <a:pPr algn="l">
+              <a:spcAft>
+                <a:spcPts val="0"/>
+              </a:spcAft>
+              <a:defRPr sz="1600" b="0">
+                <a:solidFill>
+                  <a:srgbClr val="FFFFFF"/>
+                </a:solidFill>
+                <a:latin typeface="DejaVu Sans Mono"/>
+              </a:defRPr>
+            </a:pPr>
             <a:r>
               <a:t>ros2 topic info /chatter</a:t>
             </a:r>
-            <a:br/>
+          </a:p>
+          <a:p>
+            <a:pPr algn="l">
+              <a:spcAft>
+                <a:spcPts val="0"/>
+              </a:spcAft>
+              <a:defRPr sz="1600" b="0">
+                <a:solidFill>
+                  <a:srgbClr val="FFFFFF"/>
+                </a:solidFill>
+                <a:latin typeface="DejaVu Sans Mono"/>
+              </a:defRPr>
+            </a:pPr>
             <a:r>
               <a:t>ros2 topic echo /chatter --once</a:t>
             </a:r>
@@ -7678,14 +8054,14 @@
       </p:sp>
       <p:sp>
         <p:nvSpPr>
-          <p:cNvPr id="10" name="TextBox 9"/>
-          <p:cNvSpPr txBox="1"/>
-          <p:nvPr/>
-        </p:nvSpPr>
-        <p:spPr>
-          <a:xfrm>
-            <a:off x="768096" y="5468112"/>
-            <a:ext cx="1143000" cy="256032"/>
+          <p:cNvPr id="11" name="TextBox 10"/>
+          <p:cNvSpPr txBox="1"/>
+          <p:nvPr/>
+        </p:nvSpPr>
+        <p:spPr>
+          <a:xfrm>
+            <a:off x="768096" y="5276088"/>
+            <a:ext cx="10561320" cy="384048"/>
           </a:xfrm>
           <a:prstGeom prst="rect">
             <a:avLst/>
@@ -7698,11 +8074,11 @@
           </a:bodyPr>
           <a:lstStyle/>
           <a:p>
-            <a:pPr algn="l">
-              <a:spcAft>
-                <a:spcPts val="0"/>
-              </a:spcAft>
-              <a:defRPr sz="1800" b="1">
+            <a:pPr algn="ctr">
+              <a:spcAft>
+                <a:spcPts val="0"/>
+              </a:spcAft>
+              <a:defRPr sz="1500" b="1">
                 <a:solidFill>
                   <a:srgbClr val="2A8B5A"/>
                 </a:solidFill>
@@ -7710,21 +8086,21 @@
               </a:defRPr>
             </a:pPr>
             <a:r>
-              <a:t>확인</a:t>
-            </a:r>
-          </a:p>
-        </p:txBody>
-      </p:sp>
-      <p:sp>
-        <p:nvSpPr>
-          <p:cNvPr id="11" name="TextBox 10"/>
-          <p:cNvSpPr txBox="1"/>
-          <p:nvPr/>
-        </p:nvSpPr>
-        <p:spPr>
-          <a:xfrm>
-            <a:off x="768096" y="5742432"/>
-            <a:ext cx="10561320" cy="347472"/>
+              <a:t>터미널 1 역할: 다른 터미널의 실행 결과를 이 창에서 관찰·검증합니다.</a:t>
+            </a:r>
+          </a:p>
+        </p:txBody>
+      </p:sp>
+      <p:sp>
+        <p:nvSpPr>
+          <p:cNvPr id="12" name="TextBox 11"/>
+          <p:cNvSpPr txBox="1"/>
+          <p:nvPr/>
+        </p:nvSpPr>
+        <p:spPr>
+          <a:xfrm>
+            <a:off x="768096" y="5916168"/>
+            <a:ext cx="10561320" cy="292608"/>
           </a:xfrm>
           <a:prstGeom prst="rect">
             <a:avLst/>
@@ -7737,11 +8113,11 @@
           </a:bodyPr>
           <a:lstStyle/>
           <a:p>
-            <a:pPr algn="l">
-              <a:spcAft>
-                <a:spcPts val="0"/>
-              </a:spcAft>
-              <a:defRPr sz="1800" b="0">
+            <a:pPr algn="ctr">
+              <a:spcAft>
+                <a:spcPts val="0"/>
+              </a:spcAft>
+              <a:defRPr sz="1500" b="1">
                 <a:solidFill>
                   <a:srgbClr val="122C4E"/>
                 </a:solidFill>
@@ -7749,7 +8125,7 @@
               </a:defRPr>
             </a:pPr>
             <a:r>
-              <a:t>출력에서 topic·frame·파일 이름 또는 성공 메시지를 찾고, 맞지 않으면 다음 파일로 가지 않습니다.</a:t>
+              <a:t>확인: 출력에서 topic·frame·파일 이름 또는 성공 메시지를 찾고, 맞지 않으면 다음 파일로 가지 않습니다.</a:t>
             </a:r>
           </a:p>
         </p:txBody>
@@ -7981,21 +8357,177 @@
               </a:defRPr>
             </a:pPr>
             <a:r>
-              <a:t>현재 단계 실행    |    현재 폴더 ~/ros2_curri/my_agv_ws    |    현재 터미널</a:t>
-            </a:r>
-          </a:p>
-        </p:txBody>
-      </p:sp>
-      <p:sp>
-        <p:nvSpPr>
-          <p:cNvPr id="7" name="Rounded Rectangle 6"/>
+              <a:t>현재 단계 실행    |    현재 폴더 ~/ros2_curri/my_agv_ws    |    터미널 1 + 2</a:t>
+            </a:r>
+          </a:p>
+        </p:txBody>
+      </p:sp>
+      <p:sp>
+        <p:nvSpPr>
+          <p:cNvPr id="7" name="TextBox 6"/>
+          <p:cNvSpPr txBox="1"/>
+          <p:nvPr/>
+        </p:nvSpPr>
+        <p:spPr>
+          <a:xfrm>
+            <a:off x="676656" y="1719072"/>
+            <a:ext cx="1691640" cy="274320"/>
+          </a:xfrm>
+          <a:prstGeom prst="rect">
+            <a:avLst/>
+          </a:prstGeom>
+          <a:noFill/>
+        </p:spPr>
+        <p:txBody>
+          <a:bodyPr wrap="square" lIns="73152" rIns="73152" tIns="36576" bIns="36576">
+            <a:spAutoFit/>
+          </a:bodyPr>
+          <a:lstStyle/>
+          <a:p>
+            <a:pPr algn="l">
+              <a:spcAft>
+                <a:spcPts val="0"/>
+              </a:spcAft>
+              <a:defRPr sz="1700" b="1">
+                <a:solidFill>
+                  <a:srgbClr val="225B9B"/>
+                </a:solidFill>
+                <a:latin typeface="Noto Sans CJK KR"/>
+              </a:defRPr>
+            </a:pPr>
+            <a:r>
+              <a:t>명령의 목적</a:t>
+            </a:r>
+          </a:p>
+        </p:txBody>
+      </p:sp>
+      <p:sp>
+        <p:nvSpPr>
+          <p:cNvPr id="8" name="TextBox 7"/>
+          <p:cNvSpPr txBox="1"/>
+          <p:nvPr/>
+        </p:nvSpPr>
+        <p:spPr>
+          <a:xfrm>
+            <a:off x="676656" y="2002536"/>
+            <a:ext cx="10789920" cy="512064"/>
+          </a:xfrm>
+          <a:prstGeom prst="rect">
+            <a:avLst/>
+          </a:prstGeom>
+          <a:noFill/>
+        </p:spPr>
+        <p:txBody>
+          <a:bodyPr wrap="square" lIns="73152" rIns="73152" tIns="36576" bIns="36576">
+            <a:spAutoFit/>
+          </a:bodyPr>
+          <a:lstStyle/>
+          <a:p>
+            <a:pPr algn="l">
+              <a:spcAft>
+                <a:spcPts val="0"/>
+              </a:spcAft>
+              <a:defRPr sz="1800" b="0">
+                <a:solidFill>
+                  <a:srgbClr val="122C4E"/>
+                </a:solidFill>
+                <a:latin typeface="Noto Sans CJK KR"/>
+              </a:defRPr>
+            </a:pPr>
+            <a:r>
+              <a:t>명령 순서를 바꾸지 않습니다. build가 끝난 뒤 source하고, 마지막 명령으로 node·Gazebo·RViz를 실행합니다.</a:t>
+            </a:r>
+          </a:p>
+        </p:txBody>
+      </p:sp>
+      <p:sp>
+        <p:nvSpPr>
+          <p:cNvPr id="9" name="TextBox 8"/>
+          <p:cNvSpPr txBox="1"/>
+          <p:nvPr/>
+        </p:nvSpPr>
+        <p:spPr>
+          <a:xfrm>
+            <a:off x="676656" y="2679192"/>
+            <a:ext cx="10789920" cy="237744"/>
+          </a:xfrm>
+          <a:prstGeom prst="rect">
+            <a:avLst/>
+          </a:prstGeom>
+          <a:noFill/>
+        </p:spPr>
+        <p:txBody>
+          <a:bodyPr wrap="square" lIns="73152" rIns="73152" tIns="36576" bIns="36576">
+            <a:spAutoFit/>
+          </a:bodyPr>
+          <a:lstStyle/>
+          <a:p>
+            <a:pPr algn="ctr">
+              <a:spcAft>
+                <a:spcPts val="0"/>
+              </a:spcAft>
+              <a:defRPr sz="1400" b="1">
+                <a:solidFill>
+                  <a:srgbClr val="DB7E22"/>
+                </a:solidFill>
+                <a:latin typeface="Noto Sans CJK KR"/>
+              </a:defRPr>
+            </a:pPr>
+            <a:r>
+              <a:t>두 터미널은 동시에 필요합니다. 각 검은 블록에는 그대로 복사할 명령만 들어 있습니다.</a:t>
+            </a:r>
+          </a:p>
+        </p:txBody>
+      </p:sp>
+      <p:sp>
+        <p:nvSpPr>
+          <p:cNvPr id="10" name="TextBox 9"/>
+          <p:cNvSpPr txBox="1"/>
+          <p:nvPr/>
+        </p:nvSpPr>
+        <p:spPr>
+          <a:xfrm>
+            <a:off x="676656" y="3017520"/>
+            <a:ext cx="5138928" cy="256032"/>
+          </a:xfrm>
+          <a:prstGeom prst="rect">
+            <a:avLst/>
+          </a:prstGeom>
+          <a:noFill/>
+        </p:spPr>
+        <p:txBody>
+          <a:bodyPr wrap="square" lIns="73152" rIns="73152" tIns="36576" bIns="36576">
+            <a:spAutoFit/>
+          </a:bodyPr>
+          <a:lstStyle/>
+          <a:p>
+            <a:pPr algn="ctr">
+              <a:spcAft>
+                <a:spcPts val="0"/>
+              </a:spcAft>
+              <a:defRPr sz="1600" b="1">
+                <a:solidFill>
+                  <a:srgbClr val="225B9B"/>
+                </a:solidFill>
+                <a:latin typeface="Noto Sans CJK KR"/>
+              </a:defRPr>
+            </a:pPr>
+            <a:r>
+              <a:t>터미널 1 — 명령만 복사</a:t>
+            </a:r>
+          </a:p>
+        </p:txBody>
+      </p:sp>
+      <p:sp>
+        <p:nvSpPr>
+          <p:cNvPr id="11" name="Rounded Rectangle 10"/>
           <p:cNvSpPr/>
           <p:nvPr/>
         </p:nvSpPr>
         <p:spPr>
           <a:xfrm>
-            <a:off x="658368" y="1700784"/>
-            <a:ext cx="10972800" cy="3182112"/>
+            <a:off x="676656" y="3328416"/>
+            <a:ext cx="5138928" cy="1700784"/>
           </a:xfrm>
           <a:prstGeom prst="roundRect">
             <a:avLst/>
@@ -8024,14 +8556,14 @@
           </a:fontRef>
         </p:style>
         <p:txBody>
-          <a:bodyPr rtlCol="0" anchor="ctr" wrap="square" lIns="73152" rIns="73152" tIns="36576" bIns="36576"/>
+          <a:bodyPr rtlCol="0" anchor="ctr" wrap="square" lIns="109728" rIns="109728" tIns="73152" bIns="73152"/>
           <a:lstStyle/>
           <a:p>
             <a:pPr algn="l">
               <a:spcAft>
                 <a:spcPts val="0"/>
               </a:spcAft>
-              <a:defRPr sz="1600" b="0">
+              <a:defRPr sz="1400" b="0">
                 <a:solidFill>
                   <a:srgbClr val="FFFFFF"/>
                 </a:solidFill>
@@ -8041,27 +8573,35 @@
             <a:r>
               <a:t>source /opt/ros/jazzy/setup.bash</a:t>
             </a:r>
-            <a:br/>
+          </a:p>
+          <a:p>
+            <a:pPr algn="l">
+              <a:spcAft>
+                <a:spcPts val="0"/>
+              </a:spcAft>
+              <a:defRPr sz="1400" b="0">
+                <a:solidFill>
+                  <a:srgbClr val="FFFFFF"/>
+                </a:solidFill>
+                <a:latin typeface="DejaVu Sans Mono"/>
+              </a:defRPr>
+            </a:pPr>
             <a:r>
               <a:t>ros2 run demo_nodes_cpp talker</a:t>
             </a:r>
-            <a:br/>
-            <a:r>
-              <a:t># 새 터미널: ros2 run demo_nodes_py listener</a:t>
-            </a:r>
-          </a:p>
-        </p:txBody>
-      </p:sp>
-      <p:sp>
-        <p:nvSpPr>
-          <p:cNvPr id="8" name="TextBox 7"/>
-          <p:cNvSpPr txBox="1"/>
-          <p:nvPr/>
-        </p:nvSpPr>
-        <p:spPr>
-          <a:xfrm>
-            <a:off x="786384" y="5239512"/>
-            <a:ext cx="1261872" cy="237744"/>
+          </a:p>
+        </p:txBody>
+      </p:sp>
+      <p:sp>
+        <p:nvSpPr>
+          <p:cNvPr id="12" name="TextBox 11"/>
+          <p:cNvSpPr txBox="1"/>
+          <p:nvPr/>
+        </p:nvSpPr>
+        <p:spPr>
+          <a:xfrm>
+            <a:off x="749808" y="5166360"/>
+            <a:ext cx="4992624" cy="438912"/>
           </a:xfrm>
           <a:prstGeom prst="rect">
             <a:avLst/>
@@ -8074,11 +8614,163 @@
           </a:bodyPr>
           <a:lstStyle/>
           <a:p>
+            <a:pPr algn="ctr">
+              <a:spcAft>
+                <a:spcPts val="0"/>
+              </a:spcAft>
+              <a:defRPr sz="1300" b="1">
+                <a:solidFill>
+                  <a:srgbClr val="2A8B5A"/>
+                </a:solidFill>
+                <a:latin typeface="Noto Sans CJK KR"/>
+              </a:defRPr>
+            </a:pPr>
+            <a:r>
+              <a:t>터미널 1 역할: 이 node를 실행합니다. 출력이 계속 나오는 동안 Ctrl+C로 종료하지 않습니다.</a:t>
+            </a:r>
+          </a:p>
+        </p:txBody>
+      </p:sp>
+      <p:sp>
+        <p:nvSpPr>
+          <p:cNvPr id="13" name="TextBox 12"/>
+          <p:cNvSpPr txBox="1"/>
+          <p:nvPr/>
+        </p:nvSpPr>
+        <p:spPr>
+          <a:xfrm>
+            <a:off x="6190488" y="3017520"/>
+            <a:ext cx="5138928" cy="256032"/>
+          </a:xfrm>
+          <a:prstGeom prst="rect">
+            <a:avLst/>
+          </a:prstGeom>
+          <a:noFill/>
+        </p:spPr>
+        <p:txBody>
+          <a:bodyPr wrap="square" lIns="73152" rIns="73152" tIns="36576" bIns="36576">
+            <a:spAutoFit/>
+          </a:bodyPr>
+          <a:lstStyle/>
+          <a:p>
+            <a:pPr algn="ctr">
+              <a:spcAft>
+                <a:spcPts val="0"/>
+              </a:spcAft>
+              <a:defRPr sz="1600" b="1">
+                <a:solidFill>
+                  <a:srgbClr val="225B9B"/>
+                </a:solidFill>
+                <a:latin typeface="Noto Sans CJK KR"/>
+              </a:defRPr>
+            </a:pPr>
+            <a:r>
+              <a:t>터미널 2 — 명령만 복사</a:t>
+            </a:r>
+          </a:p>
+        </p:txBody>
+      </p:sp>
+      <p:sp>
+        <p:nvSpPr>
+          <p:cNvPr id="14" name="Rounded Rectangle 13"/>
+          <p:cNvSpPr/>
+          <p:nvPr/>
+        </p:nvSpPr>
+        <p:spPr>
+          <a:xfrm>
+            <a:off x="6190488" y="3328416"/>
+            <a:ext cx="5138928" cy="1700784"/>
+          </a:xfrm>
+          <a:prstGeom prst="roundRect">
+            <a:avLst/>
+          </a:prstGeom>
+          <a:solidFill>
+            <a:srgbClr val="1D232D"/>
+          </a:solidFill>
+          <a:ln>
+            <a:solidFill>
+              <a:srgbClr val="1D232D"/>
+            </a:solidFill>
+          </a:ln>
+        </p:spPr>
+        <p:style>
+          <a:lnRef idx="1">
+            <a:schemeClr val="accent1"/>
+          </a:lnRef>
+          <a:fillRef idx="3">
+            <a:schemeClr val="accent1"/>
+          </a:fillRef>
+          <a:effectRef idx="2">
+            <a:schemeClr val="accent1"/>
+          </a:effectRef>
+          <a:fontRef idx="minor">
+            <a:schemeClr val="lt1"/>
+          </a:fontRef>
+        </p:style>
+        <p:txBody>
+          <a:bodyPr rtlCol="0" anchor="ctr" wrap="square" lIns="109728" rIns="109728" tIns="73152" bIns="73152"/>
+          <a:lstStyle/>
+          <a:p>
             <a:pPr algn="l">
               <a:spcAft>
                 <a:spcPts val="0"/>
               </a:spcAft>
-              <a:defRPr sz="1800" b="1">
+              <a:defRPr sz="1400" b="0">
+                <a:solidFill>
+                  <a:srgbClr val="FFFFFF"/>
+                </a:solidFill>
+                <a:latin typeface="DejaVu Sans Mono"/>
+              </a:defRPr>
+            </a:pPr>
+            <a:r>
+              <a:t>source /opt/ros/jazzy/setup.bash</a:t>
+            </a:r>
+          </a:p>
+          <a:p>
+            <a:pPr algn="l">
+              <a:spcAft>
+                <a:spcPts val="0"/>
+              </a:spcAft>
+              <a:defRPr sz="1400" b="0">
+                <a:solidFill>
+                  <a:srgbClr val="FFFFFF"/>
+                </a:solidFill>
+                <a:latin typeface="DejaVu Sans Mono"/>
+              </a:defRPr>
+            </a:pPr>
+            <a:r>
+              <a:t>ros2 run demo_nodes_py listener</a:t>
+            </a:r>
+          </a:p>
+        </p:txBody>
+      </p:sp>
+      <p:sp>
+        <p:nvSpPr>
+          <p:cNvPr id="15" name="TextBox 14"/>
+          <p:cNvSpPr txBox="1"/>
+          <p:nvPr/>
+        </p:nvSpPr>
+        <p:spPr>
+          <a:xfrm>
+            <a:off x="6263640" y="5166360"/>
+            <a:ext cx="4992624" cy="438912"/>
+          </a:xfrm>
+          <a:prstGeom prst="rect">
+            <a:avLst/>
+          </a:prstGeom>
+          <a:noFill/>
+        </p:spPr>
+        <p:txBody>
+          <a:bodyPr wrap="square" lIns="73152" rIns="73152" tIns="36576" bIns="36576">
+            <a:spAutoFit/>
+          </a:bodyPr>
+          <a:lstStyle/>
+          <a:p>
+            <a:pPr algn="ctr">
+              <a:spcAft>
+                <a:spcPts val="0"/>
+              </a:spcAft>
+              <a:defRPr sz="1300" b="1">
                 <a:solidFill>
                   <a:srgbClr val="2A8B5A"/>
                 </a:solidFill>
@@ -8086,21 +8778,21 @@
               </a:defRPr>
             </a:pPr>
             <a:r>
-              <a:t>확인 기준</a:t>
-            </a:r>
-          </a:p>
-        </p:txBody>
-      </p:sp>
-      <p:sp>
-        <p:nvSpPr>
-          <p:cNvPr id="9" name="TextBox 8"/>
-          <p:cNvSpPr txBox="1"/>
-          <p:nvPr/>
-        </p:nvSpPr>
-        <p:spPr>
-          <a:xfrm>
-            <a:off x="786384" y="5532120"/>
-            <a:ext cx="10469880" cy="420624"/>
+              <a:t>터미널 2 역할: 이 node를 실행합니다. 출력이 계속 나오는 동안 Ctrl+C로 종료하지 않습니다.</a:t>
+            </a:r>
+          </a:p>
+        </p:txBody>
+      </p:sp>
+      <p:sp>
+        <p:nvSpPr>
+          <p:cNvPr id="16" name="TextBox 15"/>
+          <p:cNvSpPr txBox="1"/>
+          <p:nvPr/>
+        </p:nvSpPr>
+        <p:spPr>
+          <a:xfrm>
+            <a:off x="768096" y="5916168"/>
+            <a:ext cx="10561320" cy="292608"/>
           </a:xfrm>
           <a:prstGeom prst="rect">
             <a:avLst/>
@@ -8113,11 +8805,11 @@
           </a:bodyPr>
           <a:lstStyle/>
           <a:p>
-            <a:pPr algn="l">
-              <a:spcAft>
-                <a:spcPts val="0"/>
-              </a:spcAft>
-              <a:defRPr sz="1800" b="0">
+            <a:pPr algn="ctr">
+              <a:spcAft>
+                <a:spcPts val="0"/>
+              </a:spcAft>
+              <a:defRPr sz="1500" b="1">
                 <a:solidFill>
                   <a:srgbClr val="122C4E"/>
                 </a:solidFill>
@@ -8125,7 +8817,7 @@
               </a:defRPr>
             </a:pPr>
             <a:r>
-              <a:t>talker/listener와 node·topic·echo·info 명령으로 연결을 확인한다.</a:t>
+              <a:t>확인: talker/listener와 node·topic·echo·info 명령으로 연결을 확인한다.</a:t>
             </a:r>
           </a:p>
         </p:txBody>
@@ -8637,7 +9329,7 @@
           </a:fontRef>
         </p:style>
         <p:txBody>
-          <a:bodyPr rtlCol="0" anchor="ctr" wrap="square" lIns="73152" rIns="73152" tIns="36576" bIns="36576"/>
+          <a:bodyPr rtlCol="0" anchor="ctr" wrap="square" lIns="109728" rIns="109728" tIns="73152" bIns="73152"/>
           <a:lstStyle/>
           <a:p>
             <a:pPr algn="l">
@@ -8654,11 +9346,35 @@
             <a:r>
               <a:t>ros2 node list</a:t>
             </a:r>
-            <a:br/>
+          </a:p>
+          <a:p>
+            <a:pPr algn="l">
+              <a:spcAft>
+                <a:spcPts val="0"/>
+              </a:spcAft>
+              <a:defRPr sz="1600" b="0">
+                <a:solidFill>
+                  <a:srgbClr val="FFFFFF"/>
+                </a:solidFill>
+                <a:latin typeface="DejaVu Sans Mono"/>
+              </a:defRPr>
+            </a:pPr>
             <a:r>
               <a:t>ros2 topic info /chatter</a:t>
             </a:r>
-            <a:br/>
+          </a:p>
+          <a:p>
+            <a:pPr algn="l">
+              <a:spcAft>
+                <a:spcPts val="0"/>
+              </a:spcAft>
+              <a:defRPr sz="1600" b="0">
+                <a:solidFill>
+                  <a:srgbClr val="FFFFFF"/>
+                </a:solidFill>
+                <a:latin typeface="DejaVu Sans Mono"/>
+              </a:defRPr>
+            </a:pPr>
             <a:r>
               <a:t>ros2 topic echo /chatter --once</a:t>
             </a:r>

</xml_diff>